<commit_message>
Slides: restore the English final deck (the Polish builder had overwritten it)
Co-Authored-By: Claude Sonnet 5.5 <noreply@anthropic.com>
</commit_message>
<xml_diff>
--- a/docs/analysis/chamber-final-2026-10-01/slides/chamber-slides-final.pptx
+++ b/docs/analysis/chamber-final-2026-10-01/slides/chamber-slides-final.pptx
@@ -140,7 +140,7 @@
                 </a:solidFill>
                 <a:latin typeface="Calibri"/>
               </a:rPr>
-              <a:t>Błąd pomieszczenia w pasmach (dB, pasmo w Hz)</a:t>
+              <a:t>Room error per band (dB, band in Hz)</a:t>
             </a:r>
           </a:p>
         </c:rich>
@@ -164,7 +164,7 @@
               <c:strCache>
                 <c:ptCount val="1"/>
                 <c:pt idx="0">
-                  <c:v>Początek dnia 3</c:v>
+                  <c:v>Start of day 3</c:v>
                 </c:pt>
               </c:strCache>
             </c:strRef>
@@ -265,7 +265,7 @@
               <c:strCache>
                 <c:ptCount val="1"/>
                 <c:pt idx="0">
-                  <c:v>Stan końcowy</c:v>
+                  <c:v>Final</c:v>
                 </c:pt>
               </c:strCache>
             </c:strRef>
@@ -920,7 +920,7 @@
           <a:p>
             <a:r>
               <a:rPr lang="en-US" dirty="0"/>
-              <a:t>Slajd tytułowy. Zdjęcie (komora_05_10_26.jpg) pokazuje komorę w konfiguracji końcowej (carpet-reordered): pierścień z mikrofonami ułożony poziomo wokół stanowiska ze śmigłem w środku, statyw z głośnikiem po lewej, włóknina na podłodze i suficie, kliny i obłożone słupki na ścianach. Średnica pierścienia 1,68 m (promień 0,84 m), jedenaście mikrofonów UMIK-2.</a:t>
+              <a:t>Intro slide. The photo (komora_05_10_26.jpg) shows the chamber in the final configuration (carpet-reordered): the microphone ring laid flat around the propeller rig at the hub, the loudspeaker tripod on the left, batting on the floor and ceiling, wedges and lined pillars on the walls. Ring diameter 1.68 m (radius 0.84 m), eleven UMIK-2 microphones.</a:t>
             </a:r>
             <a:endParaRPr lang="en-US" dirty="0"/>
           </a:p>
@@ -1008,7 +1008,7 @@
           <a:p>
             <a:r>
               <a:rPr lang="en-US" dirty="0"/>
-              <a:t>Dane: pomiar bazowy z 31 sierpnia 2026 (łuk ułożony poziomo, oś śmigła pionowo), śmigło przy PWM 2000, poziom całkowity 20–560 Hz na mikrofon, odczytany z fabrycznymi plikami kalibracyjnymi, tak jak był mierzony. Rozrzut skuteczny wokół średniej 2,05 dB, rozstęp 6,7 dB (63,9 do 70,6 dB SPL). Oś promieniowa 30–76 dB jest taka sama jak na wykresach w raporcie, więc ta sama czerwona krzywa może być pokazana obok pomiaru z 30 września na dalszym slajdzie. Na osi 0–80 dB ta sama krzywa wygląda na okrąglejszą.</a:t>
+              <a:t>Data: the 31 Aug 2026 horizontal baseline (arc laid flat, propeller axis vertical), propeller at PWM 2000, total level 20-560 Hz per microphone, read with the factory calibration files as it was measured. Rms spread about the mean 2.05 dB, range 6.7 dB (63.9 to 70.6 dB SPL). The radial axis is 30-76 dB, the same as the report polars, so the same red curve can be shown against the 30 Sep measurement on a later slide. On a 0-80 dB axis the same curve looks rounder.</a:t>
             </a:r>
             <a:endParaRPr lang="en-US" dirty="0"/>
           </a:p>
@@ -1096,7 +1096,7 @@
           <a:p>
             <a:r>
               <a:rPr lang="en-US" dirty="0"/>
-              <a:t>Procedura (calibrator/session.py, sesja 16.09.2026): każdą z jedenastu kapsuł UMIK-2 podłączano po kolei w tym samym punkcie montażu przed głośnikiem i mierzono 97 tonów krokowych od 62 Hz do 16 kHz (około 12 na oktawę), amplituda 0,03, próbkowanie 48 kHz, 0,7 s na ustabilizowanie i 2 s zapisu na ton (6 s poniżej 250 Hz). Kapsułę 810-8904 zmierzono trzy razy w całości (18:21, 18:30, 20:43) jako odniesienie. Różnicę każdej kapsuły względem odniesienia dodano do jej krzywej kalibracyjnej; współczynniki czułości zostały takie jak w plikach fabrycznych. Wzorcem jest średnia czterech kapsuł, których pliki fabryczne zgadzają się z pomiarem (810-8900, 810-8903, 811-1896, 811-2321). Rozrzut 4,01 → 0,02 dB pochodzi z notatek projektu: to sprawdzenie w tej samej sesji, bo poprawki pochodzą z tej sesji, a poziom bezwzględny nie jest zakotwiczony (potrzebny kalibrator 94 dB). Siedem kapsuł ma średnie odchylenie powyżej 0,6 dB w funkcji częstotliwości, od 0,76 do 2,59 dB; najgorsza pojedyncza częstotliwość to 3,48 dB (811-1892), z pliku CORRECTIONS-2026-09-16.csv.</a:t>
+              <a:t>Procedure (calibrator/session.py, 2026-09-16 session): each of the eleven UMIK-2 capsules was plugged in at the same mounting point in front of the loudspeaker and measured over 97 stepped tones, 62 Hz to 16 kHz (about 12 per octave), amplitude 0.03, 48 kHz sampling, 0.7 s settle and 2 s capture per tone (6 s below 250 Hz). Capsule 810-8904 was measured three full times (18:21, 18:30, 20:43) as the reference. The difference of each capsule from the reference was folded into its calibration curve; Sens Factors kept as in the factory files. The datum is the mean of four capsules whose factory files agree with measurement (810-8900, 810-8903, 811-1896, 811-2321). Spread 4.01 to 0.02 dB is from the project notes: a same-session check, since the corrections come from this session, and the absolute level is not anchored (that needs a 94 dB calibrator). Seven capsules have a mean offset beyond 0.6 dB over frequency, between 0.76 and 2.59 dB; the worst single frequency is 3.48 dB (811-1892), from CORRECTIONS-2026-09-16.csv. Seven capsules had a mean offset beyond 0.6 dB (811-1892 -2.6, 811-1897 -1.4, 811-2310 -0.8, 810-8897 +0.8, 810-8901 +0.8, 810-8904 +0.9, 810-8893 +1.3). Absolute level is not anchored: that needs a 94 dB calibrator.</a:t>
             </a:r>
             <a:endParaRPr lang="en-US" dirty="0"/>
           </a:p>
@@ -1184,7 +1184,7 @@
           <a:p>
             <a:r>
               <a:rPr lang="en-US" dirty="0"/>
-              <a:t>Ten sam rysunek co w rozdziale 1 raportu, narysowany większy. Te same dwa pomiary skalibrowano na dwa sposoby: plikami fabrycznymi i poprawkami zmierzonymi 16 września. Rozstęp to zakres średnich poziomów kapsuł: 4,3 do 0,8 dB na początku dnia 3 i 4,1 do 1,0 dB w konfiguracji końcowej. Błąd pomieszczenia poniżej 3 kHz: 2,277 do 1,997 dB oraz 1,736 do 1,387 dB. Zmiana to głównie przesunięcie każdej kapsuły, więc głównie przesuwa całe wiersze.</a:t>
+              <a:t>Same figure as chapter 1 of the report, redrawn larger. The same two captures were calibrated two ways: with the factory files and with the corrections measured on 16 Sep. The span is the range of the capsules mean levels: 4.3 to 0.8 dB at the start of day 3, 4.1 to 1.0 dB in the final configuration. Room error below 3 kHz: 2.277 to 1.997 dB and 1.736 to 1.387 dB. The change is mainly a per-capsule offset, so it mainly moves whole rows.</a:t>
             </a:r>
             <a:endParaRPr lang="en-US" dirty="0"/>
           </a:p>
@@ -1272,7 +1272,7 @@
           <a:p>
             <a:r>
               <a:rPr lang="en-US" dirty="0"/>
-              <a:t>Ta sama para co na stronie 3 raportu (day3-a o 13:17, carpet-reordered o 19:15, oba 25 września), odczytana z poprawionymi plikami mikrofonów. Błąd pomieszczenia to wartość skuteczna odchylenia jedenastu mikrofonów od ich średniej, w paśmie. Poniżej 630 Hz błąd skuteczny spadł z 2,98 do 1,78 dB (1,2 dB, 40 %); między 1 a 3 kHz zmienił się z 0,84 na 0,91 dB. Początek dnia 3: 3,33; 2,57; 1,57; 0,80; 0,87; 1,04 dB; stan końcowy: 1,99; 1,52; 1,47; 0,85; 0,96; 1,17 dB dla pasm 250–400, 400–630, 630–1000, 1000–1600, 1600–3000 i 5000–6400 Hz. Zastrzeżenie z raportu: w ciągu dnia głośnik przesuwano celowo (20 cm bliżej, do płaszczyzny pierścienia, 5 cm do tyłu), po czym wrócił mniej więcej do pozycji wyjściowej, której nie zapisano. Pochylenie mapy zmieniło się z −0,41 na −0,63, a średni poziom wzrósł o 1,16 dB, więc zysk to zabiegi plus niewielka, nieznana różnica położenia źródła, a część może wynikać z głośniejszego dźwięku bezpośredniego. Czysta para z nieruszanym źródłem to 24 września: pusta podłoga 2,054 do dywanu 1,317 dB.</a:t>
+              <a:t>Same pair as page 3 of the report (day3-a at 13:17, carpet-reordered at 19:15, both 25 Sep), read with the corrected microphone files. Room error is the rms deviation of the eleven microphones from their mean, per band. Below 630 Hz the rms room error fell from 2.98 to 1.78 dB (1.2 dB, 40 %); between 1 and 3 kHz it went 0.84 to 0.91 dB. Start of day 3: 3.33, 2.57, 1.57, 0.80, 0.87, 1.04 dB; final: 1.99, 1.52, 1.47, 0.85, 0.96, 1.17 dB for the bands 250-400, 400-630, 630-1000, 1000-1600, 1600-3000 and 5000-6400 Hz. Caveat from the report: the loudspeaker was moved on purpose during the day (20 cm closer, into the ring plane, 5 cm back) and then returned to about its starting mounting point, which was not recorded. The tilt of the map changed from -0.41 to -0.63 and the mean level rose 1.16 dB, so the gain is the treatments plus a small unknown difference in source position, and part of it may be the louder direct sound. The clean pair with an unmoved source is 24 Sep: empty floor 2.054 to carpet 1.317 dB.</a:t>
             </a:r>
             <a:endParaRPr lang="en-US" dirty="0"/>
           </a:p>
@@ -1360,7 +1360,7 @@
           <a:p>
             <a:r>
               <a:rPr lang="en-US" dirty="0"/>
-              <a:t>Ta sama tabela co na stronie 4 raportu. Każde pasmo tercjowe oceniono względem wartości tolerancji dla komory bezechowej z tabeli 1 normy ISO 5305 (także ISO 3745 w ujęciu Cunefare 2003): ±1,5 dB dla 125–630 Hz, ±1,0 dB dla 800–5000 Hz. Liczba to odchylenie średniej pasma najgorszego mikrofonu od średniej łuku, w dB; kolor to ta liczba jako ułamek limitu. „Komórki w limicie” liczy komórki ton × mikrofon mieszczące się w limicie (3 tony × 11 mikrofonów = 33 komórki przy 250 Hz, gdzie siatka zaczyna się od 257 Hz). To analogia: normy używają przemieszczanego mikrofonu i badają zanik z odległością, my mamy jedenaście stałych mikrofonów na jednym promieniu. Pomieszczenie jest wygłuszone, ale nie zakwalifikowane. W tolerancji od 1250 Hz na początku dnia 3 i od 2000 Hz w stanie końcowym, do 2500 Hz. Wiersze z gwiazdką (5000 i 6300 Hz) są częściowe: 4 i 5 tonów powyżej 5 kHz, limit ±1,0 dB przy 5000 Hz i ±1,5 dB przy 6300 Hz (ISO 5305, tabela 1). Oba są ponad limitem w obu stanach (1,24 i 1,23 dB; 1,59 i 1,77 dB). Pasm 3150 i 4000 Hz nie pokazano: brak tonów między 3 a 5 kHz z powodu trybu kołyszącego kuli przy około 4,4 kHz. Zastrzeżenie: położenia głośnika nie zapisano w ciągu dnia.</a:t>
+              <a:t>Same table as page 4 of the report. Each one-third-octave band is judged against the anechoic tolerance values of ISO 5305 Table 1 (also ISO 3745 as printed by Cunefare 2003): +-1.5 dB for 125-630 Hz, +-1.0 dB for 800-5000 Hz. The number is the worst microphone band-mean deviation from the arc mean, in dB; the colour is that number as a share of the limit. Cells in limit counts tone x microphone cells inside the limit (3 tones x 11 microphones = 33 cells at 250 Hz, where the grid starts at 257 Hz). This is an analogue: the standards use a traverse and test decay with distance, we use eleven fixed microphones at one radius. The room is treated and not qualified. Within the tolerance values from 1250 Hz at the start of day 3 and from 2000 Hz in the final state, up to 2500 Hz. The rows marked * (5000 and 6300 Hz) are partial: 4 and 5 tones above 5 kHz, the limit is +-1.0 dB at 5000 Hz and +-1.5 dB at 6300 Hz (ISO 5305 Table 1). Both are over the limit in both states (1.24 and 1.23 dB; 1.59 and 1.77 dB). The 3150 and 4000 Hz bands are not shown: no tones between 3 and 5 kHz because of the rocking mode of the sphere at about 4.4 kHz. Caveat: the loudspeaker position was not documented across the day.</a:t>
             </a:r>
             <a:endParaRPr lang="en-US" dirty="0"/>
           </a:p>
@@ -1448,7 +1448,7 @@
           <a:p>
             <a:r>
               <a:rPr lang="en-US" dirty="0"/>
-              <a:t>Niebieski: pomiar śmigła z 30 września (11,7 V, 7,3 A, ciąg −4 N), odczytany z poprawkami mikrofonów z 16 września. Rozrzut skuteczny wokół średniej 1,45 dB wobec 2,05 dB dla 31 sierpnia; rozstęp 4,0 dB (55,5 do 59,6 dB SPL) wobec 6,7 dB. Niebieski jest o około 11 dB niższy, ale nie można tego przypisać napięciu zasilania (niebieski miał wyższe napięcie): pomiary wykonano różnymi śmigłami, a kierunek ciągu był odwrócony, więc poziomów nie wolno porównywać. Rozstęp 4 dB niebieskiego to trend: głośniej na dole. Uczciwe zastrzeżenie: po zastosowaniu tej samej kalibracji do pomiarów z 1–2 września są one mniej więcej tak samo okrągłe jak z 30 września, więc większość poprawy względem wcześniejszych pomiarów bazowych pochodzi z kalibracji mikrofonów, nie z pomieszczenia.</a:t>
+              <a:t>Blue: 30 Sep propeller measurement (11.7 V, 7.3 A, thrust -4 N), read with the 16 Sep microphone corrections. Rms spread about the mean 1.45 dB against 2.05 dB for 31 Aug; range 4.0 dB (55.5 to 59.6 dB SPL) against 6.7 dB. The blue is about 11 dB lower, but this cannot be attributed to the supply voltage (the blue run had the higher voltage): the two runs used different propellers, and the thrust direction was reversed, so the levels are not comparable. The 4 dB range of the blue is a bottom-louder trend. Honest caveat: with the same calibration applied to the 1-2 Sep runs, those are about as round as 30 Sep, so most of the improvement against the earlier baselines comes from the microphone calibration, not the room.</a:t>
             </a:r>
             <a:endParaRPr lang="en-US" dirty="0"/>
           </a:p>
@@ -1536,7 +1536,7 @@
           <a:p>
             <a:r>
               <a:rPr lang="en-US" dirty="0"/>
-              <a:t>Zestawy pomiarowe z 2 października 2026 w repozytorium danych: 2004__5in3b__unset__v1-naked-horizontal, ...cork__v1-cork-horizontal, ...rubber__v1-rubber, ...felt__v1-felt, ...felt-rubber__v1-felt-rubber. Każdy zapis to krok PWM 2000; poziom na mikrofon to poziom całkowity 100 Hz–10 kHz w dB SPL, odczytany z poprawionymi plikami mikrofonów (wszystkie po 16 września). Wykres jest odbity do 360 stopni. Średnia z jedenastu pozycji: bez materiału 74,2, korek 78,7, guma 80,6, filc 79,5, filc z gumą 78,7 dB. Przy −90 stopni (strumień wylotowy) wszystkie pięć mieści się w 93,7–98,3 dB. Slajd pokazuje poziomy tak, jak zmierzono; punktów pracy (napięcie, ciąg) tu nie porównywano.</a:t>
+              <a:t>Bases of 2 Oct 2026 in the data repo: 2004__5in3b__unset__v1-naked-horizontal, ...cork__v1-cork-horizontal, ...rubber__v1-rubber, ...felt__v1-felt, ...felt-rubber__v1-felt-rubber. Each capture is the PWM 2000 step; level per microphone is the total level 100 Hz to 10 kHz in dB SPL, read with the corrected microphone files (all after 16 Sep). The polar is mirrored to 360 degrees. Mean over the eleven positions: naked 74.2, cork 78.7, rubber 80.6, felt 79.5, felt plus rubber 78.7 dB. At -90 degrees (the outflow) all five are 93.7 to 98.3 dB. The slide shows levels as measured; operating points (voltage, thrust) were not compared here.</a:t>
             </a:r>
             <a:endParaRPr lang="en-US" dirty="0"/>
           </a:p>
@@ -1911,7 +1911,7 @@
       </p:grpSpPr>
       <p:pic>
         <p:nvPicPr>
-          <p:cNvPr id="2" name="Image 0" descr="Komora w obecnej konfiguracji: pierścień z mikrofonami ułożony poziomo wokół stanowiska ze śmigłem, statyw z głośnikiem po lewej, materiał pochłaniający na podłodze, suficie i ścianach">    </p:cNvPr>
+          <p:cNvPr id="2" name="Image 0" descr="The chamber in its current set-up: the microphone ring laid flat around the propeller rig, speaker tripod on the left, absorbing material on floor, ceiling and walls">    </p:cNvPr>
           <p:cNvPicPr>
             <a:picLocks noChangeAspect="1"/>
           </p:cNvPicPr>
@@ -1957,7 +1957,7 @@
               <a:buNone/>
             </a:pPr>
             <a:r>
-              <a:rPr lang="en-US" sz="3400" b="1" dirty="0">
+              <a:rPr lang="en-US" sz="4000" b="1" dirty="0">
                 <a:solidFill>
                   <a:srgbClr val="FFFFFF"/>
                 </a:solidFill>
@@ -1965,9 +1965,9 @@
                 <a:ea typeface="Cambria" pitchFamily="34" charset="-122"/>
                 <a:cs typeface="Cambria" pitchFamily="34" charset="-120"/>
               </a:rPr>
-              <a:t>W pogoni za okrągłym wykresem biegunowym</a:t>
+              <a:t>Chasing a round polar</a:t>
             </a:r>
-            <a:endParaRPr lang="en-US" sz="3400" dirty="0"/>
+            <a:endParaRPr lang="en-US" sz="4000" dirty="0"/>
           </a:p>
         </p:txBody>
       </p:sp>
@@ -2004,7 +2004,7 @@
                 <a:ea typeface="Calibri" pitchFamily="34" charset="-122"/>
                 <a:cs typeface="Calibri" pitchFamily="34" charset="-120"/>
               </a:rPr>
-              <a:t>Nasza komora w obecnej konfiguracji (5 października 2026): jedenaście mikrofonów na pierścieniu wokół źródła, materiał pochłaniający na podłodze, suficie i ścianach.</a:t>
+              <a:t>Our chamber in its current set-up (5 Oct 2026): eleven microphones on a ring around the source, absorbing material on floor, ceiling and walls.</a:t>
             </a:r>
             <a:endParaRPr lang="en-US" sz="1400" dirty="0"/>
           </a:p>
@@ -2044,7 +2044,7 @@
       </p:grpSpPr>
       <p:pic>
         <p:nvPicPr>
-          <p:cNvPr id="2" name="Image 0" descr="Wykres biegunowy pomiaru śmigła z 31 sierpnia, 20–560 Hz, o postrzępionym kształcie">    </p:cNvPr>
+          <p:cNvPr id="2" name="Image 0" descr="Polar plot of the 31 Aug propeller measurement, 20 to 560 Hz, with a jagged outline">    </p:cNvPr>
           <p:cNvPicPr>
             <a:picLocks noChangeAspect="1"/>
           </p:cNvPicPr>
@@ -2099,7 +2099,7 @@
                 <a:ea typeface="Calibri" pitchFamily="34" charset="-122"/>
                 <a:cs typeface="Calibri" pitchFamily="34" charset="-120"/>
               </a:rPr>
-              <a:t>PROBLEM</a:t>
+              <a:t>THE PROBLEM</a:t>
             </a:r>
             <a:endParaRPr lang="en-US" sz="1400" dirty="0"/>
           </a:p>
@@ -2130,7 +2130,7 @@
               <a:buNone/>
             </a:pPr>
             <a:r>
-              <a:rPr lang="en-US" sz="2600" b="1" dirty="0">
+              <a:rPr lang="en-US" sz="3400" b="1" dirty="0">
                 <a:solidFill>
                   <a:srgbClr val="1F2A44"/>
                 </a:solidFill>
@@ -2138,9 +2138,9 @@
                 <a:ea typeface="Cambria" pitchFamily="34" charset="-122"/>
                 <a:cs typeface="Cambria" pitchFamily="34" charset="-120"/>
               </a:rPr>
-              <a:t>Nasz wykres biegunowy jest postrzępiony</a:t>
+              <a:t>Our polar plot is jagged</a:t>
             </a:r>
-            <a:endParaRPr lang="en-US" sz="2600" dirty="0"/>
+            <a:endParaRPr lang="en-US" sz="3400" dirty="0"/>
           </a:p>
         </p:txBody>
       </p:sp>
@@ -2181,7 +2181,7 @@
                 <a:ea typeface="Calibri" pitchFamily="34" charset="-122"/>
                 <a:cs typeface="Calibri" pitchFamily="34" charset="-120"/>
               </a:rPr>
-              <a:t>Mierzyliśmy śmigło, ustawiając łuk z mikrofonami w płaszczyźnie równoległej do tarczy śmigła.</a:t>
+              <a:t>We measured a propeller with the microphone arc in a plane parallel to the propeller disc.</a:t>
             </a:r>
             <a:endParaRPr lang="en-US" sz="1600" dirty="0"/>
           </a:p>
@@ -2202,7 +2202,7 @@
                 <a:ea typeface="Calibri" pitchFamily="34" charset="-122"/>
                 <a:cs typeface="Calibri" pitchFamily="34" charset="-120"/>
               </a:rPr>
-              <a:t>Śmigło jest symetryczne względem swojej osi, więc każdy mikrofon powinien pokazywać mniej więcej to samo.</a:t>
+              <a:t>A propeller is symmetric around its axis, so every microphone should read about the same.</a:t>
             </a:r>
             <a:endParaRPr lang="en-US" sz="1600" dirty="0"/>
           </a:p>
@@ -2223,7 +2223,7 @@
                 <a:ea typeface="Calibri" pitchFamily="34" charset="-122"/>
                 <a:cs typeface="Calibri" pitchFamily="34" charset="-120"/>
               </a:rPr>
-              <a:t>Spodziewaliśmy się gładkiego, prawie okrągłego wykresu. Zobaczyliśmy postrzępiony kształt.</a:t>
+              <a:t>We expected a smooth, nearly round polar. We observed a jagged outline.</a:t>
             </a:r>
             <a:endParaRPr lang="en-US" sz="1600" dirty="0"/>
           </a:p>
@@ -2262,7 +2262,7 @@
                 <a:ea typeface="Cambria" pitchFamily="34" charset="-122"/>
                 <a:cs typeface="Cambria" pitchFamily="34" charset="-120"/>
               </a:rPr>
-              <a:t>6,7 dB</a:t>
+              <a:t>6.7 dB</a:t>
             </a:r>
             <a:endParaRPr lang="en-US" sz="4800" dirty="0"/>
           </a:p>
@@ -2301,7 +2301,7 @@
                 <a:ea typeface="Calibri" pitchFamily="34" charset="-122"/>
                 <a:cs typeface="Calibri" pitchFamily="34" charset="-120"/>
               </a:rPr>
-              <a:t>między najgłośniejszym a najcichszym z jedenastu mikrofonów</a:t>
+              <a:t>between the loudest and quietest of the eleven microphones</a:t>
             </a:r>
             <a:endParaRPr lang="en-US" sz="1400" dirty="0"/>
           </a:p>
@@ -2340,7 +2340,7 @@
                 <a:ea typeface="Calibri" pitchFamily="34" charset="-122"/>
                 <a:cs typeface="Calibri" pitchFamily="34" charset="-120"/>
               </a:rPr>
-              <a:t>31 sierpnia 2026, 20–560 Hz, silnik przy 2000 µs. Oś promieniowa 30–76 dB, taka sama jak w raporcie.</a:t>
+              <a:t>31 Aug 2026, 20–560 Hz, motor at 2000 µs. Radial axis 30–76 dB, the same as in the report.</a:t>
             </a:r>
             <a:endParaRPr lang="en-US" sz="1100" dirty="0"/>
           </a:p>
@@ -2450,7 +2450,7 @@
                 <a:ea typeface="Calibri" pitchFamily="34" charset="-122"/>
                 <a:cs typeface="Calibri" pitchFamily="34" charset="-120"/>
               </a:rPr>
-              <a:t>NAPRAWA</a:t>
+              <a:t>THE FIX</a:t>
             </a:r>
             <a:endParaRPr lang="en-US" sz="1400" dirty="0"/>
           </a:p>
@@ -2489,7 +2489,7 @@
                 <a:ea typeface="Cambria" pitchFamily="34" charset="-122"/>
                 <a:cs typeface="Cambria" pitchFamily="34" charset="-120"/>
               </a:rPr>
-              <a:t>Co zrobiliśmy: każdy mikrofon, jeden głośnik</a:t>
+              <a:t>What we did: every microphone, one loudspeaker</a:t>
             </a:r>
             <a:endParaRPr lang="en-US" sz="3200" dirty="0"/>
           </a:p>
@@ -2497,7 +2497,7 @@
       </p:sp>
       <p:pic>
         <p:nvPicPr>
-          <p:cNvPr id="4" name="Image 0" descr="Nasz głośnik: drukowana kula z głośnikiem o średnicy 8 cm">    </p:cNvPr>
+          <p:cNvPr id="4" name="Image 0" descr="Our loudspeaker: a printed sphere with an 8 cm driver">    </p:cNvPr>
           <p:cNvPicPr>
             <a:picLocks noChangeAspect="1"/>
           </p:cNvPicPr>
@@ -2551,7 +2551,7 @@
                 <a:ea typeface="Calibri" pitchFamily="34" charset="-122"/>
                 <a:cs typeface="Calibri" pitchFamily="34" charset="-120"/>
               </a:rPr>
-              <a:t>Nasz głośnik</a:t>
+              <a:t>Our loudspeaker</a:t>
             </a:r>
             <a:endParaRPr lang="en-US" sz="1600" dirty="0"/>
           </a:p>
@@ -2590,7 +2590,7 @@
                 <a:ea typeface="Calibri" pitchFamily="34" charset="-122"/>
                 <a:cs typeface="Calibri" pitchFamily="34" charset="-120"/>
               </a:rPr>
-              <a:t>tony, 62 Hz–16 kHz</a:t>
+              <a:t>tones, 62 Hz–16 kHz</a:t>
             </a:r>
             <a:endParaRPr lang="en-US" sz="1400" dirty="0"/>
           </a:p>
@@ -2622,7 +2622,7 @@
       </p:sp>
       <p:pic>
         <p:nvPicPr>
-          <p:cNvPr id="8" name="Image 1" descr="Mikrofon pomiarowy UMIK-2, kapsuła po lewej stronie zwrócona do głośnika">    </p:cNvPr>
+          <p:cNvPr id="8" name="Image 1" descr="UMIK-2 measurement microphone, capsule end on the left facing the loudspeaker">    </p:cNvPr>
           <p:cNvPicPr>
             <a:picLocks noChangeAspect="1"/>
           </p:cNvPicPr>
@@ -2677,7 +2677,7 @@
                 <a:ea typeface="Calibri" pitchFamily="34" charset="-122"/>
                 <a:cs typeface="Calibri" pitchFamily="34" charset="-120"/>
               </a:rPr>
-              <a:t>Mikrofon UMIK-2, kapsuła zwrócona do głośnika</a:t>
+              <a:t>UMIK-2 microphone, capsule faces the loudspeaker</a:t>
             </a:r>
             <a:endParaRPr lang="en-US" sz="1600" dirty="0"/>
           </a:p>
@@ -2720,7 +2720,7 @@
                 <a:ea typeface="Calibri" pitchFamily="34" charset="-122"/>
                 <a:cs typeface="Calibri" pitchFamily="34" charset="-120"/>
               </a:rPr>
-              <a:t>97 tonów na mikrofon, 62 Hz–16 kHz, 12 na oktawę (przemiatanie krokowe)</a:t>
+              <a:t>97 tones per microphone, 62 Hz to 16 kHz, 12 per octave (a stepped sweep)</a:t>
             </a:r>
             <a:endParaRPr lang="en-US" sz="1400" dirty="0"/>
           </a:p>
@@ -2741,7 +2741,7 @@
                 <a:ea typeface="Calibri" pitchFamily="34" charset="-122"/>
                 <a:cs typeface="Calibri" pitchFamily="34" charset="-120"/>
               </a:rPr>
-              <a:t>Jeden ton naraz: 0,7 s ustalania, 2 s zapisu (6 s poniżej 250 Hz)</a:t>
+              <a:t>One tone at a time: 0.7 s to settle, then 2 s recorded (6 s below 250 Hz)</a:t>
             </a:r>
             <a:endParaRPr lang="en-US" sz="1400" dirty="0"/>
           </a:p>
@@ -2762,7 +2762,7 @@
                 <a:ea typeface="Calibri" pitchFamily="34" charset="-122"/>
                 <a:cs typeface="Calibri" pitchFamily="34" charset="-120"/>
               </a:rPr>
-              <a:t>Mikrofony wymieniane po kolei: ta sama pozycja, głośnik i poziom</a:t>
+              <a:t>Microphones swapped in turn: same position, same loudspeaker, same level</a:t>
             </a:r>
             <a:endParaRPr lang="en-US" sz="1400" dirty="0"/>
           </a:p>
@@ -2783,7 +2783,7 @@
                 <a:ea typeface="Calibri" pitchFamily="34" charset="-122"/>
                 <a:cs typeface="Calibri" pitchFamily="34" charset="-120"/>
               </a:rPr>
-              <a:t>Jeden mikrofon zmierzony trzy razy jako odniesienie</a:t>
+              <a:t>One microphone measured three times as the reference</a:t>
             </a:r>
             <a:endParaRPr lang="en-US" sz="1400" dirty="0"/>
           </a:p>
@@ -2822,11 +2822,8 @@
                 <a:ea typeface="Cambria" pitchFamily="34" charset="-122"/>
                 <a:cs typeface="Cambria" pitchFamily="34" charset="-120"/>
               </a:rPr>
-              <a:t>4,01</a:t>
+              <a:t>4.01</a:t>
             </a:r>
-            <a:pPr indent="0" marL="0">
-              <a:buNone/>
-            </a:pPr>
             <a:r>
               <a:rPr lang="en-US" sz="4000" b="1" dirty="0">
                 <a:solidFill>
@@ -2838,9 +2835,6 @@
               </a:rPr>
               <a:t> → </a:t>
             </a:r>
-            <a:pPr indent="0" marL="0">
-              <a:buNone/>
-            </a:pPr>
             <a:r>
               <a:rPr lang="en-US" sz="4000" b="1" dirty="0">
                 <a:solidFill>
@@ -2850,7 +2844,7 @@
                 <a:ea typeface="Cambria" pitchFamily="34" charset="-122"/>
                 <a:cs typeface="Cambria" pitchFamily="34" charset="-120"/>
               </a:rPr>
-              <a:t>0,02 dB</a:t>
+              <a:t>0.02 dB</a:t>
             </a:r>
             <a:endParaRPr lang="en-US" sz="4000" dirty="0"/>
           </a:p>
@@ -2889,7 +2883,7 @@
                 <a:ea typeface="Calibri" pitchFamily="34" charset="-122"/>
                 <a:cs typeface="Calibri" pitchFamily="34" charset="-120"/>
               </a:rPr>
-              <a:t>rozrzut między jedenastoma mikrofonami dla tego samego dźwięku</a:t>
+              <a:t>spread across the eleven microphones for the same sound</a:t>
             </a:r>
             <a:endParaRPr lang="en-US" sz="1400" dirty="0"/>
           </a:p>
@@ -2928,7 +2922,7 @@
                 <a:ea typeface="Calibri" pitchFamily="34" charset="-122"/>
                 <a:cs typeface="Calibri" pitchFamily="34" charset="-120"/>
               </a:rPr>
-              <a:t>7 z 11 fabrycznych plików odbiegało średnio o 0,8–2,6 dB</a:t>
+              <a:t>7 of 11 factory files were off by 0.8–2.6 dB on average</a:t>
             </a:r>
             <a:endParaRPr lang="en-US" sz="1400" dirty="0"/>
           </a:p>
@@ -2967,7 +2961,7 @@
                 <a:ea typeface="Calibri" pitchFamily="34" charset="-122"/>
                 <a:cs typeface="Calibri" pitchFamily="34" charset="-120"/>
               </a:rPr>
-              <a:t>Sesja kalibracyjna 16 września 2026, amplituda głośnika 0,03 pełnej skali. Zdjęcie UMIK-2: karta produktu miniDSP.</a:t>
+              <a:t>Calibration session 16 Sep 2026, loudspeaker amplitude 0.03 of full scale. UMIK-2 photo: miniDSP product brief.</a:t>
             </a:r>
             <a:endParaRPr lang="en-US" sz="1100" dirty="0"/>
           </a:p>
@@ -3046,7 +3040,7 @@
       </p:grpSpPr>
       <p:pic>
         <p:nvPicPr>
-          <p:cNvPr id="2" name="Image 0" descr="Mapy każdego mikrofonu w funkcji częstotliwości dla dwóch pomiarów: pliki fabryczne (góra), z poprawkami (środek), efekt poprawki (dół)">    </p:cNvPr>
+          <p:cNvPr id="2" name="Image 0" descr="Maps of each microphone against frequency for two captures: factory files (top), corrected (middle), effect of the correction (bottom)">    </p:cNvPr>
           <p:cNvPicPr>
             <a:picLocks noChangeAspect="1"/>
           </p:cNvPicPr>
@@ -3101,7 +3095,7 @@
                 <a:ea typeface="Calibri" pitchFamily="34" charset="-122"/>
                 <a:cs typeface="Calibri" pitchFamily="34" charset="-120"/>
               </a:rPr>
-              <a:t>WYNIK</a:t>
+              <a:t>THE RESULT</a:t>
             </a:r>
             <a:endParaRPr lang="en-US" sz="1400" dirty="0"/>
           </a:p>
@@ -3132,7 +3126,7 @@
               <a:buNone/>
             </a:pPr>
             <a:r>
-              <a:rPr lang="en-US" sz="2600" b="1" dirty="0">
+              <a:rPr lang="en-US" sz="2800" b="1" dirty="0">
                 <a:solidFill>
                   <a:srgbClr val="1F2A44"/>
                 </a:solidFill>
@@ -3140,9 +3134,9 @@
                 <a:ea typeface="Cambria" pitchFamily="34" charset="-122"/>
                 <a:cs typeface="Cambria" pitchFamily="34" charset="-120"/>
               </a:rPr>
-              <a:t>Poprawka usuwa przesunięcia mikrofonów</a:t>
+              <a:t>The correction removes the microphone offsets</a:t>
             </a:r>
-            <a:endParaRPr lang="en-US" sz="2600" dirty="0"/>
+            <a:endParaRPr lang="en-US" sz="2800" dirty="0"/>
           </a:p>
         </p:txBody>
       </p:sp>
@@ -3167,11 +3161,12 @@
           <a:bodyPr wrap="square" lIns="0" tIns="0" rIns="0" bIns="0" rtlCol="0" anchor="t"/>
           <a:lstStyle/>
           <a:p>
-            <a:pPr indent="0" marL="0">
+            <a:pPr marL="342900" indent="-342900">
               <a:spcAft>
                 <a:spcPts val="800"/>
               </a:spcAft>
-              <a:buNone/>
+              <a:buSzPct val="100000"/>
+              <a:buChar char="•"/>
             </a:pPr>
             <a:r>
               <a:rPr lang="en-US" sz="1400" b="1" dirty="0">
@@ -3182,14 +3177,8 @@
                 <a:ea typeface="Calibri" pitchFamily="34" charset="-122"/>
                 <a:cs typeface="Calibri" pitchFamily="34" charset="-120"/>
               </a:rPr>
-              <a:t>Góra</a:t>
+              <a:t>Top</a:t>
             </a:r>
-            <a:pPr indent="0" marL="0">
-              <a:spcAft>
-                <a:spcPts val="800"/>
-              </a:spcAft>
-              <a:buNone/>
-            </a:pPr>
             <a:r>
               <a:rPr lang="en-US" sz="1400" dirty="0">
                 <a:solidFill>
@@ -3199,14 +3188,8 @@
                 <a:ea typeface="Calibri" pitchFamily="34" charset="-122"/>
                 <a:cs typeface="Calibri" pitchFamily="34" charset="-120"/>
               </a:rPr>
-              <a:t>: pliki fabryczne. </a:t>
+              <a:t>: factory files. </a:t>
             </a:r>
-            <a:pPr indent="0" marL="0">
-              <a:spcAft>
-                <a:spcPts val="800"/>
-              </a:spcAft>
-              <a:buNone/>
-            </a:pPr>
             <a:r>
               <a:rPr lang="en-US" sz="1400" b="1" dirty="0">
                 <a:solidFill>
@@ -3216,14 +3199,8 @@
                 <a:ea typeface="Calibri" pitchFamily="34" charset="-122"/>
                 <a:cs typeface="Calibri" pitchFamily="34" charset="-120"/>
               </a:rPr>
-              <a:t>Środek</a:t>
+              <a:t>Middle</a:t>
             </a:r>
-            <a:pPr indent="0" marL="0">
-              <a:spcAft>
-                <a:spcPts val="800"/>
-              </a:spcAft>
-              <a:buNone/>
-            </a:pPr>
             <a:r>
               <a:rPr lang="en-US" sz="1400" dirty="0">
                 <a:solidFill>
@@ -3233,14 +3210,8 @@
                 <a:ea typeface="Calibri" pitchFamily="34" charset="-122"/>
                 <a:cs typeface="Calibri" pitchFamily="34" charset="-120"/>
               </a:rPr>
-              <a:t>: z poprawkami. </a:t>
+              <a:t>: corrected. </a:t>
             </a:r>
-            <a:pPr indent="0" marL="0">
-              <a:spcAft>
-                <a:spcPts val="800"/>
-              </a:spcAft>
-              <a:buNone/>
-            </a:pPr>
             <a:r>
               <a:rPr lang="en-US" sz="1400" b="1" dirty="0">
                 <a:solidFill>
@@ -3250,14 +3221,8 @@
                 <a:ea typeface="Calibri" pitchFamily="34" charset="-122"/>
                 <a:cs typeface="Calibri" pitchFamily="34" charset="-120"/>
               </a:rPr>
-              <a:t>Dół</a:t>
+              <a:t>Bottom</a:t>
             </a:r>
-            <a:pPr indent="0" marL="0">
-              <a:spcAft>
-                <a:spcPts val="800"/>
-              </a:spcAft>
-              <a:buNone/>
-            </a:pPr>
             <a:r>
               <a:rPr lang="en-US" sz="1400" dirty="0">
                 <a:solidFill>
@@ -3267,7 +3232,7 @@
                 <a:ea typeface="Calibri" pitchFamily="34" charset="-122"/>
                 <a:cs typeface="Calibri" pitchFamily="34" charset="-120"/>
               </a:rPr>
-              <a:t>: co zmieniła poprawka.</a:t>
+              <a:t>: what the correction changed.</a:t>
             </a:r>
             <a:endParaRPr lang="en-US" sz="1400" dirty="0"/>
           </a:p>
@@ -3288,7 +3253,7 @@
                 <a:ea typeface="Calibri" pitchFamily="34" charset="-122"/>
                 <a:cs typeface="Calibri" pitchFamily="34" charset="-120"/>
               </a:rPr>
-              <a:t>Pasek przez wszystkie częstotliwości to jeden mikrofon, który pokazuje za głośno lub za cicho. W środkowym rzędzie go nie ma.</a:t>
+              <a:t>A stripe across all frequencies is one microphone reading too loud or too quiet. The middle row has none.</a:t>
             </a:r>
             <a:endParaRPr lang="en-US" sz="1400" dirty="0"/>
           </a:p>
@@ -3309,7 +3274,7 @@
                 <a:ea typeface="Calibri" pitchFamily="34" charset="-122"/>
                 <a:cs typeface="Calibri" pitchFamily="34" charset="-120"/>
               </a:rPr>
-              <a:t>Obraz pomieszczenia zostaje: przesuwają się całe wiersze, a nie struktura częstotliwościowa.</a:t>
+              <a:t>The room pattern stays: whole rows move, not the frequency structure.</a:t>
             </a:r>
             <a:endParaRPr lang="en-US" sz="1400" dirty="0"/>
           </a:p>
@@ -3348,11 +3313,8 @@
                 <a:ea typeface="Cambria" pitchFamily="34" charset="-122"/>
                 <a:cs typeface="Cambria" pitchFamily="34" charset="-120"/>
               </a:rPr>
-              <a:t>4,3</a:t>
+              <a:t>4.3</a:t>
             </a:r>
-            <a:pPr indent="0" marL="0">
-              <a:buNone/>
-            </a:pPr>
             <a:r>
               <a:rPr lang="en-US" sz="3600" b="1" dirty="0">
                 <a:solidFill>
@@ -3364,9 +3326,6 @@
               </a:rPr>
               <a:t> → </a:t>
             </a:r>
-            <a:pPr indent="0" marL="0">
-              <a:buNone/>
-            </a:pPr>
             <a:r>
               <a:rPr lang="en-US" sz="3600" b="1" dirty="0">
                 <a:solidFill>
@@ -3376,7 +3335,7 @@
                 <a:ea typeface="Cambria" pitchFamily="34" charset="-122"/>
                 <a:cs typeface="Cambria" pitchFamily="34" charset="-120"/>
               </a:rPr>
-              <a:t>0,8 dB</a:t>
+              <a:t>0.8 dB</a:t>
             </a:r>
             <a:endParaRPr lang="en-US" sz="3600" dirty="0"/>
           </a:p>
@@ -3415,7 +3374,7 @@
                 <a:ea typeface="Calibri" pitchFamily="34" charset="-122"/>
                 <a:cs typeface="Calibri" pitchFamily="34" charset="-120"/>
               </a:rPr>
-              <a:t>różnica między najgłośniejszym a najcichszym mikrofonem dla tego samego dźwięku: pliki fabryczne → z poprawkami (początek dnia 3; stan końcowy 4,1 → 1,0 dB)</a:t>
+              <a:t>gap between the loudest and quietest microphone for the same sound: factory files → corrected (start of day 3; final state 4.1 → 1.0 dB)</a:t>
             </a:r>
             <a:endParaRPr lang="en-US" sz="1200" dirty="0"/>
           </a:p>
@@ -3454,7 +3413,7 @@
                 <a:ea typeface="Calibri" pitchFamily="34" charset="-122"/>
                 <a:cs typeface="Calibri" pitchFamily="34" charset="-120"/>
               </a:rPr>
-              <a:t>Dwa pomiary z 25 września 2026: początek dnia 3 (po lewej) i konfiguracja końcowa (po prawej).</a:t>
+              <a:t>Two captures from 25 Sep 2026: the start of day 3 (left) and the final configuration (right).</a:t>
             </a:r>
             <a:endParaRPr lang="en-US" sz="1100" dirty="0"/>
           </a:p>
@@ -3533,7 +3492,7 @@
       </p:grpSpPr>
       <p:pic>
         <p:nvPicPr>
-          <p:cNvPr id="2" name="Image 0" descr="Mapy każdego mikrofonu w funkcji częstotliwości: początek dnia 3, stan końcowy i różnica między nimi">    </p:cNvPr>
+          <p:cNvPr id="2" name="Image 0" descr="Maps of each microphone against frequency: start of day 3, final state, and the change between them">    </p:cNvPr>
           <p:cNvPicPr>
             <a:picLocks noChangeAspect="1"/>
           </p:cNvPicPr>
@@ -3588,7 +3547,7 @@
                 <a:ea typeface="Calibri" pitchFamily="34" charset="-122"/>
                 <a:cs typeface="Calibri" pitchFamily="34" charset="-120"/>
               </a:rPr>
-              <a:t>KOMORA</a:t>
+              <a:t>THE CHAMBER</a:t>
             </a:r>
             <a:endParaRPr lang="en-US" sz="1400" dirty="0"/>
           </a:p>
@@ -3619,7 +3578,7 @@
               <a:buNone/>
             </a:pPr>
             <a:r>
-              <a:rPr lang="en-US" sz="2600" b="1" dirty="0">
+              <a:rPr lang="en-US" sz="2800" b="1" dirty="0">
                 <a:solidFill>
                   <a:srgbClr val="1F2A44"/>
                 </a:solidFill>
@@ -3627,9 +3586,9 @@
                 <a:ea typeface="Cambria" pitchFamily="34" charset="-122"/>
                 <a:cs typeface="Cambria" pitchFamily="34" charset="-120"/>
               </a:rPr>
-              <a:t>Zabiegi wyrównują niskie częstotliwości</a:t>
+              <a:t>The treatments flatten the low end</a:t>
             </a:r>
-            <a:endParaRPr lang="en-US" sz="2600" dirty="0"/>
+            <a:endParaRPr lang="en-US" sz="2800" dirty="0"/>
           </a:p>
         </p:txBody>
       </p:sp>
@@ -3682,11 +3641,8 @@
                 <a:ea typeface="Cambria" pitchFamily="34" charset="-122"/>
                 <a:cs typeface="Cambria" pitchFamily="34" charset="-120"/>
               </a:rPr>
-              <a:t>2,00</a:t>
+              <a:t>2.00</a:t>
             </a:r>
-            <a:pPr indent="0" marL="0">
-              <a:buNone/>
-            </a:pPr>
             <a:r>
               <a:rPr lang="en-US" sz="3400" b="1" dirty="0">
                 <a:solidFill>
@@ -3698,9 +3654,6 @@
               </a:rPr>
               <a:t> → </a:t>
             </a:r>
-            <a:pPr indent="0" marL="0">
-              <a:buNone/>
-            </a:pPr>
             <a:r>
               <a:rPr lang="en-US" sz="3400" b="1" dirty="0">
                 <a:solidFill>
@@ -3710,7 +3663,7 @@
                 <a:ea typeface="Cambria" pitchFamily="34" charset="-122"/>
                 <a:cs typeface="Cambria" pitchFamily="34" charset="-120"/>
               </a:rPr>
-              <a:t>1,39 dB</a:t>
+              <a:t>1.39 dB</a:t>
             </a:r>
             <a:endParaRPr lang="en-US" sz="3400" dirty="0"/>
           </a:p>
@@ -3749,7 +3702,7 @@
                 <a:ea typeface="Calibri" pitchFamily="34" charset="-122"/>
                 <a:cs typeface="Calibri" pitchFamily="34" charset="-120"/>
               </a:rPr>
-              <a:t>błąd pomieszczenia poniżej 3 kHz</a:t>
+              <a:t>room error below 3 kHz</a:t>
             </a:r>
             <a:endParaRPr lang="en-US" sz="1200" dirty="0"/>
           </a:p>
@@ -3788,7 +3741,7 @@
                 <a:ea typeface="Calibri" pitchFamily="34" charset="-122"/>
                 <a:cs typeface="Calibri" pitchFamily="34" charset="-120"/>
               </a:rPr>
-              <a:t>Poprawiliśmy niskie częstotliwości (poniżej 630 Hz) o 1,2 dB: błąd spadł z 3,0 do 1,8 dB, czyli o 40 %. Powyżej 1 kHz tylko nieznaczne zmiany.</a:t>
+              <a:t>We improved the low end (below 630 Hz) by 1.2 dB: the error fell from 3.0 to 1.8 dB, 40 % lower. Above 1 kHz only marginal changes.</a:t>
             </a:r>
             <a:endParaRPr lang="en-US" sz="1400" dirty="0"/>
           </a:p>
@@ -3827,7 +3780,7 @@
                 <a:ea typeface="Calibri" pitchFamily="34" charset="-122"/>
                 <a:cs typeface="Calibri" pitchFamily="34" charset="-120"/>
               </a:rPr>
-              <a:t>25 września 2026. W ciągu dnia głośnik przesuwano i wrócił mniej więcej do punktu wyjścia; położenia nie zapisano. Błąd pomieszczenia: wartość skuteczna różnicy jedenastu mikrofonów od ich średniej.</a:t>
+              <a:t>25 Sep 2026. The loudspeaker was moved during the day and returned to about its starting point; the position was not documented. Room error: rms difference of the eleven microphones from their average.</a:t>
             </a:r>
             <a:endParaRPr lang="en-US" sz="1100" dirty="0"/>
           </a:p>
@@ -3937,7 +3890,7 @@
                 <a:ea typeface="Calibri" pitchFamily="34" charset="-122"/>
                 <a:cs typeface="Calibri" pitchFamily="34" charset="-120"/>
               </a:rPr>
-              <a:t>OCENA</a:t>
+              <a:t>THE EVALUATION</a:t>
             </a:r>
             <a:endParaRPr lang="en-US" sz="1400" dirty="0"/>
           </a:p>
@@ -3976,7 +3929,7 @@
                 <a:ea typeface="Cambria" pitchFamily="34" charset="-122"/>
                 <a:cs typeface="Cambria" pitchFamily="34" charset="-120"/>
               </a:rPr>
-              <a:t>Pasmo po paśmie względem tolerancji ISO</a:t>
+              <a:t>Band by band against the ISO tolerance</a:t>
             </a:r>
             <a:endParaRPr lang="en-US" sz="2600" dirty="0"/>
           </a:p>
@@ -4031,7 +3984,7 @@
                           <a:ea typeface="Calibri" pitchFamily="34" charset="-122"/>
                           <a:cs typeface="Calibri" pitchFamily="34" charset="-120"/>
                         </a:rPr>
-                        <a:t>Pasmo</a:t>
+                        <a:t>Band</a:t>
                       </a:r>
                       <a:endParaRPr lang="en-US" sz="1200" dirty="0">
                         <a:latin typeface="Calibri" charset="0"/>
@@ -4161,7 +4114,7 @@
                           <a:ea typeface="Calibri" pitchFamily="34" charset="-122"/>
                           <a:cs typeface="Calibri" pitchFamily="34" charset="-120"/>
                         </a:rPr>
-                        <a:t>Tony</a:t>
+                        <a:t>Tones</a:t>
                       </a:r>
                       <a:endParaRPr lang="en-US" sz="1200" dirty="0">
                         <a:latin typeface="Calibri" charset="0"/>
@@ -4226,7 +4179,7 @@
                           <a:ea typeface="Calibri" pitchFamily="34" charset="-122"/>
                           <a:cs typeface="Calibri" pitchFamily="34" charset="-120"/>
                         </a:rPr>
-                        <a:t>Początek dnia 3</a:t>
+                        <a:t>Start of day 3</a:t>
                       </a:r>
                       <a:endParaRPr lang="en-US" sz="1200" dirty="0">
                         <a:latin typeface="Calibri" charset="0"/>
@@ -4294,7 +4247,7 @@
                           <a:ea typeface="Calibri" pitchFamily="34" charset="-122"/>
                           <a:cs typeface="Calibri" pitchFamily="34" charset="-120"/>
                         </a:rPr>
-                        <a:t>Stan końcowy</a:t>
+                        <a:t>Final</a:t>
                       </a:r>
                       <a:endParaRPr lang="en-US" sz="1200" dirty="0">
                         <a:latin typeface="Calibri" charset="0"/>
@@ -4494,7 +4447,7 @@
                           <a:ea typeface="Calibri" pitchFamily="34" charset="-122"/>
                           <a:cs typeface="Calibri" pitchFamily="34" charset="-120"/>
                         </a:rPr>
-                        <a:t>w paśmie</a:t>
+                        <a:t>per band</a:t>
                       </a:r>
                       <a:endParaRPr lang="en-US" sz="1200" dirty="0">
                         <a:latin typeface="Calibri" charset="0"/>
@@ -4559,7 +4512,7 @@
                           <a:ea typeface="Calibri" pitchFamily="34" charset="-122"/>
                           <a:cs typeface="Calibri" pitchFamily="34" charset="-120"/>
                         </a:rPr>
-                        <a:t>najgorszy mikr., dB</a:t>
+                        <a:t>worst mic, dB</a:t>
                       </a:r>
                       <a:endParaRPr lang="en-US" sz="1200" dirty="0">
                         <a:latin typeface="Calibri" charset="0"/>
@@ -4624,7 +4577,7 @@
                           <a:ea typeface="Calibri" pitchFamily="34" charset="-122"/>
                           <a:cs typeface="Calibri" pitchFamily="34" charset="-120"/>
                         </a:rPr>
-                        <a:t>komórki w limicie</a:t>
+                        <a:t>cells in limit</a:t>
                       </a:r>
                       <a:endParaRPr lang="en-US" sz="1200" dirty="0">
                         <a:latin typeface="Calibri" charset="0"/>
@@ -4689,7 +4642,7 @@
                           <a:ea typeface="Calibri" pitchFamily="34" charset="-122"/>
                           <a:cs typeface="Calibri" pitchFamily="34" charset="-120"/>
                         </a:rPr>
-                        <a:t>najgorszy mikr., dB</a:t>
+                        <a:t>worst mic, dB</a:t>
                       </a:r>
                       <a:endParaRPr lang="en-US" sz="1200" dirty="0">
                         <a:latin typeface="Calibri" charset="0"/>
@@ -4754,7 +4707,7 @@
                           <a:ea typeface="Calibri" pitchFamily="34" charset="-122"/>
                           <a:cs typeface="Calibri" pitchFamily="34" charset="-120"/>
                         </a:rPr>
-                        <a:t>komórki w limicie</a:t>
+                        <a:t>cells in limit</a:t>
                       </a:r>
                       <a:endParaRPr lang="en-US" sz="1200" dirty="0">
                         <a:latin typeface="Calibri" charset="0"/>
@@ -4886,7 +4839,7 @@
                           <a:ea typeface="Calibri" pitchFamily="34" charset="-122"/>
                           <a:cs typeface="Calibri" pitchFamily="34" charset="-120"/>
                         </a:rPr>
-                        <a:t>1,5</a:t>
+                        <a:t>1.5</a:t>
                       </a:r>
                       <a:endParaRPr lang="en-US" sz="1400" dirty="0">
                         <a:latin typeface="Calibri" charset="0"/>
@@ -5016,7 +4969,7 @@
                           <a:ea typeface="Calibri" pitchFamily="34" charset="-122"/>
                           <a:cs typeface="Calibri" pitchFamily="34" charset="-120"/>
                         </a:rPr>
-                        <a:t>6,81</a:t>
+                        <a:t>6.81</a:t>
                       </a:r>
                       <a:endParaRPr lang="en-US" sz="1400" dirty="0">
                         <a:latin typeface="Calibri" charset="0"/>
@@ -5152,7 +5105,7 @@
                           <a:ea typeface="Calibri" pitchFamily="34" charset="-122"/>
                           <a:cs typeface="Calibri" pitchFamily="34" charset="-120"/>
                         </a:rPr>
-                        <a:t>1,88</a:t>
+                        <a:t>1.88</a:t>
                       </a:r>
                       <a:endParaRPr lang="en-US" sz="1400" dirty="0">
                         <a:latin typeface="Calibri" charset="0"/>
@@ -5355,7 +5308,7 @@
                           <a:ea typeface="Calibri" pitchFamily="34" charset="-122"/>
                           <a:cs typeface="Calibri" pitchFamily="34" charset="-120"/>
                         </a:rPr>
-                        <a:t>1,5</a:t>
+                        <a:t>1.5</a:t>
                       </a:r>
                       <a:endParaRPr lang="en-US" sz="1400" dirty="0">
                         <a:latin typeface="Calibri" charset="0"/>
@@ -5485,7 +5438,7 @@
                           <a:ea typeface="Calibri" pitchFamily="34" charset="-122"/>
                           <a:cs typeface="Calibri" pitchFamily="34" charset="-120"/>
                         </a:rPr>
-                        <a:t>3,46</a:t>
+                        <a:t>3.46</a:t>
                       </a:r>
                       <a:endParaRPr lang="en-US" sz="1400" dirty="0">
                         <a:latin typeface="Calibri" charset="0"/>
@@ -5621,7 +5574,7 @@
                           <a:ea typeface="Calibri" pitchFamily="34" charset="-122"/>
                           <a:cs typeface="Calibri" pitchFamily="34" charset="-120"/>
                         </a:rPr>
-                        <a:t>0,89</a:t>
+                        <a:t>0.89</a:t>
                       </a:r>
                       <a:endParaRPr lang="en-US" sz="1400" dirty="0">
                         <a:latin typeface="Calibri" charset="0"/>
@@ -5824,7 +5777,7 @@
                           <a:ea typeface="Calibri" pitchFamily="34" charset="-122"/>
                           <a:cs typeface="Calibri" pitchFamily="34" charset="-120"/>
                         </a:rPr>
-                        <a:t>1,5</a:t>
+                        <a:t>1.5</a:t>
                       </a:r>
                       <a:endParaRPr lang="en-US" sz="1400" dirty="0">
                         <a:latin typeface="Calibri" charset="0"/>
@@ -5954,7 +5907,7 @@
                           <a:ea typeface="Calibri" pitchFamily="34" charset="-122"/>
                           <a:cs typeface="Calibri" pitchFamily="34" charset="-120"/>
                         </a:rPr>
-                        <a:t>3,46</a:t>
+                        <a:t>3.46</a:t>
                       </a:r>
                       <a:endParaRPr lang="en-US" sz="1400" dirty="0">
                         <a:latin typeface="Calibri" charset="0"/>
@@ -6090,7 +6043,7 @@
                           <a:ea typeface="Calibri" pitchFamily="34" charset="-122"/>
                           <a:cs typeface="Calibri" pitchFamily="34" charset="-120"/>
                         </a:rPr>
-                        <a:t>1,41</a:t>
+                        <a:t>1.41</a:t>
                       </a:r>
                       <a:endParaRPr lang="en-US" sz="1400" dirty="0">
                         <a:latin typeface="Calibri" charset="0"/>
@@ -6293,7 +6246,7 @@
                           <a:ea typeface="Calibri" pitchFamily="34" charset="-122"/>
                           <a:cs typeface="Calibri" pitchFamily="34" charset="-120"/>
                         </a:rPr>
-                        <a:t>1,5</a:t>
+                        <a:t>1.5</a:t>
                       </a:r>
                       <a:endParaRPr lang="en-US" sz="1400" dirty="0">
                         <a:latin typeface="Calibri" charset="0"/>
@@ -6423,7 +6376,7 @@
                           <a:ea typeface="Calibri" pitchFamily="34" charset="-122"/>
                           <a:cs typeface="Calibri" pitchFamily="34" charset="-120"/>
                         </a:rPr>
-                        <a:t>1,93</a:t>
+                        <a:t>1.93</a:t>
                       </a:r>
                       <a:endParaRPr lang="en-US" sz="1400" dirty="0">
                         <a:latin typeface="Calibri" charset="0"/>
@@ -6559,7 +6512,7 @@
                           <a:ea typeface="Calibri" pitchFamily="34" charset="-122"/>
                           <a:cs typeface="Calibri" pitchFamily="34" charset="-120"/>
                         </a:rPr>
-                        <a:t>1,99</a:t>
+                        <a:t>1.99</a:t>
                       </a:r>
                       <a:endParaRPr lang="en-US" sz="1400" dirty="0">
                         <a:latin typeface="Calibri" charset="0"/>
@@ -6762,7 +6715,7 @@
                           <a:ea typeface="Calibri" pitchFamily="34" charset="-122"/>
                           <a:cs typeface="Calibri" pitchFamily="34" charset="-120"/>
                         </a:rPr>
-                        <a:t>1,5</a:t>
+                        <a:t>1.5</a:t>
                       </a:r>
                       <a:endParaRPr lang="en-US" sz="1400" dirty="0">
                         <a:latin typeface="Calibri" charset="0"/>
@@ -6892,7 +6845,7 @@
                           <a:ea typeface="Calibri" pitchFamily="34" charset="-122"/>
                           <a:cs typeface="Calibri" pitchFamily="34" charset="-120"/>
                         </a:rPr>
-                        <a:t>0,93</a:t>
+                        <a:t>0.93</a:t>
                       </a:r>
                       <a:endParaRPr lang="en-US" sz="1400" dirty="0">
                         <a:latin typeface="Calibri" charset="0"/>
@@ -7028,7 +6981,7 @@
                           <a:ea typeface="Calibri" pitchFamily="34" charset="-122"/>
                           <a:cs typeface="Calibri" pitchFamily="34" charset="-120"/>
                         </a:rPr>
-                        <a:t>1,49</a:t>
+                        <a:t>1.49</a:t>
                       </a:r>
                       <a:endParaRPr lang="en-US" sz="1400" dirty="0">
                         <a:latin typeface="Calibri" charset="0"/>
@@ -7231,7 +7184,7 @@
                           <a:ea typeface="Calibri" pitchFamily="34" charset="-122"/>
                           <a:cs typeface="Calibri" pitchFamily="34" charset="-120"/>
                         </a:rPr>
-                        <a:t>1,0</a:t>
+                        <a:t>1.0</a:t>
                       </a:r>
                       <a:endParaRPr lang="en-US" sz="1400" dirty="0">
                         <a:latin typeface="Calibri" charset="0"/>
@@ -7361,7 +7314,7 @@
                           <a:ea typeface="Calibri" pitchFamily="34" charset="-122"/>
                           <a:cs typeface="Calibri" pitchFamily="34" charset="-120"/>
                         </a:rPr>
-                        <a:t>0,87</a:t>
+                        <a:t>0.87</a:t>
                       </a:r>
                       <a:endParaRPr lang="en-US" sz="1400" dirty="0">
                         <a:latin typeface="Calibri" charset="0"/>
@@ -7497,7 +7450,7 @@
                           <a:ea typeface="Calibri" pitchFamily="34" charset="-122"/>
                           <a:cs typeface="Calibri" pitchFamily="34" charset="-120"/>
                         </a:rPr>
-                        <a:t>1,12</a:t>
+                        <a:t>1.12</a:t>
                       </a:r>
                       <a:endParaRPr lang="en-US" sz="1400" dirty="0">
                         <a:latin typeface="Calibri" charset="0"/>
@@ -7700,7 +7653,7 @@
                           <a:ea typeface="Calibri" pitchFamily="34" charset="-122"/>
                           <a:cs typeface="Calibri" pitchFamily="34" charset="-120"/>
                         </a:rPr>
-                        <a:t>1,0</a:t>
+                        <a:t>1.0</a:t>
                       </a:r>
                       <a:endParaRPr lang="en-US" sz="1400" dirty="0">
                         <a:latin typeface="Calibri" charset="0"/>
@@ -7830,7 +7783,7 @@
                           <a:ea typeface="Calibri" pitchFamily="34" charset="-122"/>
                           <a:cs typeface="Calibri" pitchFamily="34" charset="-120"/>
                         </a:rPr>
-                        <a:t>1,08</a:t>
+                        <a:t>1.08</a:t>
                       </a:r>
                       <a:endParaRPr lang="en-US" sz="1400" dirty="0">
                         <a:latin typeface="Calibri" charset="0"/>
@@ -7966,7 +7919,7 @@
                           <a:ea typeface="Calibri" pitchFamily="34" charset="-122"/>
                           <a:cs typeface="Calibri" pitchFamily="34" charset="-120"/>
                         </a:rPr>
-                        <a:t>0,57</a:t>
+                        <a:t>0.57</a:t>
                       </a:r>
                       <a:endParaRPr lang="en-US" sz="1400" dirty="0">
                         <a:latin typeface="Calibri" charset="0"/>
@@ -8169,7 +8122,7 @@
                           <a:ea typeface="Calibri" pitchFamily="34" charset="-122"/>
                           <a:cs typeface="Calibri" pitchFamily="34" charset="-120"/>
                         </a:rPr>
-                        <a:t>1,0</a:t>
+                        <a:t>1.0</a:t>
                       </a:r>
                       <a:endParaRPr lang="en-US" sz="1400" dirty="0">
                         <a:latin typeface="Calibri" charset="0"/>
@@ -8299,7 +8252,7 @@
                           <a:ea typeface="Calibri" pitchFamily="34" charset="-122"/>
                           <a:cs typeface="Calibri" pitchFamily="34" charset="-120"/>
                         </a:rPr>
-                        <a:t>0,54</a:t>
+                        <a:t>0.54</a:t>
                       </a:r>
                       <a:endParaRPr lang="en-US" sz="1400" dirty="0">
                         <a:latin typeface="Calibri" charset="0"/>
@@ -8435,7 +8388,7 @@
                           <a:ea typeface="Calibri" pitchFamily="34" charset="-122"/>
                           <a:cs typeface="Calibri" pitchFamily="34" charset="-120"/>
                         </a:rPr>
-                        <a:t>1,02</a:t>
+                        <a:t>1.02</a:t>
                       </a:r>
                       <a:endParaRPr lang="en-US" sz="1400" dirty="0">
                         <a:latin typeface="Calibri" charset="0"/>
@@ -8638,7 +8591,7 @@
                           <a:ea typeface="Calibri" pitchFamily="34" charset="-122"/>
                           <a:cs typeface="Calibri" pitchFamily="34" charset="-120"/>
                         </a:rPr>
-                        <a:t>1,0</a:t>
+                        <a:t>1.0</a:t>
                       </a:r>
                       <a:endParaRPr lang="en-US" sz="1400" dirty="0">
                         <a:latin typeface="Calibri" charset="0"/>
@@ -8768,7 +8721,7 @@
                           <a:ea typeface="Calibri" pitchFamily="34" charset="-122"/>
                           <a:cs typeface="Calibri" pitchFamily="34" charset="-120"/>
                         </a:rPr>
-                        <a:t>0,69</a:t>
+                        <a:t>0.69</a:t>
                       </a:r>
                       <a:endParaRPr lang="en-US" sz="1400" dirty="0">
                         <a:latin typeface="Calibri" charset="0"/>
@@ -8904,7 +8857,7 @@
                           <a:ea typeface="Calibri" pitchFamily="34" charset="-122"/>
                           <a:cs typeface="Calibri" pitchFamily="34" charset="-120"/>
                         </a:rPr>
-                        <a:t>1,15</a:t>
+                        <a:t>1.15</a:t>
                       </a:r>
                       <a:endParaRPr lang="en-US" sz="1400" dirty="0">
                         <a:latin typeface="Calibri" charset="0"/>
@@ -9107,7 +9060,7 @@
                           <a:ea typeface="Calibri" pitchFamily="34" charset="-122"/>
                           <a:cs typeface="Calibri" pitchFamily="34" charset="-120"/>
                         </a:rPr>
-                        <a:t>1,0</a:t>
+                        <a:t>1.0</a:t>
                       </a:r>
                       <a:endParaRPr lang="en-US" sz="1400" dirty="0">
                         <a:latin typeface="Calibri" charset="0"/>
@@ -9237,7 +9190,7 @@
                           <a:ea typeface="Calibri" pitchFamily="34" charset="-122"/>
                           <a:cs typeface="Calibri" pitchFamily="34" charset="-120"/>
                         </a:rPr>
-                        <a:t>0,66</a:t>
+                        <a:t>0.66</a:t>
                       </a:r>
                       <a:endParaRPr lang="en-US" sz="1400" dirty="0">
                         <a:latin typeface="Calibri" charset="0"/>
@@ -9373,7 +9326,7 @@
                           <a:ea typeface="Calibri" pitchFamily="34" charset="-122"/>
                           <a:cs typeface="Calibri" pitchFamily="34" charset="-120"/>
                         </a:rPr>
-                        <a:t>0,77</a:t>
+                        <a:t>0.77</a:t>
                       </a:r>
                       <a:endParaRPr lang="en-US" sz="1400" dirty="0">
                         <a:latin typeface="Calibri" charset="0"/>
@@ -9576,7 +9529,7 @@
                           <a:ea typeface="Calibri" pitchFamily="34" charset="-122"/>
                           <a:cs typeface="Calibri" pitchFamily="34" charset="-120"/>
                         </a:rPr>
-                        <a:t>1,0</a:t>
+                        <a:t>1.0</a:t>
                       </a:r>
                       <a:endParaRPr lang="en-US" sz="1400" dirty="0">
                         <a:latin typeface="Calibri" charset="0"/>
@@ -9706,7 +9659,7 @@
                           <a:ea typeface="Calibri" pitchFamily="34" charset="-122"/>
                           <a:cs typeface="Calibri" pitchFamily="34" charset="-120"/>
                         </a:rPr>
-                        <a:t>0,82</a:t>
+                        <a:t>0.82</a:t>
                       </a:r>
                       <a:endParaRPr lang="en-US" sz="1400" dirty="0">
                         <a:latin typeface="Calibri" charset="0"/>
@@ -9842,7 +9795,7 @@
                           <a:ea typeface="Calibri" pitchFamily="34" charset="-122"/>
                           <a:cs typeface="Calibri" pitchFamily="34" charset="-120"/>
                         </a:rPr>
-                        <a:t>0,75</a:t>
+                        <a:t>0.75</a:t>
                       </a:r>
                       <a:endParaRPr lang="en-US" sz="1400" dirty="0">
                         <a:latin typeface="Calibri" charset="0"/>
@@ -10045,7 +9998,7 @@
                           <a:ea typeface="Calibri" pitchFamily="34" charset="-122"/>
                           <a:cs typeface="Calibri" pitchFamily="34" charset="-120"/>
                         </a:rPr>
-                        <a:t>1,0</a:t>
+                        <a:t>1.0</a:t>
                       </a:r>
                       <a:endParaRPr lang="en-US" sz="1400" dirty="0">
                         <a:latin typeface="Calibri" charset="0"/>
@@ -10175,7 +10128,7 @@
                           <a:ea typeface="Calibri" pitchFamily="34" charset="-122"/>
                           <a:cs typeface="Calibri" pitchFamily="34" charset="-120"/>
                         </a:rPr>
-                        <a:t>1,24</a:t>
+                        <a:t>1.24</a:t>
                       </a:r>
                       <a:endParaRPr lang="en-US" sz="1400" dirty="0">
                         <a:latin typeface="Calibri" charset="0"/>
@@ -10311,7 +10264,7 @@
                           <a:ea typeface="Calibri" pitchFamily="34" charset="-122"/>
                           <a:cs typeface="Calibri" pitchFamily="34" charset="-120"/>
                         </a:rPr>
-                        <a:t>1,23</a:t>
+                        <a:t>1.23</a:t>
                       </a:r>
                       <a:endParaRPr lang="en-US" sz="1400" dirty="0">
                         <a:latin typeface="Calibri" charset="0"/>
@@ -10514,7 +10467,7 @@
                           <a:ea typeface="Calibri" pitchFamily="34" charset="-122"/>
                           <a:cs typeface="Calibri" pitchFamily="34" charset="-120"/>
                         </a:rPr>
-                        <a:t>1,5</a:t>
+                        <a:t>1.5</a:t>
                       </a:r>
                       <a:endParaRPr lang="en-US" sz="1400" dirty="0">
                         <a:latin typeface="Calibri" charset="0"/>
@@ -10644,7 +10597,7 @@
                           <a:ea typeface="Calibri" pitchFamily="34" charset="-122"/>
                           <a:cs typeface="Calibri" pitchFamily="34" charset="-120"/>
                         </a:rPr>
-                        <a:t>1,59</a:t>
+                        <a:t>1.59</a:t>
                       </a:r>
                       <a:endParaRPr lang="en-US" sz="1400" dirty="0">
                         <a:latin typeface="Calibri" charset="0"/>
@@ -10780,7 +10733,7 @@
                           <a:ea typeface="Calibri" pitchFamily="34" charset="-122"/>
                           <a:cs typeface="Calibri" pitchFamily="34" charset="-120"/>
                         </a:rPr>
-                        <a:t>1,77</a:t>
+                        <a:t>1.77</a:t>
                       </a:r>
                       <a:endParaRPr lang="en-US" sz="1400" dirty="0">
                         <a:latin typeface="Calibri" charset="0"/>
@@ -10937,7 +10890,7 @@
                 <a:ea typeface="Calibri" pitchFamily="34" charset="-122"/>
                 <a:cs typeface="Calibri" pitchFamily="34" charset="-120"/>
               </a:rPr>
-              <a:t>Skala kolorów</a:t>
+              <a:t>Colour key</a:t>
             </a:r>
             <a:endParaRPr lang="en-US" sz="1400" dirty="0"/>
           </a:p>
@@ -11140,7 +11093,7 @@
                 <a:ea typeface="Calibri" pitchFamily="34" charset="-122"/>
                 <a:cs typeface="Calibri" pitchFamily="34" charset="-120"/>
               </a:rPr>
-              <a:t>na limicie</a:t>
+              <a:t>at the limit</a:t>
             </a:r>
             <a:endParaRPr lang="en-US" sz="1200" dirty="0"/>
           </a:p>
@@ -11179,7 +11132,7 @@
                 <a:ea typeface="Calibri" pitchFamily="34" charset="-122"/>
                 <a:cs typeface="Calibri" pitchFamily="34" charset="-120"/>
               </a:rPr>
-              <a:t>≥ 2×</a:t>
+              <a:t>2× or more</a:t>
             </a:r>
             <a:endParaRPr lang="en-US" sz="1200" dirty="0"/>
           </a:p>
@@ -11218,7 +11171,7 @@
                 <a:ea typeface="Calibri" pitchFamily="34" charset="-122"/>
                 <a:cs typeface="Calibri" pitchFamily="34" charset="-120"/>
               </a:rPr>
-              <a:t>Najgorszy mikrofon jako ułamek limitu. Komórki: zielony 100 %, żółty 50 %, czerwony 0 %.</a:t>
+              <a:t>Worst microphone as a share of the limit. Cells: green 100 %, yellow 50 %, red 0 %.</a:t>
             </a:r>
             <a:endParaRPr lang="en-US" sz="1200" dirty="0"/>
           </a:p>
@@ -11260,14 +11213,8 @@
                 <a:ea typeface="Calibri" pitchFamily="34" charset="-122"/>
                 <a:cs typeface="Calibri" pitchFamily="34" charset="-120"/>
               </a:rPr>
-              <a:t>Pasma ponad limitem (z 13): </a:t>
+              <a:t>Bands clearly over (of 13): </a:t>
             </a:r>
-            <a:pPr indent="0" marL="0">
-              <a:spcAft>
-                <a:spcPts val="600"/>
-              </a:spcAft>
-              <a:buNone/>
-            </a:pPr>
             <a:r>
               <a:rPr lang="en-US" sz="1400" b="1" dirty="0">
                 <a:solidFill>
@@ -11297,14 +11244,8 @@
                 <a:ea typeface="Calibri" pitchFamily="34" charset="-122"/>
                 <a:cs typeface="Calibri" pitchFamily="34" charset="-120"/>
               </a:rPr>
-              <a:t>Komórki w limicie (13 pasm): </a:t>
+              <a:t>Cells in limit (13 bands): </a:t>
             </a:r>
-            <a:pPr indent="0" marL="0">
-              <a:spcAft>
-                <a:spcPts val="600"/>
-              </a:spcAft>
-              <a:buNone/>
-            </a:pPr>
             <a:r>
               <a:rPr lang="en-US" sz="1400" b="1" dirty="0">
                 <a:solidFill>
@@ -11353,7 +11294,7 @@
                 <a:ea typeface="Calibri" pitchFamily="34" charset="-122"/>
                 <a:cs typeface="Calibri" pitchFamily="34" charset="-120"/>
               </a:rPr>
-              <a:t>* Pasma częściowe: zmierzono tylko tony powyżej 5 kHz (4 i 5 tonów). Zakres 3–5 kHz pominięto z powodu głośnika: jego membrana ma tryb kołyszący około 4,4 kHz. Wartości ISO służą jako analogia, nie jako kwalifikacja pomieszczenia.</a:t>
+              <a:t>* Partial bands: only the tones above 5 kHz are measured (4 and 5 tones). 3–5 kHz is left out because of the loudspeaker: its cone has a rocking mode near 4.4 kHz. ISO values are an analogue, not a qualification of the room.</a:t>
             </a:r>
             <a:endParaRPr lang="en-US" sz="1200" dirty="0"/>
           </a:p>
@@ -11432,7 +11373,7 @@
       </p:grpSpPr>
       <p:pic>
         <p:nvPicPr>
-          <p:cNvPr id="2" name="Image 0" descr="Wykres biegunowy 20–560 Hz: postrzępiony czerwony kształt z 31 sierpnia i gładszy niebieski z 30 września">    </p:cNvPr>
+          <p:cNvPr id="2" name="Image 0" descr="Polar plot of 20 to 560 Hz: the jagged red 31 Aug outline and the smoother blue 30 Sep outline">    </p:cNvPr>
           <p:cNvPicPr>
             <a:picLocks noChangeAspect="1"/>
           </p:cNvPicPr>
@@ -11487,7 +11428,7 @@
                 <a:ea typeface="Calibri" pitchFamily="34" charset="-122"/>
                 <a:cs typeface="Calibri" pitchFamily="34" charset="-120"/>
               </a:rPr>
-              <a:t>PORÓWNANIE</a:t>
+              <a:t>COMPARISON</a:t>
             </a:r>
             <a:endParaRPr lang="en-US" sz="1400" dirty="0"/>
           </a:p>
@@ -11518,7 +11459,7 @@
               <a:buNone/>
             </a:pPr>
             <a:r>
-              <a:rPr lang="en-US" sz="2600" b="1" dirty="0">
+              <a:rPr lang="en-US" sz="3400" b="1" dirty="0">
                 <a:solidFill>
                   <a:srgbClr val="1F2A44"/>
                 </a:solidFill>
@@ -11526,9 +11467,9 @@
                 <a:ea typeface="Cambria" pitchFamily="34" charset="-122"/>
                 <a:cs typeface="Cambria" pitchFamily="34" charset="-120"/>
               </a:rPr>
-              <a:t>31 sierpnia i 30 września na tych samych osiach</a:t>
+              <a:t>31 Aug and 30 Sep on the same axes</a:t>
             </a:r>
-            <a:endParaRPr lang="en-US" sz="2600" dirty="0"/>
+            <a:endParaRPr lang="en-US" sz="3400" dirty="0"/>
           </a:p>
         </p:txBody>
       </p:sp>
@@ -11569,7 +11510,7 @@
                 <a:ea typeface="Calibri" pitchFamily="34" charset="-122"/>
                 <a:cs typeface="Calibri" pitchFamily="34" charset="-120"/>
               </a:rPr>
-              <a:t>Czerwony: 31 sierpnia, fabryczne pliki mikrofonów. Niebieski: 30 września, pliki z poprawkami. Dwa różne śmigła.</a:t>
+              <a:t>Red: 31 Aug, factory microphone files. Blue: 30 Sep, corrected files. Two different propellers.</a:t>
             </a:r>
             <a:endParaRPr lang="en-US" sz="1600" dirty="0"/>
           </a:p>
@@ -11590,7 +11531,7 @@
                 <a:ea typeface="Calibri" pitchFamily="34" charset="-122"/>
                 <a:cs typeface="Calibri" pitchFamily="34" charset="-120"/>
               </a:rPr>
-              <a:t>Między pomiarami śmigło zamontowano w przeciwną stronę, więc ciąg jest skierowany odwrotnie. Nie spodziewamy się, że to zmieni dźwięk.</a:t>
+              <a:t>The propeller was mounted the other way round between the two, so the thrust points the other way. We do not expect this to change the sound.</a:t>
             </a:r>
             <a:endParaRPr lang="en-US" sz="1600" dirty="0"/>
           </a:p>
@@ -11611,7 +11552,7 @@
                 <a:ea typeface="Calibri" pitchFamily="34" charset="-122"/>
                 <a:cs typeface="Calibri" pitchFamily="34" charset="-120"/>
               </a:rPr>
-              <a:t>Kształt z 30 września jest gładszy.</a:t>
+              <a:t>The 30 Sep outline is smoother.</a:t>
             </a:r>
             <a:endParaRPr lang="en-US" sz="1600" dirty="0"/>
           </a:p>
@@ -11650,11 +11591,8 @@
                 <a:ea typeface="Cambria" pitchFamily="34" charset="-122"/>
                 <a:cs typeface="Cambria" pitchFamily="34" charset="-120"/>
               </a:rPr>
-              <a:t>6,7</a:t>
+              <a:t>6.7</a:t>
             </a:r>
-            <a:pPr indent="0" marL="0">
-              <a:buNone/>
-            </a:pPr>
             <a:r>
               <a:rPr lang="en-US" sz="4800" b="1" dirty="0">
                 <a:solidFill>
@@ -11666,9 +11604,6 @@
               </a:rPr>
               <a:t> → </a:t>
             </a:r>
-            <a:pPr indent="0" marL="0">
-              <a:buNone/>
-            </a:pPr>
             <a:r>
               <a:rPr lang="en-US" sz="4800" b="1" dirty="0">
                 <a:solidFill>
@@ -11678,7 +11613,7 @@
                 <a:ea typeface="Cambria" pitchFamily="34" charset="-122"/>
                 <a:cs typeface="Cambria" pitchFamily="34" charset="-120"/>
               </a:rPr>
-              <a:t>4,0 dB</a:t>
+              <a:t>4.0 dB</a:t>
             </a:r>
             <a:endParaRPr lang="en-US" sz="4800" dirty="0"/>
           </a:p>
@@ -11717,7 +11652,7 @@
                 <a:ea typeface="Calibri" pitchFamily="34" charset="-122"/>
                 <a:cs typeface="Calibri" pitchFamily="34" charset="-120"/>
               </a:rPr>
-              <a:t>między najgłośniejszym a najcichszym mikrofonem</a:t>
+              <a:t>between the loudest and quietest microphone</a:t>
             </a:r>
             <a:endParaRPr lang="en-US" sz="1400" dirty="0"/>
           </a:p>
@@ -11756,7 +11691,7 @@
                 <a:ea typeface="Calibri" pitchFamily="34" charset="-122"/>
                 <a:cs typeface="Calibri" pitchFamily="34" charset="-120"/>
               </a:rPr>
-              <a:t>20–560 Hz, silnik przy 2000 µs. Różne śmigła i warunki pracy, więc poziomów nie wolno porównywać; porównujemy kształty.</a:t>
+              <a:t>20–560 Hz, motor at 2000 µs. Different propellers and run conditions, so the levels are not comparable; compare the shapes.</a:t>
             </a:r>
             <a:endParaRPr lang="en-US" sz="1100" dirty="0"/>
           </a:p>
@@ -11835,7 +11770,7 @@
       </p:grpSpPr>
       <p:pic>
         <p:nvPicPr>
-          <p:cNvPr id="2" name="Image 0" descr="Wykres biegunowy pięciu wariantów materiałowych przy 2000 mikrosekundach: bez materiału, korek, guma, filc i filc z gumą">    </p:cNvPr>
+          <p:cNvPr id="2" name="Image 0" descr="Polar plot of five material set-ups at 2000 microseconds: naked, cork, rubber, felt and felt with rubber">    </p:cNvPr>
           <p:cNvPicPr>
             <a:picLocks noChangeAspect="1"/>
           </p:cNvPicPr>
@@ -11890,7 +11825,7 @@
                 <a:ea typeface="Calibri" pitchFamily="34" charset="-122"/>
                 <a:cs typeface="Calibri" pitchFamily="34" charset="-120"/>
               </a:rPr>
-              <a:t>MATERIAŁY</a:t>
+              <a:t>THE MATERIALS</a:t>
             </a:r>
             <a:endParaRPr lang="en-US" sz="1400" dirty="0"/>
           </a:p>
@@ -11921,7 +11856,7 @@
               <a:buNone/>
             </a:pPr>
             <a:r>
-              <a:rPr lang="en-US" sz="2600" b="1" dirty="0">
+              <a:rPr lang="en-US" sz="3000" b="1" dirty="0">
                 <a:solidFill>
                   <a:srgbClr val="1F2A44"/>
                 </a:solidFill>
@@ -11929,9 +11864,9 @@
                 <a:ea typeface="Cambria" pitchFamily="34" charset="-122"/>
                 <a:cs typeface="Cambria" pitchFamily="34" charset="-120"/>
               </a:rPr>
-              <a:t>Pomiary materiałów przy 2000 µs</a:t>
+              <a:t>Material measurements at 2000 µs</a:t>
             </a:r>
-            <a:endParaRPr lang="en-US" sz="2600" dirty="0"/>
+            <a:endParaRPr lang="en-US" sz="3000" dirty="0"/>
           </a:p>
         </p:txBody>
       </p:sp>
@@ -11968,7 +11903,7 @@
                 <a:ea typeface="Calibri" pitchFamily="34" charset="-122"/>
                 <a:cs typeface="Calibri" pitchFamily="34" charset="-120"/>
               </a:rPr>
-              <a:t>Średni poziom z jedenastu mikrofonów</a:t>
+              <a:t>Mean level over the eleven microphones</a:t>
             </a:r>
             <a:endParaRPr lang="en-US" sz="1200" dirty="0"/>
           </a:p>
@@ -12032,7 +11967,7 @@
                 <a:ea typeface="Calibri" pitchFamily="34" charset="-122"/>
                 <a:cs typeface="Calibri" pitchFamily="34" charset="-120"/>
               </a:rPr>
-              <a:t>Bez materiału</a:t>
+              <a:t>Bare</a:t>
             </a:r>
             <a:endParaRPr lang="en-US" sz="1800" dirty="0"/>
           </a:p>
@@ -12071,7 +12006,7 @@
                 <a:ea typeface="Calibri" pitchFamily="34" charset="-122"/>
                 <a:cs typeface="Calibri" pitchFamily="34" charset="-120"/>
               </a:rPr>
-              <a:t>74,2 dB</a:t>
+              <a:t>74.2 dB</a:t>
             </a:r>
             <a:endParaRPr lang="en-US" sz="1800" dirty="0"/>
           </a:p>
@@ -12135,7 +12070,7 @@
                 <a:ea typeface="Calibri" pitchFamily="34" charset="-122"/>
                 <a:cs typeface="Calibri" pitchFamily="34" charset="-120"/>
               </a:rPr>
-              <a:t>Filc + guma</a:t>
+              <a:t>Felt + rubber</a:t>
             </a:r>
             <a:endParaRPr lang="en-US" sz="1800" dirty="0"/>
           </a:p>
@@ -12174,7 +12109,7 @@
                 <a:ea typeface="Calibri" pitchFamily="34" charset="-122"/>
                 <a:cs typeface="Calibri" pitchFamily="34" charset="-120"/>
               </a:rPr>
-              <a:t>78,7 dB</a:t>
+              <a:t>78.7 dB</a:t>
             </a:r>
             <a:endParaRPr lang="en-US" sz="1800" dirty="0"/>
           </a:p>
@@ -12238,7 +12173,7 @@
                 <a:ea typeface="Calibri" pitchFamily="34" charset="-122"/>
                 <a:cs typeface="Calibri" pitchFamily="34" charset="-120"/>
               </a:rPr>
-              <a:t>Korek</a:t>
+              <a:t>Cork</a:t>
             </a:r>
             <a:endParaRPr lang="en-US" sz="1800" dirty="0"/>
           </a:p>
@@ -12277,7 +12212,7 @@
                 <a:ea typeface="Calibri" pitchFamily="34" charset="-122"/>
                 <a:cs typeface="Calibri" pitchFamily="34" charset="-120"/>
               </a:rPr>
-              <a:t>78,7 dB</a:t>
+              <a:t>78.7 dB</a:t>
             </a:r>
             <a:endParaRPr lang="en-US" sz="1800" dirty="0"/>
           </a:p>
@@ -12341,7 +12276,7 @@
                 <a:ea typeface="Calibri" pitchFamily="34" charset="-122"/>
                 <a:cs typeface="Calibri" pitchFamily="34" charset="-120"/>
               </a:rPr>
-              <a:t>Filc</a:t>
+              <a:t>Felt</a:t>
             </a:r>
             <a:endParaRPr lang="en-US" sz="1800" dirty="0"/>
           </a:p>
@@ -12380,7 +12315,7 @@
                 <a:ea typeface="Calibri" pitchFamily="34" charset="-122"/>
                 <a:cs typeface="Calibri" pitchFamily="34" charset="-120"/>
               </a:rPr>
-              <a:t>79,5 dB</a:t>
+              <a:t>79.5 dB</a:t>
             </a:r>
             <a:endParaRPr lang="en-US" sz="1800" dirty="0"/>
           </a:p>
@@ -12444,7 +12379,7 @@
                 <a:ea typeface="Calibri" pitchFamily="34" charset="-122"/>
                 <a:cs typeface="Calibri" pitchFamily="34" charset="-120"/>
               </a:rPr>
-              <a:t>Guma</a:t>
+              <a:t>Rubber</a:t>
             </a:r>
             <a:endParaRPr lang="en-US" sz="1800" dirty="0"/>
           </a:p>
@@ -12483,7 +12418,7 @@
                 <a:ea typeface="Calibri" pitchFamily="34" charset="-122"/>
                 <a:cs typeface="Calibri" pitchFamily="34" charset="-120"/>
               </a:rPr>
-              <a:t>80,6 dB</a:t>
+              <a:t>80.6 dB</a:t>
             </a:r>
             <a:endParaRPr lang="en-US" sz="1800" dirty="0"/>
           </a:p>
@@ -12522,7 +12457,7 @@
                 <a:ea typeface="Cambria" pitchFamily="34" charset="-122"/>
                 <a:cs typeface="Cambria" pitchFamily="34" charset="-120"/>
               </a:rPr>
-              <a:t>+4,5 do +6,4 dB</a:t>
+              <a:t>+4.5 to +6.4 dB</a:t>
             </a:r>
             <a:endParaRPr lang="en-US" sz="4000" dirty="0"/>
           </a:p>
@@ -12561,7 +12496,7 @@
                 <a:ea typeface="Calibri" pitchFamily="34" charset="-122"/>
                 <a:cs typeface="Calibri" pitchFamily="34" charset="-120"/>
               </a:rPr>
-              <a:t>głośniej niż bez materiału, średnio</a:t>
+              <a:t>louder than bare, on average</a:t>
             </a:r>
             <a:endParaRPr lang="en-US" sz="1400" dirty="0"/>
           </a:p>
@@ -12600,7 +12535,7 @@
                 <a:ea typeface="Calibri" pitchFamily="34" charset="-122"/>
                 <a:cs typeface="Calibri" pitchFamily="34" charset="-120"/>
               </a:rPr>
-              <a:t>Przy −90°, w strumieniu wylotowym (poza wykresem), wszystkie pięć spotyka się przy 94–98 dB.</a:t>
+              <a:t>At −90°, in the outflow (off the plot), all five meet at 94–98 dB.</a:t>
             </a:r>
             <a:endParaRPr lang="en-US" sz="1200" dirty="0"/>
           </a:p>
@@ -12639,7 +12574,7 @@
                 <a:ea typeface="Calibri" pitchFamily="34" charset="-122"/>
                 <a:cs typeface="Calibri" pitchFamily="34" charset="-120"/>
               </a:rPr>
-              <a:t>2 października 2026, śmigło 5-calowe, poziom całkowity 100 Hz–10 kHz, 2000 µs, pliki z poprawkami. Oś 65–90 dB.</a:t>
+              <a:t>2 Oct 2026, 5-inch 3-blade propeller, total level 100 Hz–10 kHz, motor at 2000 µs, corrected microphone files. Radial axis 65–90 dB.</a:t>
             </a:r>
             <a:endParaRPr lang="en-US" sz="1100" dirty="0"/>
           </a:p>

</xml_diff>

<commit_message>
Slides: slide 8 adds the five 7 Oct materials (PU foam, double PU foam, felt+PU foam, Thinsulate 4 and 8 layers); band changed to 500 Hz-24 kHz
Co-Authored-By: Claude Sonnet 5.5 <noreply@anthropic.com>
</commit_message>
<xml_diff>
--- a/docs/analysis/chamber-final-2026-10-01/slides/chamber-slides-final.pptx
+++ b/docs/analysis/chamber-final-2026-10-01/slides/chamber-slides-final.pptx
@@ -1536,7 +1536,7 @@
           <a:p>
             <a:r>
               <a:rPr lang="en-US" dirty="0"/>
-              <a:t>Bases of 2 Oct 2026 in the data repo: 2004__5in3b__unset__v1-naked-horizontal, ...cork__v1-cork-horizontal, ...rubber__v1-rubber, ...felt__v1-felt, ...felt-rubber__v1-felt-rubber. Each capture is the PWM 2000 step; level per microphone is the total level 100 Hz to 10 kHz in dB SPL, read with the corrected microphone files (all after 16 Sep). The polar is mirrored to 360 degrees. Mean over the eleven positions: naked 74.2, cork 78.7, rubber 80.6, felt 79.5, felt plus rubber 78.7 dB. At -90 degrees (the outflow) all five are 93.7 to 98.3 dB. The slide shows levels as measured; operating points (voltage, thrust) were not compared here.</a:t>
+              <a:t>Bases in the data repo. 2 Oct 2026: 2004__5in3b__unset__v1-naked-horizontal (bare), ...cork__v1-cork-horizontal, ...rubber__v1-rubber, ...felt__v1-felt, ...felt-rubber__v1-felt-rubber. 7 Oct 2026 (axii__5in3b__...): inner-felt-outer-open-pore-pu-foam, open-pore-pu-foam, open-pore-pu-foam-double-layer, thinsulate-4-layers, thinsulate-8-layers. Each capture is the PWM 2000 step; level per microphone is the total level 500 Hz to 24 kHz in dB SPL (was 100 Hz to 10 kHz on the earlier version of this slide), read with the corrected microphone files (all after 16 Sep). The polar is mirrored to 360 degrees. Mean over the eleven positions. The bare reference is from 2 Oct, so the 7 Oct materials are compared across days: the differences from bare are indicative, not a controlled comparison. The earlier 100 Hz-10 kHz version had a strong lobe at -90 degrees (94-98 dB); with the band from 500 Hz it is 78-87 dB and fits on the plot. Operating points (voltage, thrust) were not compared here.</a:t>
             </a:r>
             <a:endParaRPr lang="en-US" dirty="0"/>
           </a:p>
@@ -11770,7 +11770,7 @@
       </p:grpSpPr>
       <p:pic>
         <p:nvPicPr>
-          <p:cNvPr id="2" name="Image 0" descr="Polar plot of five material set-ups at 2000 microseconds: naked, cork, rubber, felt and felt with rubber">    </p:cNvPr>
+          <p:cNvPr id="2" name="Image 0" descr="Polar plot of ten material set-ups at 2000 microseconds, total level 500 Hz to 24 kHz: bare, cork, rubber, felt, felt with rubber, felt with PU foam, PU foam, double PU foam, 4 and 8 layers of Thinsulate">    </p:cNvPr>
           <p:cNvPicPr>
             <a:picLocks noChangeAspect="1"/>
           </p:cNvPicPr>
@@ -11800,8 +11800,8 @@
         </p:nvSpPr>
         <p:spPr>
           <a:xfrm>
-            <a:off x="6949440" y="640080"/>
-            <a:ext cx="4754880" cy="320040"/>
+            <a:off x="6583680" y="365760"/>
+            <a:ext cx="5120640" cy="320040"/>
           </a:xfrm>
           <a:prstGeom prst="rect">
             <a:avLst/>
@@ -11839,8 +11839,8 @@
         </p:nvSpPr>
         <p:spPr>
           <a:xfrm>
-            <a:off x="6949440" y="960120"/>
-            <a:ext cx="4754880" cy="1188720"/>
+            <a:off x="6583680" y="658368"/>
+            <a:ext cx="5120640" cy="822960"/>
           </a:xfrm>
           <a:prstGeom prst="rect">
             <a:avLst/>
@@ -11864,7 +11864,7 @@
                 <a:ea typeface="Cambria" pitchFamily="34" charset="-122"/>
                 <a:cs typeface="Cambria" pitchFamily="34" charset="-120"/>
               </a:rPr>
-              <a:t>Material measurements at 2000 µs</a:t>
+              <a:t>Materials at 2000 µs</a:t>
             </a:r>
             <a:endParaRPr lang="en-US" sz="3000" dirty="0"/>
           </a:p>
@@ -11878,8 +11878,8 @@
         </p:nvSpPr>
         <p:spPr>
           <a:xfrm>
-            <a:off x="6949440" y="2331720"/>
-            <a:ext cx="4754880" cy="274320"/>
+            <a:off x="6583680" y="1508760"/>
+            <a:ext cx="5120640" cy="274320"/>
           </a:xfrm>
           <a:prstGeom prst="rect">
             <a:avLst/>
@@ -11903,7 +11903,7 @@
                 <a:ea typeface="Calibri" pitchFamily="34" charset="-122"/>
                 <a:cs typeface="Calibri" pitchFamily="34" charset="-120"/>
               </a:rPr>
-              <a:t>Mean level over the eleven microphones</a:t>
+              <a:t>Mean level, eleven microphones. Solid: 2 Oct. Dashed: 7 Oct.</a:t>
             </a:r>
             <a:endParaRPr lang="en-US" sz="1200" dirty="0"/>
           </a:p>
@@ -11917,8 +11917,8 @@
         </p:nvSpPr>
         <p:spPr>
           <a:xfrm>
-            <a:off x="6949440" y="2715768"/>
-            <a:ext cx="237744" cy="237744"/>
+            <a:off x="6583680" y="1938528"/>
+            <a:ext cx="182880" cy="182880"/>
           </a:xfrm>
           <a:prstGeom prst="ellipse">
             <a:avLst/>
@@ -11942,8 +11942,8 @@
         </p:nvSpPr>
         <p:spPr>
           <a:xfrm>
-            <a:off x="7360920" y="2651760"/>
-            <a:ext cx="2377440" cy="365760"/>
+            <a:off x="6858000" y="1874520"/>
+            <a:ext cx="2743200" cy="310896"/>
           </a:xfrm>
           <a:prstGeom prst="rect">
             <a:avLst/>
@@ -11959,7 +11959,7 @@
               <a:buNone/>
             </a:pPr>
             <a:r>
-              <a:rPr lang="en-US" sz="1800" b="1" dirty="0">
+              <a:rPr lang="en-US" sz="1400" b="1" dirty="0">
                 <a:solidFill>
                   <a:srgbClr val="1F2A44"/>
                 </a:solidFill>
@@ -11969,7 +11969,7 @@
               </a:rPr>
               <a:t>Bare</a:t>
             </a:r>
-            <a:endParaRPr lang="en-US" sz="1800" dirty="0"/>
+            <a:endParaRPr lang="en-US" sz="1400" dirty="0"/>
           </a:p>
         </p:txBody>
       </p:sp>
@@ -11981,537 +11981,8 @@
         </p:nvSpPr>
         <p:spPr>
           <a:xfrm>
-            <a:off x="9692640" y="2651760"/>
-            <a:ext cx="2011680" cy="365760"/>
-          </a:xfrm>
-          <a:prstGeom prst="rect">
-            <a:avLst/>
-          </a:prstGeom>
-          <a:noFill/>
-          <a:ln/>
-        </p:spPr>
-        <p:txBody>
-          <a:bodyPr wrap="square" lIns="0" tIns="0" rIns="0" bIns="0" rtlCol="0" anchor="ctr"/>
-          <a:lstStyle/>
-          <a:p>
-            <a:pPr algn="r" indent="0" marL="0">
-              <a:buNone/>
-            </a:pPr>
-            <a:r>
-              <a:rPr lang="en-US" sz="1800" dirty="0">
-                <a:solidFill>
-                  <a:srgbClr val="1F2A44"/>
-                </a:solidFill>
-                <a:latin typeface="Calibri" pitchFamily="34" charset="0"/>
-                <a:ea typeface="Calibri" pitchFamily="34" charset="-122"/>
-                <a:cs typeface="Calibri" pitchFamily="34" charset="-120"/>
-              </a:rPr>
-              <a:t>74.2 dB</a:t>
-            </a:r>
-            <a:endParaRPr lang="en-US" sz="1800" dirty="0"/>
-          </a:p>
-        </p:txBody>
-      </p:sp>
-      <p:sp>
-        <p:nvSpPr>
-          <p:cNvPr id="9" name="Shape 6"/>
-          <p:cNvSpPr/>
-          <p:nvPr/>
-        </p:nvSpPr>
-        <p:spPr>
-          <a:xfrm>
-            <a:off x="6949440" y="3136392"/>
-            <a:ext cx="237744" cy="237744"/>
-          </a:xfrm>
-          <a:prstGeom prst="ellipse">
-            <a:avLst/>
-          </a:prstGeom>
-          <a:solidFill>
-            <a:srgbClr val="7048E8"/>
-          </a:solidFill>
-          <a:ln w="12700">
-            <a:solidFill>
-              <a:srgbClr val="7048E8"/>
-            </a:solidFill>
-            <a:prstDash val="solid"/>
-          </a:ln>
-        </p:spPr>
-      </p:sp>
-      <p:sp>
-        <p:nvSpPr>
-          <p:cNvPr id="10" name="Text 7"/>
-          <p:cNvSpPr txBox="1"/>
-          <p:nvPr/>
-        </p:nvSpPr>
-        <p:spPr>
-          <a:xfrm>
-            <a:off x="7360920" y="3072384"/>
-            <a:ext cx="2377440" cy="365760"/>
-          </a:xfrm>
-          <a:prstGeom prst="rect">
-            <a:avLst/>
-          </a:prstGeom>
-          <a:noFill/>
-          <a:ln/>
-        </p:spPr>
-        <p:txBody>
-          <a:bodyPr wrap="square" lIns="0" tIns="0" rIns="0" bIns="0" rtlCol="0" anchor="ctr"/>
-          <a:lstStyle/>
-          <a:p>
-            <a:pPr indent="0" marL="0">
-              <a:buNone/>
-            </a:pPr>
-            <a:r>
-              <a:rPr lang="en-US" sz="1800" b="1" dirty="0">
-                <a:solidFill>
-                  <a:srgbClr val="1F2A44"/>
-                </a:solidFill>
-                <a:latin typeface="Calibri" pitchFamily="34" charset="0"/>
-                <a:ea typeface="Calibri" pitchFamily="34" charset="-122"/>
-                <a:cs typeface="Calibri" pitchFamily="34" charset="-120"/>
-              </a:rPr>
-              <a:t>Felt + rubber</a:t>
-            </a:r>
-            <a:endParaRPr lang="en-US" sz="1800" dirty="0"/>
-          </a:p>
-        </p:txBody>
-      </p:sp>
-      <p:sp>
-        <p:nvSpPr>
-          <p:cNvPr id="11" name="Text 8"/>
-          <p:cNvSpPr txBox="1"/>
-          <p:nvPr/>
-        </p:nvSpPr>
-        <p:spPr>
-          <a:xfrm>
-            <a:off x="9692640" y="3072384"/>
-            <a:ext cx="2011680" cy="365760"/>
-          </a:xfrm>
-          <a:prstGeom prst="rect">
-            <a:avLst/>
-          </a:prstGeom>
-          <a:noFill/>
-          <a:ln/>
-        </p:spPr>
-        <p:txBody>
-          <a:bodyPr wrap="square" lIns="0" tIns="0" rIns="0" bIns="0" rtlCol="0" anchor="ctr"/>
-          <a:lstStyle/>
-          <a:p>
-            <a:pPr algn="r" indent="0" marL="0">
-              <a:buNone/>
-            </a:pPr>
-            <a:r>
-              <a:rPr lang="en-US" sz="1800" dirty="0">
-                <a:solidFill>
-                  <a:srgbClr val="1F2A44"/>
-                </a:solidFill>
-                <a:latin typeface="Calibri" pitchFamily="34" charset="0"/>
-                <a:ea typeface="Calibri" pitchFamily="34" charset="-122"/>
-                <a:cs typeface="Calibri" pitchFamily="34" charset="-120"/>
-              </a:rPr>
-              <a:t>78.7 dB</a:t>
-            </a:r>
-            <a:endParaRPr lang="en-US" sz="1800" dirty="0"/>
-          </a:p>
-        </p:txBody>
-      </p:sp>
-      <p:sp>
-        <p:nvSpPr>
-          <p:cNvPr id="12" name="Shape 9"/>
-          <p:cNvSpPr/>
-          <p:nvPr/>
-        </p:nvSpPr>
-        <p:spPr>
-          <a:xfrm>
-            <a:off x="6949440" y="3557016"/>
-            <a:ext cx="237744" cy="237744"/>
-          </a:xfrm>
-          <a:prstGeom prst="ellipse">
-            <a:avLst/>
-          </a:prstGeom>
-          <a:solidFill>
-            <a:srgbClr val="2F9E44"/>
-          </a:solidFill>
-          <a:ln w="12700">
-            <a:solidFill>
-              <a:srgbClr val="2F9E44"/>
-            </a:solidFill>
-            <a:prstDash val="solid"/>
-          </a:ln>
-        </p:spPr>
-      </p:sp>
-      <p:sp>
-        <p:nvSpPr>
-          <p:cNvPr id="13" name="Text 10"/>
-          <p:cNvSpPr txBox="1"/>
-          <p:nvPr/>
-        </p:nvSpPr>
-        <p:spPr>
-          <a:xfrm>
-            <a:off x="7360920" y="3493008"/>
-            <a:ext cx="2377440" cy="365760"/>
-          </a:xfrm>
-          <a:prstGeom prst="rect">
-            <a:avLst/>
-          </a:prstGeom>
-          <a:noFill/>
-          <a:ln/>
-        </p:spPr>
-        <p:txBody>
-          <a:bodyPr wrap="square" lIns="0" tIns="0" rIns="0" bIns="0" rtlCol="0" anchor="ctr"/>
-          <a:lstStyle/>
-          <a:p>
-            <a:pPr indent="0" marL="0">
-              <a:buNone/>
-            </a:pPr>
-            <a:r>
-              <a:rPr lang="en-US" sz="1800" b="1" dirty="0">
-                <a:solidFill>
-                  <a:srgbClr val="1F2A44"/>
-                </a:solidFill>
-                <a:latin typeface="Calibri" pitchFamily="34" charset="0"/>
-                <a:ea typeface="Calibri" pitchFamily="34" charset="-122"/>
-                <a:cs typeface="Calibri" pitchFamily="34" charset="-120"/>
-              </a:rPr>
-              <a:t>Cork</a:t>
-            </a:r>
-            <a:endParaRPr lang="en-US" sz="1800" dirty="0"/>
-          </a:p>
-        </p:txBody>
-      </p:sp>
-      <p:sp>
-        <p:nvSpPr>
-          <p:cNvPr id="14" name="Text 11"/>
-          <p:cNvSpPr txBox="1"/>
-          <p:nvPr/>
-        </p:nvSpPr>
-        <p:spPr>
-          <a:xfrm>
-            <a:off x="9692640" y="3493008"/>
-            <a:ext cx="2011680" cy="365760"/>
-          </a:xfrm>
-          <a:prstGeom prst="rect">
-            <a:avLst/>
-          </a:prstGeom>
-          <a:noFill/>
-          <a:ln/>
-        </p:spPr>
-        <p:txBody>
-          <a:bodyPr wrap="square" lIns="0" tIns="0" rIns="0" bIns="0" rtlCol="0" anchor="ctr"/>
-          <a:lstStyle/>
-          <a:p>
-            <a:pPr algn="r" indent="0" marL="0">
-              <a:buNone/>
-            </a:pPr>
-            <a:r>
-              <a:rPr lang="en-US" sz="1800" dirty="0">
-                <a:solidFill>
-                  <a:srgbClr val="1F2A44"/>
-                </a:solidFill>
-                <a:latin typeface="Calibri" pitchFamily="34" charset="0"/>
-                <a:ea typeface="Calibri" pitchFamily="34" charset="-122"/>
-                <a:cs typeface="Calibri" pitchFamily="34" charset="-120"/>
-              </a:rPr>
-              <a:t>78.7 dB</a:t>
-            </a:r>
-            <a:endParaRPr lang="en-US" sz="1800" dirty="0"/>
-          </a:p>
-        </p:txBody>
-      </p:sp>
-      <p:sp>
-        <p:nvSpPr>
-          <p:cNvPr id="15" name="Shape 12"/>
-          <p:cNvSpPr/>
-          <p:nvPr/>
-        </p:nvSpPr>
-        <p:spPr>
-          <a:xfrm>
-            <a:off x="6949440" y="3977640"/>
-            <a:ext cx="237744" cy="237744"/>
-          </a:xfrm>
-          <a:prstGeom prst="ellipse">
-            <a:avLst/>
-          </a:prstGeom>
-          <a:solidFill>
-            <a:srgbClr val="1098AD"/>
-          </a:solidFill>
-          <a:ln w="12700">
-            <a:solidFill>
-              <a:srgbClr val="1098AD"/>
-            </a:solidFill>
-            <a:prstDash val="solid"/>
-          </a:ln>
-        </p:spPr>
-      </p:sp>
-      <p:sp>
-        <p:nvSpPr>
-          <p:cNvPr id="16" name="Text 13"/>
-          <p:cNvSpPr txBox="1"/>
-          <p:nvPr/>
-        </p:nvSpPr>
-        <p:spPr>
-          <a:xfrm>
-            <a:off x="7360920" y="3913632"/>
-            <a:ext cx="2377440" cy="365760"/>
-          </a:xfrm>
-          <a:prstGeom prst="rect">
-            <a:avLst/>
-          </a:prstGeom>
-          <a:noFill/>
-          <a:ln/>
-        </p:spPr>
-        <p:txBody>
-          <a:bodyPr wrap="square" lIns="0" tIns="0" rIns="0" bIns="0" rtlCol="0" anchor="ctr"/>
-          <a:lstStyle/>
-          <a:p>
-            <a:pPr indent="0" marL="0">
-              <a:buNone/>
-            </a:pPr>
-            <a:r>
-              <a:rPr lang="en-US" sz="1800" b="1" dirty="0">
-                <a:solidFill>
-                  <a:srgbClr val="1F2A44"/>
-                </a:solidFill>
-                <a:latin typeface="Calibri" pitchFamily="34" charset="0"/>
-                <a:ea typeface="Calibri" pitchFamily="34" charset="-122"/>
-                <a:cs typeface="Calibri" pitchFamily="34" charset="-120"/>
-              </a:rPr>
-              <a:t>Felt</a:t>
-            </a:r>
-            <a:endParaRPr lang="en-US" sz="1800" dirty="0"/>
-          </a:p>
-        </p:txBody>
-      </p:sp>
-      <p:sp>
-        <p:nvSpPr>
-          <p:cNvPr id="17" name="Text 14"/>
-          <p:cNvSpPr txBox="1"/>
-          <p:nvPr/>
-        </p:nvSpPr>
-        <p:spPr>
-          <a:xfrm>
-            <a:off x="9692640" y="3913632"/>
-            <a:ext cx="2011680" cy="365760"/>
-          </a:xfrm>
-          <a:prstGeom prst="rect">
-            <a:avLst/>
-          </a:prstGeom>
-          <a:noFill/>
-          <a:ln/>
-        </p:spPr>
-        <p:txBody>
-          <a:bodyPr wrap="square" lIns="0" tIns="0" rIns="0" bIns="0" rtlCol="0" anchor="ctr"/>
-          <a:lstStyle/>
-          <a:p>
-            <a:pPr algn="r" indent="0" marL="0">
-              <a:buNone/>
-            </a:pPr>
-            <a:r>
-              <a:rPr lang="en-US" sz="1800" dirty="0">
-                <a:solidFill>
-                  <a:srgbClr val="1F2A44"/>
-                </a:solidFill>
-                <a:latin typeface="Calibri" pitchFamily="34" charset="0"/>
-                <a:ea typeface="Calibri" pitchFamily="34" charset="-122"/>
-                <a:cs typeface="Calibri" pitchFamily="34" charset="-120"/>
-              </a:rPr>
-              <a:t>79.5 dB</a:t>
-            </a:r>
-            <a:endParaRPr lang="en-US" sz="1800" dirty="0"/>
-          </a:p>
-        </p:txBody>
-      </p:sp>
-      <p:sp>
-        <p:nvSpPr>
-          <p:cNvPr id="18" name="Shape 15"/>
-          <p:cNvSpPr/>
-          <p:nvPr/>
-        </p:nvSpPr>
-        <p:spPr>
-          <a:xfrm>
-            <a:off x="6949440" y="4398264"/>
-            <a:ext cx="237744" cy="237744"/>
-          </a:xfrm>
-          <a:prstGeom prst="ellipse">
-            <a:avLst/>
-          </a:prstGeom>
-          <a:solidFill>
-            <a:srgbClr val="F08C00"/>
-          </a:solidFill>
-          <a:ln w="12700">
-            <a:solidFill>
-              <a:srgbClr val="F08C00"/>
-            </a:solidFill>
-            <a:prstDash val="solid"/>
-          </a:ln>
-        </p:spPr>
-      </p:sp>
-      <p:sp>
-        <p:nvSpPr>
-          <p:cNvPr id="19" name="Text 16"/>
-          <p:cNvSpPr txBox="1"/>
-          <p:nvPr/>
-        </p:nvSpPr>
-        <p:spPr>
-          <a:xfrm>
-            <a:off x="7360920" y="4334256"/>
-            <a:ext cx="2377440" cy="365760"/>
-          </a:xfrm>
-          <a:prstGeom prst="rect">
-            <a:avLst/>
-          </a:prstGeom>
-          <a:noFill/>
-          <a:ln/>
-        </p:spPr>
-        <p:txBody>
-          <a:bodyPr wrap="square" lIns="0" tIns="0" rIns="0" bIns="0" rtlCol="0" anchor="ctr"/>
-          <a:lstStyle/>
-          <a:p>
-            <a:pPr indent="0" marL="0">
-              <a:buNone/>
-            </a:pPr>
-            <a:r>
-              <a:rPr lang="en-US" sz="1800" b="1" dirty="0">
-                <a:solidFill>
-                  <a:srgbClr val="1F2A44"/>
-                </a:solidFill>
-                <a:latin typeface="Calibri" pitchFamily="34" charset="0"/>
-                <a:ea typeface="Calibri" pitchFamily="34" charset="-122"/>
-                <a:cs typeface="Calibri" pitchFamily="34" charset="-120"/>
-              </a:rPr>
-              <a:t>Rubber</a:t>
-            </a:r>
-            <a:endParaRPr lang="en-US" sz="1800" dirty="0"/>
-          </a:p>
-        </p:txBody>
-      </p:sp>
-      <p:sp>
-        <p:nvSpPr>
-          <p:cNvPr id="20" name="Text 17"/>
-          <p:cNvSpPr txBox="1"/>
-          <p:nvPr/>
-        </p:nvSpPr>
-        <p:spPr>
-          <a:xfrm>
-            <a:off x="9692640" y="4334256"/>
-            <a:ext cx="2011680" cy="365760"/>
-          </a:xfrm>
-          <a:prstGeom prst="rect">
-            <a:avLst/>
-          </a:prstGeom>
-          <a:noFill/>
-          <a:ln/>
-        </p:spPr>
-        <p:txBody>
-          <a:bodyPr wrap="square" lIns="0" tIns="0" rIns="0" bIns="0" rtlCol="0" anchor="ctr"/>
-          <a:lstStyle/>
-          <a:p>
-            <a:pPr algn="r" indent="0" marL="0">
-              <a:buNone/>
-            </a:pPr>
-            <a:r>
-              <a:rPr lang="en-US" sz="1800" dirty="0">
-                <a:solidFill>
-                  <a:srgbClr val="1F2A44"/>
-                </a:solidFill>
-                <a:latin typeface="Calibri" pitchFamily="34" charset="0"/>
-                <a:ea typeface="Calibri" pitchFamily="34" charset="-122"/>
-                <a:cs typeface="Calibri" pitchFamily="34" charset="-120"/>
-              </a:rPr>
-              <a:t>80.6 dB</a:t>
-            </a:r>
-            <a:endParaRPr lang="en-US" sz="1800" dirty="0"/>
-          </a:p>
-        </p:txBody>
-      </p:sp>
-      <p:sp>
-        <p:nvSpPr>
-          <p:cNvPr id="21" name="Text 18"/>
-          <p:cNvSpPr txBox="1"/>
-          <p:nvPr/>
-        </p:nvSpPr>
-        <p:spPr>
-          <a:xfrm>
-            <a:off x="6949440" y="4846320"/>
-            <a:ext cx="4754880" cy="731520"/>
-          </a:xfrm>
-          <a:prstGeom prst="rect">
-            <a:avLst/>
-          </a:prstGeom>
-          <a:noFill/>
-          <a:ln/>
-        </p:spPr>
-        <p:txBody>
-          <a:bodyPr wrap="square" lIns="0" tIns="0" rIns="0" bIns="0" rtlCol="0" anchor="ctr"/>
-          <a:lstStyle/>
-          <a:p>
-            <a:pPr indent="0" marL="0">
-              <a:buNone/>
-            </a:pPr>
-            <a:r>
-              <a:rPr lang="en-US" sz="4000" b="1" dirty="0">
-                <a:solidFill>
-                  <a:srgbClr val="D6336C"/>
-                </a:solidFill>
-                <a:latin typeface="Cambria" pitchFamily="34" charset="0"/>
-                <a:ea typeface="Cambria" pitchFamily="34" charset="-122"/>
-                <a:cs typeface="Cambria" pitchFamily="34" charset="-120"/>
-              </a:rPr>
-              <a:t>+4.5 to +6.4 dB</a:t>
-            </a:r>
-            <a:endParaRPr lang="en-US" sz="4000" dirty="0"/>
-          </a:p>
-        </p:txBody>
-      </p:sp>
-      <p:sp>
-        <p:nvSpPr>
-          <p:cNvPr id="22" name="Text 19"/>
-          <p:cNvSpPr txBox="1"/>
-          <p:nvPr/>
-        </p:nvSpPr>
-        <p:spPr>
-          <a:xfrm>
-            <a:off x="6949440" y="5559552"/>
-            <a:ext cx="4754880" cy="320040"/>
-          </a:xfrm>
-          <a:prstGeom prst="rect">
-            <a:avLst/>
-          </a:prstGeom>
-          <a:noFill/>
-          <a:ln/>
-        </p:spPr>
-        <p:txBody>
-          <a:bodyPr wrap="square" lIns="0" tIns="0" rIns="0" bIns="0" rtlCol="0" anchor="ctr"/>
-          <a:lstStyle/>
-          <a:p>
-            <a:pPr indent="0" marL="0">
-              <a:buNone/>
-            </a:pPr>
-            <a:r>
-              <a:rPr lang="en-US" sz="1400" dirty="0">
-                <a:solidFill>
-                  <a:srgbClr val="1F2A44"/>
-                </a:solidFill>
-                <a:latin typeface="Calibri" pitchFamily="34" charset="0"/>
-                <a:ea typeface="Calibri" pitchFamily="34" charset="-122"/>
-                <a:cs typeface="Calibri" pitchFamily="34" charset="-120"/>
-              </a:rPr>
-              <a:t>louder than bare, on average</a:t>
-            </a:r>
-            <a:endParaRPr lang="en-US" sz="1400" dirty="0"/>
-          </a:p>
-        </p:txBody>
-      </p:sp>
-      <p:sp>
-        <p:nvSpPr>
-          <p:cNvPr id="23" name="Text 20"/>
-          <p:cNvSpPr txBox="1"/>
-          <p:nvPr/>
-        </p:nvSpPr>
-        <p:spPr>
-          <a:xfrm>
-            <a:off x="6949440" y="5897880"/>
-            <a:ext cx="4754880" cy="274320"/>
+            <a:off x="9646920" y="1874520"/>
+            <a:ext cx="640080" cy="310896"/>
           </a:xfrm>
           <a:prstGeom prst="rect">
             <a:avLst/>
@@ -12535,7 +12006,7 @@
                 <a:ea typeface="Calibri" pitchFamily="34" charset="-122"/>
                 <a:cs typeface="Calibri" pitchFamily="34" charset="-120"/>
               </a:rPr>
-              <a:t>At −90°, in the outflow (off the plot), all five meet at 94–98 dB.</a:t>
+              <a:t>2 Oct</a:t>
             </a:r>
             <a:endParaRPr lang="en-US" sz="1200" dirty="0"/>
           </a:p>
@@ -12543,7 +12014,1402 @@
       </p:sp>
       <p:sp>
         <p:nvSpPr>
+          <p:cNvPr id="9" name="Text 6"/>
+          <p:cNvSpPr txBox="1"/>
+          <p:nvPr/>
+        </p:nvSpPr>
+        <p:spPr>
+          <a:xfrm>
+            <a:off x="10241280" y="1874520"/>
+            <a:ext cx="1463040" cy="310896"/>
+          </a:xfrm>
+          <a:prstGeom prst="rect">
+            <a:avLst/>
+          </a:prstGeom>
+          <a:noFill/>
+          <a:ln/>
+        </p:spPr>
+        <p:txBody>
+          <a:bodyPr wrap="square" lIns="0" tIns="0" rIns="0" bIns="0" rtlCol="0" anchor="ctr"/>
+          <a:lstStyle/>
+          <a:p>
+            <a:pPr algn="r" indent="0" marL="0">
+              <a:buNone/>
+            </a:pPr>
+            <a:r>
+              <a:rPr lang="en-US" sz="1400" dirty="0">
+                <a:solidFill>
+                  <a:srgbClr val="1F2A44"/>
+                </a:solidFill>
+                <a:latin typeface="Calibri" pitchFamily="34" charset="0"/>
+                <a:ea typeface="Calibri" pitchFamily="34" charset="-122"/>
+                <a:cs typeface="Calibri" pitchFamily="34" charset="-120"/>
+              </a:rPr>
+              <a:t>74.2 dB</a:t>
+            </a:r>
+            <a:endParaRPr lang="en-US" sz="1400" dirty="0"/>
+          </a:p>
+        </p:txBody>
+      </p:sp>
+      <p:sp>
+        <p:nvSpPr>
+          <p:cNvPr id="10" name="Shape 7"/>
+          <p:cNvSpPr/>
+          <p:nvPr/>
+        </p:nvSpPr>
+        <p:spPr>
+          <a:xfrm>
+            <a:off x="6583680" y="2276856"/>
+            <a:ext cx="182880" cy="182880"/>
+          </a:xfrm>
+          <a:prstGeom prst="ellipse">
+            <a:avLst/>
+          </a:prstGeom>
+          <a:solidFill>
+            <a:srgbClr val="862E9C"/>
+          </a:solidFill>
+          <a:ln w="12700">
+            <a:solidFill>
+              <a:srgbClr val="862E9C"/>
+            </a:solidFill>
+            <a:prstDash val="solid"/>
+          </a:ln>
+        </p:spPr>
+      </p:sp>
+      <p:sp>
+        <p:nvSpPr>
+          <p:cNvPr id="11" name="Text 8"/>
+          <p:cNvSpPr txBox="1"/>
+          <p:nvPr/>
+        </p:nvSpPr>
+        <p:spPr>
+          <a:xfrm>
+            <a:off x="6858000" y="2212848"/>
+            <a:ext cx="2743200" cy="310896"/>
+          </a:xfrm>
+          <a:prstGeom prst="rect">
+            <a:avLst/>
+          </a:prstGeom>
+          <a:noFill/>
+          <a:ln/>
+        </p:spPr>
+        <p:txBody>
+          <a:bodyPr wrap="square" lIns="0" tIns="0" rIns="0" bIns="0" rtlCol="0" anchor="ctr"/>
+          <a:lstStyle/>
+          <a:p>
+            <a:pPr indent="0" marL="0">
+              <a:buNone/>
+            </a:pPr>
+            <a:r>
+              <a:rPr lang="en-US" sz="1400" b="1" dirty="0">
+                <a:solidFill>
+                  <a:srgbClr val="1F2A44"/>
+                </a:solidFill>
+                <a:latin typeface="Calibri" pitchFamily="34" charset="0"/>
+                <a:ea typeface="Calibri" pitchFamily="34" charset="-122"/>
+                <a:cs typeface="Calibri" pitchFamily="34" charset="-120"/>
+              </a:rPr>
+              <a:t>PU foam</a:t>
+            </a:r>
+            <a:endParaRPr lang="en-US" sz="1400" dirty="0"/>
+          </a:p>
+        </p:txBody>
+      </p:sp>
+      <p:sp>
+        <p:nvSpPr>
+          <p:cNvPr id="12" name="Text 9"/>
+          <p:cNvSpPr txBox="1"/>
+          <p:nvPr/>
+        </p:nvSpPr>
+        <p:spPr>
+          <a:xfrm>
+            <a:off x="9646920" y="2212848"/>
+            <a:ext cx="640080" cy="310896"/>
+          </a:xfrm>
+          <a:prstGeom prst="rect">
+            <a:avLst/>
+          </a:prstGeom>
+          <a:noFill/>
+          <a:ln/>
+        </p:spPr>
+        <p:txBody>
+          <a:bodyPr wrap="square" lIns="0" tIns="0" rIns="0" bIns="0" rtlCol="0" anchor="ctr"/>
+          <a:lstStyle/>
+          <a:p>
+            <a:pPr indent="0" marL="0">
+              <a:buNone/>
+            </a:pPr>
+            <a:r>
+              <a:rPr lang="en-US" sz="1200" dirty="0">
+                <a:solidFill>
+                  <a:srgbClr val="5B6578"/>
+                </a:solidFill>
+                <a:latin typeface="Calibri" pitchFamily="34" charset="0"/>
+                <a:ea typeface="Calibri" pitchFamily="34" charset="-122"/>
+                <a:cs typeface="Calibri" pitchFamily="34" charset="-120"/>
+              </a:rPr>
+              <a:t>7 Oct</a:t>
+            </a:r>
+            <a:endParaRPr lang="en-US" sz="1200" dirty="0"/>
+          </a:p>
+        </p:txBody>
+      </p:sp>
+      <p:sp>
+        <p:nvSpPr>
+          <p:cNvPr id="13" name="Text 10"/>
+          <p:cNvSpPr txBox="1"/>
+          <p:nvPr/>
+        </p:nvSpPr>
+        <p:spPr>
+          <a:xfrm>
+            <a:off x="10241280" y="2212848"/>
+            <a:ext cx="1463040" cy="310896"/>
+          </a:xfrm>
+          <a:prstGeom prst="rect">
+            <a:avLst/>
+          </a:prstGeom>
+          <a:noFill/>
+          <a:ln/>
+        </p:spPr>
+        <p:txBody>
+          <a:bodyPr wrap="square" lIns="0" tIns="0" rIns="0" bIns="0" rtlCol="0" anchor="ctr"/>
+          <a:lstStyle/>
+          <a:p>
+            <a:pPr algn="r" indent="0" marL="0">
+              <a:buNone/>
+            </a:pPr>
+            <a:r>
+              <a:rPr lang="en-US" sz="1400" dirty="0">
+                <a:solidFill>
+                  <a:srgbClr val="1F2A44"/>
+                </a:solidFill>
+                <a:latin typeface="Calibri" pitchFamily="34" charset="0"/>
+                <a:ea typeface="Calibri" pitchFamily="34" charset="-122"/>
+                <a:cs typeface="Calibri" pitchFamily="34" charset="-120"/>
+              </a:rPr>
+              <a:t>77.6 dB</a:t>
+            </a:r>
+            <a:endParaRPr lang="en-US" sz="1400" dirty="0"/>
+          </a:p>
+        </p:txBody>
+      </p:sp>
+      <p:sp>
+        <p:nvSpPr>
+          <p:cNvPr id="14" name="Shape 11"/>
+          <p:cNvSpPr/>
+          <p:nvPr/>
+        </p:nvSpPr>
+        <p:spPr>
+          <a:xfrm>
+            <a:off x="6583680" y="2615184"/>
+            <a:ext cx="182880" cy="182880"/>
+          </a:xfrm>
+          <a:prstGeom prst="ellipse">
+            <a:avLst/>
+          </a:prstGeom>
+          <a:solidFill>
+            <a:srgbClr val="7048E8"/>
+          </a:solidFill>
+          <a:ln w="12700">
+            <a:solidFill>
+              <a:srgbClr val="7048E8"/>
+            </a:solidFill>
+            <a:prstDash val="solid"/>
+          </a:ln>
+        </p:spPr>
+      </p:sp>
+      <p:sp>
+        <p:nvSpPr>
+          <p:cNvPr id="15" name="Text 12"/>
+          <p:cNvSpPr txBox="1"/>
+          <p:nvPr/>
+        </p:nvSpPr>
+        <p:spPr>
+          <a:xfrm>
+            <a:off x="6858000" y="2551176"/>
+            <a:ext cx="2743200" cy="310896"/>
+          </a:xfrm>
+          <a:prstGeom prst="rect">
+            <a:avLst/>
+          </a:prstGeom>
+          <a:noFill/>
+          <a:ln/>
+        </p:spPr>
+        <p:txBody>
+          <a:bodyPr wrap="square" lIns="0" tIns="0" rIns="0" bIns="0" rtlCol="0" anchor="ctr"/>
+          <a:lstStyle/>
+          <a:p>
+            <a:pPr indent="0" marL="0">
+              <a:buNone/>
+            </a:pPr>
+            <a:r>
+              <a:rPr lang="en-US" sz="1400" b="1" dirty="0">
+                <a:solidFill>
+                  <a:srgbClr val="1F2A44"/>
+                </a:solidFill>
+                <a:latin typeface="Calibri" pitchFamily="34" charset="0"/>
+                <a:ea typeface="Calibri" pitchFamily="34" charset="-122"/>
+                <a:cs typeface="Calibri" pitchFamily="34" charset="-120"/>
+              </a:rPr>
+              <a:t>Felt + rubber</a:t>
+            </a:r>
+            <a:endParaRPr lang="en-US" sz="1400" dirty="0"/>
+          </a:p>
+        </p:txBody>
+      </p:sp>
+      <p:sp>
+        <p:nvSpPr>
+          <p:cNvPr id="16" name="Text 13"/>
+          <p:cNvSpPr txBox="1"/>
+          <p:nvPr/>
+        </p:nvSpPr>
+        <p:spPr>
+          <a:xfrm>
+            <a:off x="9646920" y="2551176"/>
+            <a:ext cx="640080" cy="310896"/>
+          </a:xfrm>
+          <a:prstGeom prst="rect">
+            <a:avLst/>
+          </a:prstGeom>
+          <a:noFill/>
+          <a:ln/>
+        </p:spPr>
+        <p:txBody>
+          <a:bodyPr wrap="square" lIns="0" tIns="0" rIns="0" bIns="0" rtlCol="0" anchor="ctr"/>
+          <a:lstStyle/>
+          <a:p>
+            <a:pPr indent="0" marL="0">
+              <a:buNone/>
+            </a:pPr>
+            <a:r>
+              <a:rPr lang="en-US" sz="1200" dirty="0">
+                <a:solidFill>
+                  <a:srgbClr val="5B6578"/>
+                </a:solidFill>
+                <a:latin typeface="Calibri" pitchFamily="34" charset="0"/>
+                <a:ea typeface="Calibri" pitchFamily="34" charset="-122"/>
+                <a:cs typeface="Calibri" pitchFamily="34" charset="-120"/>
+              </a:rPr>
+              <a:t>2 Oct</a:t>
+            </a:r>
+            <a:endParaRPr lang="en-US" sz="1200" dirty="0"/>
+          </a:p>
+        </p:txBody>
+      </p:sp>
+      <p:sp>
+        <p:nvSpPr>
+          <p:cNvPr id="17" name="Text 14"/>
+          <p:cNvSpPr txBox="1"/>
+          <p:nvPr/>
+        </p:nvSpPr>
+        <p:spPr>
+          <a:xfrm>
+            <a:off x="10241280" y="2551176"/>
+            <a:ext cx="1463040" cy="310896"/>
+          </a:xfrm>
+          <a:prstGeom prst="rect">
+            <a:avLst/>
+          </a:prstGeom>
+          <a:noFill/>
+          <a:ln/>
+        </p:spPr>
+        <p:txBody>
+          <a:bodyPr wrap="square" lIns="0" tIns="0" rIns="0" bIns="0" rtlCol="0" anchor="ctr"/>
+          <a:lstStyle/>
+          <a:p>
+            <a:pPr algn="r" indent="0" marL="0">
+              <a:buNone/>
+            </a:pPr>
+            <a:r>
+              <a:rPr lang="en-US" sz="1400" dirty="0">
+                <a:solidFill>
+                  <a:srgbClr val="1F2A44"/>
+                </a:solidFill>
+                <a:latin typeface="Calibri" pitchFamily="34" charset="0"/>
+                <a:ea typeface="Calibri" pitchFamily="34" charset="-122"/>
+                <a:cs typeface="Calibri" pitchFamily="34" charset="-120"/>
+              </a:rPr>
+              <a:t>78.2 dB</a:t>
+            </a:r>
+            <a:endParaRPr lang="en-US" sz="1400" dirty="0"/>
+          </a:p>
+        </p:txBody>
+      </p:sp>
+      <p:sp>
+        <p:nvSpPr>
+          <p:cNvPr id="18" name="Shape 15"/>
+          <p:cNvSpPr/>
+          <p:nvPr/>
+        </p:nvSpPr>
+        <p:spPr>
+          <a:xfrm>
+            <a:off x="6583680" y="2953512"/>
+            <a:ext cx="182880" cy="182880"/>
+          </a:xfrm>
+          <a:prstGeom prst="ellipse">
+            <a:avLst/>
+          </a:prstGeom>
+          <a:solidFill>
+            <a:srgbClr val="5C940D"/>
+          </a:solidFill>
+          <a:ln w="12700">
+            <a:solidFill>
+              <a:srgbClr val="5C940D"/>
+            </a:solidFill>
+            <a:prstDash val="solid"/>
+          </a:ln>
+        </p:spPr>
+      </p:sp>
+      <p:sp>
+        <p:nvSpPr>
+          <p:cNvPr id="19" name="Text 16"/>
+          <p:cNvSpPr txBox="1"/>
+          <p:nvPr/>
+        </p:nvSpPr>
+        <p:spPr>
+          <a:xfrm>
+            <a:off x="6858000" y="2889504"/>
+            <a:ext cx="2743200" cy="310896"/>
+          </a:xfrm>
+          <a:prstGeom prst="rect">
+            <a:avLst/>
+          </a:prstGeom>
+          <a:noFill/>
+          <a:ln/>
+        </p:spPr>
+        <p:txBody>
+          <a:bodyPr wrap="square" lIns="0" tIns="0" rIns="0" bIns="0" rtlCol="0" anchor="ctr"/>
+          <a:lstStyle/>
+          <a:p>
+            <a:pPr indent="0" marL="0">
+              <a:buNone/>
+            </a:pPr>
+            <a:r>
+              <a:rPr lang="en-US" sz="1400" b="1" dirty="0">
+                <a:solidFill>
+                  <a:srgbClr val="1F2A44"/>
+                </a:solidFill>
+                <a:latin typeface="Calibri" pitchFamily="34" charset="0"/>
+                <a:ea typeface="Calibri" pitchFamily="34" charset="-122"/>
+                <a:cs typeface="Calibri" pitchFamily="34" charset="-120"/>
+              </a:rPr>
+              <a:t>PU foam, double layer</a:t>
+            </a:r>
+            <a:endParaRPr lang="en-US" sz="1400" dirty="0"/>
+          </a:p>
+        </p:txBody>
+      </p:sp>
+      <p:sp>
+        <p:nvSpPr>
+          <p:cNvPr id="20" name="Text 17"/>
+          <p:cNvSpPr txBox="1"/>
+          <p:nvPr/>
+        </p:nvSpPr>
+        <p:spPr>
+          <a:xfrm>
+            <a:off x="9646920" y="2889504"/>
+            <a:ext cx="640080" cy="310896"/>
+          </a:xfrm>
+          <a:prstGeom prst="rect">
+            <a:avLst/>
+          </a:prstGeom>
+          <a:noFill/>
+          <a:ln/>
+        </p:spPr>
+        <p:txBody>
+          <a:bodyPr wrap="square" lIns="0" tIns="0" rIns="0" bIns="0" rtlCol="0" anchor="ctr"/>
+          <a:lstStyle/>
+          <a:p>
+            <a:pPr indent="0" marL="0">
+              <a:buNone/>
+            </a:pPr>
+            <a:r>
+              <a:rPr lang="en-US" sz="1200" dirty="0">
+                <a:solidFill>
+                  <a:srgbClr val="5B6578"/>
+                </a:solidFill>
+                <a:latin typeface="Calibri" pitchFamily="34" charset="0"/>
+                <a:ea typeface="Calibri" pitchFamily="34" charset="-122"/>
+                <a:cs typeface="Calibri" pitchFamily="34" charset="-120"/>
+              </a:rPr>
+              <a:t>7 Oct</a:t>
+            </a:r>
+            <a:endParaRPr lang="en-US" sz="1200" dirty="0"/>
+          </a:p>
+        </p:txBody>
+      </p:sp>
+      <p:sp>
+        <p:nvSpPr>
+          <p:cNvPr id="21" name="Text 18"/>
+          <p:cNvSpPr txBox="1"/>
+          <p:nvPr/>
+        </p:nvSpPr>
+        <p:spPr>
+          <a:xfrm>
+            <a:off x="10241280" y="2889504"/>
+            <a:ext cx="1463040" cy="310896"/>
+          </a:xfrm>
+          <a:prstGeom prst="rect">
+            <a:avLst/>
+          </a:prstGeom>
+          <a:noFill/>
+          <a:ln/>
+        </p:spPr>
+        <p:txBody>
+          <a:bodyPr wrap="square" lIns="0" tIns="0" rIns="0" bIns="0" rtlCol="0" anchor="ctr"/>
+          <a:lstStyle/>
+          <a:p>
+            <a:pPr algn="r" indent="0" marL="0">
+              <a:buNone/>
+            </a:pPr>
+            <a:r>
+              <a:rPr lang="en-US" sz="1400" dirty="0">
+                <a:solidFill>
+                  <a:srgbClr val="1F2A44"/>
+                </a:solidFill>
+                <a:latin typeface="Calibri" pitchFamily="34" charset="0"/>
+                <a:ea typeface="Calibri" pitchFamily="34" charset="-122"/>
+                <a:cs typeface="Calibri" pitchFamily="34" charset="-120"/>
+              </a:rPr>
+              <a:t>78.2 dB</a:t>
+            </a:r>
+            <a:endParaRPr lang="en-US" sz="1400" dirty="0"/>
+          </a:p>
+        </p:txBody>
+      </p:sp>
+      <p:sp>
+        <p:nvSpPr>
+          <p:cNvPr id="22" name="Shape 19"/>
+          <p:cNvSpPr/>
+          <p:nvPr/>
+        </p:nvSpPr>
+        <p:spPr>
+          <a:xfrm>
+            <a:off x="6583680" y="3291840"/>
+            <a:ext cx="182880" cy="182880"/>
+          </a:xfrm>
+          <a:prstGeom prst="ellipse">
+            <a:avLst/>
+          </a:prstGeom>
+          <a:solidFill>
+            <a:srgbClr val="2F9E44"/>
+          </a:solidFill>
+          <a:ln w="12700">
+            <a:solidFill>
+              <a:srgbClr val="2F9E44"/>
+            </a:solidFill>
+            <a:prstDash val="solid"/>
+          </a:ln>
+        </p:spPr>
+      </p:sp>
+      <p:sp>
+        <p:nvSpPr>
+          <p:cNvPr id="23" name="Text 20"/>
+          <p:cNvSpPr txBox="1"/>
+          <p:nvPr/>
+        </p:nvSpPr>
+        <p:spPr>
+          <a:xfrm>
+            <a:off x="6858000" y="3227832"/>
+            <a:ext cx="2743200" cy="310896"/>
+          </a:xfrm>
+          <a:prstGeom prst="rect">
+            <a:avLst/>
+          </a:prstGeom>
+          <a:noFill/>
+          <a:ln/>
+        </p:spPr>
+        <p:txBody>
+          <a:bodyPr wrap="square" lIns="0" tIns="0" rIns="0" bIns="0" rtlCol="0" anchor="ctr"/>
+          <a:lstStyle/>
+          <a:p>
+            <a:pPr indent="0" marL="0">
+              <a:buNone/>
+            </a:pPr>
+            <a:r>
+              <a:rPr lang="en-US" sz="1400" b="1" dirty="0">
+                <a:solidFill>
+                  <a:srgbClr val="1F2A44"/>
+                </a:solidFill>
+                <a:latin typeface="Calibri" pitchFamily="34" charset="0"/>
+                <a:ea typeface="Calibri" pitchFamily="34" charset="-122"/>
+                <a:cs typeface="Calibri" pitchFamily="34" charset="-120"/>
+              </a:rPr>
+              <a:t>Cork</a:t>
+            </a:r>
+            <a:endParaRPr lang="en-US" sz="1400" dirty="0"/>
+          </a:p>
+        </p:txBody>
+      </p:sp>
+      <p:sp>
+        <p:nvSpPr>
           <p:cNvPr id="24" name="Text 21"/>
+          <p:cNvSpPr txBox="1"/>
+          <p:nvPr/>
+        </p:nvSpPr>
+        <p:spPr>
+          <a:xfrm>
+            <a:off x="9646920" y="3227832"/>
+            <a:ext cx="640080" cy="310896"/>
+          </a:xfrm>
+          <a:prstGeom prst="rect">
+            <a:avLst/>
+          </a:prstGeom>
+          <a:noFill/>
+          <a:ln/>
+        </p:spPr>
+        <p:txBody>
+          <a:bodyPr wrap="square" lIns="0" tIns="0" rIns="0" bIns="0" rtlCol="0" anchor="ctr"/>
+          <a:lstStyle/>
+          <a:p>
+            <a:pPr indent="0" marL="0">
+              <a:buNone/>
+            </a:pPr>
+            <a:r>
+              <a:rPr lang="en-US" sz="1200" dirty="0">
+                <a:solidFill>
+                  <a:srgbClr val="5B6578"/>
+                </a:solidFill>
+                <a:latin typeface="Calibri" pitchFamily="34" charset="0"/>
+                <a:ea typeface="Calibri" pitchFamily="34" charset="-122"/>
+                <a:cs typeface="Calibri" pitchFamily="34" charset="-120"/>
+              </a:rPr>
+              <a:t>2 Oct</a:t>
+            </a:r>
+            <a:endParaRPr lang="en-US" sz="1200" dirty="0"/>
+          </a:p>
+        </p:txBody>
+      </p:sp>
+      <p:sp>
+        <p:nvSpPr>
+          <p:cNvPr id="25" name="Text 22"/>
+          <p:cNvSpPr txBox="1"/>
+          <p:nvPr/>
+        </p:nvSpPr>
+        <p:spPr>
+          <a:xfrm>
+            <a:off x="10241280" y="3227832"/>
+            <a:ext cx="1463040" cy="310896"/>
+          </a:xfrm>
+          <a:prstGeom prst="rect">
+            <a:avLst/>
+          </a:prstGeom>
+          <a:noFill/>
+          <a:ln/>
+        </p:spPr>
+        <p:txBody>
+          <a:bodyPr wrap="square" lIns="0" tIns="0" rIns="0" bIns="0" rtlCol="0" anchor="ctr"/>
+          <a:lstStyle/>
+          <a:p>
+            <a:pPr algn="r" indent="0" marL="0">
+              <a:buNone/>
+            </a:pPr>
+            <a:r>
+              <a:rPr lang="en-US" sz="1400" dirty="0">
+                <a:solidFill>
+                  <a:srgbClr val="1F2A44"/>
+                </a:solidFill>
+                <a:latin typeface="Calibri" pitchFamily="34" charset="0"/>
+                <a:ea typeface="Calibri" pitchFamily="34" charset="-122"/>
+                <a:cs typeface="Calibri" pitchFamily="34" charset="-120"/>
+              </a:rPr>
+              <a:t>78.6 dB</a:t>
+            </a:r>
+            <a:endParaRPr lang="en-US" sz="1400" dirty="0"/>
+          </a:p>
+        </p:txBody>
+      </p:sp>
+      <p:sp>
+        <p:nvSpPr>
+          <p:cNvPr id="26" name="Shape 23"/>
+          <p:cNvSpPr/>
+          <p:nvPr/>
+        </p:nvSpPr>
+        <p:spPr>
+          <a:xfrm>
+            <a:off x="6583680" y="3630168"/>
+            <a:ext cx="182880" cy="182880"/>
+          </a:xfrm>
+          <a:prstGeom prst="ellipse">
+            <a:avLst/>
+          </a:prstGeom>
+          <a:solidFill>
+            <a:srgbClr val="C2255C"/>
+          </a:solidFill>
+          <a:ln w="12700">
+            <a:solidFill>
+              <a:srgbClr val="C2255C"/>
+            </a:solidFill>
+            <a:prstDash val="solid"/>
+          </a:ln>
+        </p:spPr>
+      </p:sp>
+      <p:sp>
+        <p:nvSpPr>
+          <p:cNvPr id="27" name="Text 24"/>
+          <p:cNvSpPr txBox="1"/>
+          <p:nvPr/>
+        </p:nvSpPr>
+        <p:spPr>
+          <a:xfrm>
+            <a:off x="6858000" y="3566160"/>
+            <a:ext cx="2743200" cy="310896"/>
+          </a:xfrm>
+          <a:prstGeom prst="rect">
+            <a:avLst/>
+          </a:prstGeom>
+          <a:noFill/>
+          <a:ln/>
+        </p:spPr>
+        <p:txBody>
+          <a:bodyPr wrap="square" lIns="0" tIns="0" rIns="0" bIns="0" rtlCol="0" anchor="ctr"/>
+          <a:lstStyle/>
+          <a:p>
+            <a:pPr indent="0" marL="0">
+              <a:buNone/>
+            </a:pPr>
+            <a:r>
+              <a:rPr lang="en-US" sz="1400" b="1" dirty="0">
+                <a:solidFill>
+                  <a:srgbClr val="1F2A44"/>
+                </a:solidFill>
+                <a:latin typeface="Calibri" pitchFamily="34" charset="0"/>
+                <a:ea typeface="Calibri" pitchFamily="34" charset="-122"/>
+                <a:cs typeface="Calibri" pitchFamily="34" charset="-120"/>
+              </a:rPr>
+              <a:t>Inner felt + outer PU foam</a:t>
+            </a:r>
+            <a:endParaRPr lang="en-US" sz="1400" dirty="0"/>
+          </a:p>
+        </p:txBody>
+      </p:sp>
+      <p:sp>
+        <p:nvSpPr>
+          <p:cNvPr id="28" name="Text 25"/>
+          <p:cNvSpPr txBox="1"/>
+          <p:nvPr/>
+        </p:nvSpPr>
+        <p:spPr>
+          <a:xfrm>
+            <a:off x="9646920" y="3566160"/>
+            <a:ext cx="640080" cy="310896"/>
+          </a:xfrm>
+          <a:prstGeom prst="rect">
+            <a:avLst/>
+          </a:prstGeom>
+          <a:noFill/>
+          <a:ln/>
+        </p:spPr>
+        <p:txBody>
+          <a:bodyPr wrap="square" lIns="0" tIns="0" rIns="0" bIns="0" rtlCol="0" anchor="ctr"/>
+          <a:lstStyle/>
+          <a:p>
+            <a:pPr indent="0" marL="0">
+              <a:buNone/>
+            </a:pPr>
+            <a:r>
+              <a:rPr lang="en-US" sz="1200" dirty="0">
+                <a:solidFill>
+                  <a:srgbClr val="5B6578"/>
+                </a:solidFill>
+                <a:latin typeface="Calibri" pitchFamily="34" charset="0"/>
+                <a:ea typeface="Calibri" pitchFamily="34" charset="-122"/>
+                <a:cs typeface="Calibri" pitchFamily="34" charset="-120"/>
+              </a:rPr>
+              <a:t>7 Oct</a:t>
+            </a:r>
+            <a:endParaRPr lang="en-US" sz="1200" dirty="0"/>
+          </a:p>
+        </p:txBody>
+      </p:sp>
+      <p:sp>
+        <p:nvSpPr>
+          <p:cNvPr id="29" name="Text 26"/>
+          <p:cNvSpPr txBox="1"/>
+          <p:nvPr/>
+        </p:nvSpPr>
+        <p:spPr>
+          <a:xfrm>
+            <a:off x="10241280" y="3566160"/>
+            <a:ext cx="1463040" cy="310896"/>
+          </a:xfrm>
+          <a:prstGeom prst="rect">
+            <a:avLst/>
+          </a:prstGeom>
+          <a:noFill/>
+          <a:ln/>
+        </p:spPr>
+        <p:txBody>
+          <a:bodyPr wrap="square" lIns="0" tIns="0" rIns="0" bIns="0" rtlCol="0" anchor="ctr"/>
+          <a:lstStyle/>
+          <a:p>
+            <a:pPr algn="r" indent="0" marL="0">
+              <a:buNone/>
+            </a:pPr>
+            <a:r>
+              <a:rPr lang="en-US" sz="1400" dirty="0">
+                <a:solidFill>
+                  <a:srgbClr val="1F2A44"/>
+                </a:solidFill>
+                <a:latin typeface="Calibri" pitchFamily="34" charset="0"/>
+                <a:ea typeface="Calibri" pitchFamily="34" charset="-122"/>
+                <a:cs typeface="Calibri" pitchFamily="34" charset="-120"/>
+              </a:rPr>
+              <a:t>78.8 dB</a:t>
+            </a:r>
+            <a:endParaRPr lang="en-US" sz="1400" dirty="0"/>
+          </a:p>
+        </p:txBody>
+      </p:sp>
+      <p:sp>
+        <p:nvSpPr>
+          <p:cNvPr id="30" name="Shape 27"/>
+          <p:cNvSpPr/>
+          <p:nvPr/>
+        </p:nvSpPr>
+        <p:spPr>
+          <a:xfrm>
+            <a:off x="6583680" y="3968496"/>
+            <a:ext cx="182880" cy="182880"/>
+          </a:xfrm>
+          <a:prstGeom prst="ellipse">
+            <a:avLst/>
+          </a:prstGeom>
+          <a:solidFill>
+            <a:srgbClr val="1864AB"/>
+          </a:solidFill>
+          <a:ln w="12700">
+            <a:solidFill>
+              <a:srgbClr val="1864AB"/>
+            </a:solidFill>
+            <a:prstDash val="solid"/>
+          </a:ln>
+        </p:spPr>
+      </p:sp>
+      <p:sp>
+        <p:nvSpPr>
+          <p:cNvPr id="31" name="Text 28"/>
+          <p:cNvSpPr txBox="1"/>
+          <p:nvPr/>
+        </p:nvSpPr>
+        <p:spPr>
+          <a:xfrm>
+            <a:off x="6858000" y="3904488"/>
+            <a:ext cx="2743200" cy="310896"/>
+          </a:xfrm>
+          <a:prstGeom prst="rect">
+            <a:avLst/>
+          </a:prstGeom>
+          <a:noFill/>
+          <a:ln/>
+        </p:spPr>
+        <p:txBody>
+          <a:bodyPr wrap="square" lIns="0" tIns="0" rIns="0" bIns="0" rtlCol="0" anchor="ctr"/>
+          <a:lstStyle/>
+          <a:p>
+            <a:pPr indent="0" marL="0">
+              <a:buNone/>
+            </a:pPr>
+            <a:r>
+              <a:rPr lang="en-US" sz="1400" b="1" dirty="0">
+                <a:solidFill>
+                  <a:srgbClr val="1F2A44"/>
+                </a:solidFill>
+                <a:latin typeface="Calibri" pitchFamily="34" charset="0"/>
+                <a:ea typeface="Calibri" pitchFamily="34" charset="-122"/>
+                <a:cs typeface="Calibri" pitchFamily="34" charset="-120"/>
+              </a:rPr>
+              <a:t>Thinsulate, 8 layers</a:t>
+            </a:r>
+            <a:endParaRPr lang="en-US" sz="1400" dirty="0"/>
+          </a:p>
+        </p:txBody>
+      </p:sp>
+      <p:sp>
+        <p:nvSpPr>
+          <p:cNvPr id="32" name="Text 29"/>
+          <p:cNvSpPr txBox="1"/>
+          <p:nvPr/>
+        </p:nvSpPr>
+        <p:spPr>
+          <a:xfrm>
+            <a:off x="9646920" y="3904488"/>
+            <a:ext cx="640080" cy="310896"/>
+          </a:xfrm>
+          <a:prstGeom prst="rect">
+            <a:avLst/>
+          </a:prstGeom>
+          <a:noFill/>
+          <a:ln/>
+        </p:spPr>
+        <p:txBody>
+          <a:bodyPr wrap="square" lIns="0" tIns="0" rIns="0" bIns="0" rtlCol="0" anchor="ctr"/>
+          <a:lstStyle/>
+          <a:p>
+            <a:pPr indent="0" marL="0">
+              <a:buNone/>
+            </a:pPr>
+            <a:r>
+              <a:rPr lang="en-US" sz="1200" dirty="0">
+                <a:solidFill>
+                  <a:srgbClr val="5B6578"/>
+                </a:solidFill>
+                <a:latin typeface="Calibri" pitchFamily="34" charset="0"/>
+                <a:ea typeface="Calibri" pitchFamily="34" charset="-122"/>
+                <a:cs typeface="Calibri" pitchFamily="34" charset="-120"/>
+              </a:rPr>
+              <a:t>7 Oct</a:t>
+            </a:r>
+            <a:endParaRPr lang="en-US" sz="1200" dirty="0"/>
+          </a:p>
+        </p:txBody>
+      </p:sp>
+      <p:sp>
+        <p:nvSpPr>
+          <p:cNvPr id="33" name="Text 30"/>
+          <p:cNvSpPr txBox="1"/>
+          <p:nvPr/>
+        </p:nvSpPr>
+        <p:spPr>
+          <a:xfrm>
+            <a:off x="10241280" y="3904488"/>
+            <a:ext cx="1463040" cy="310896"/>
+          </a:xfrm>
+          <a:prstGeom prst="rect">
+            <a:avLst/>
+          </a:prstGeom>
+          <a:noFill/>
+          <a:ln/>
+        </p:spPr>
+        <p:txBody>
+          <a:bodyPr wrap="square" lIns="0" tIns="0" rIns="0" bIns="0" rtlCol="0" anchor="ctr"/>
+          <a:lstStyle/>
+          <a:p>
+            <a:pPr algn="r" indent="0" marL="0">
+              <a:buNone/>
+            </a:pPr>
+            <a:r>
+              <a:rPr lang="en-US" sz="1400" dirty="0">
+                <a:solidFill>
+                  <a:srgbClr val="1F2A44"/>
+                </a:solidFill>
+                <a:latin typeface="Calibri" pitchFamily="34" charset="0"/>
+                <a:ea typeface="Calibri" pitchFamily="34" charset="-122"/>
+                <a:cs typeface="Calibri" pitchFamily="34" charset="-120"/>
+              </a:rPr>
+              <a:t>79.2 dB</a:t>
+            </a:r>
+            <a:endParaRPr lang="en-US" sz="1400" dirty="0"/>
+          </a:p>
+        </p:txBody>
+      </p:sp>
+      <p:sp>
+        <p:nvSpPr>
+          <p:cNvPr id="34" name="Shape 31"/>
+          <p:cNvSpPr/>
+          <p:nvPr/>
+        </p:nvSpPr>
+        <p:spPr>
+          <a:xfrm>
+            <a:off x="6583680" y="4306824"/>
+            <a:ext cx="182880" cy="182880"/>
+          </a:xfrm>
+          <a:prstGeom prst="ellipse">
+            <a:avLst/>
+          </a:prstGeom>
+          <a:solidFill>
+            <a:srgbClr val="1098AD"/>
+          </a:solidFill>
+          <a:ln w="12700">
+            <a:solidFill>
+              <a:srgbClr val="1098AD"/>
+            </a:solidFill>
+            <a:prstDash val="solid"/>
+          </a:ln>
+        </p:spPr>
+      </p:sp>
+      <p:sp>
+        <p:nvSpPr>
+          <p:cNvPr id="35" name="Text 32"/>
+          <p:cNvSpPr txBox="1"/>
+          <p:nvPr/>
+        </p:nvSpPr>
+        <p:spPr>
+          <a:xfrm>
+            <a:off x="6858000" y="4242816"/>
+            <a:ext cx="2743200" cy="310896"/>
+          </a:xfrm>
+          <a:prstGeom prst="rect">
+            <a:avLst/>
+          </a:prstGeom>
+          <a:noFill/>
+          <a:ln/>
+        </p:spPr>
+        <p:txBody>
+          <a:bodyPr wrap="square" lIns="0" tIns="0" rIns="0" bIns="0" rtlCol="0" anchor="ctr"/>
+          <a:lstStyle/>
+          <a:p>
+            <a:pPr indent="0" marL="0">
+              <a:buNone/>
+            </a:pPr>
+            <a:r>
+              <a:rPr lang="en-US" sz="1400" b="1" dirty="0">
+                <a:solidFill>
+                  <a:srgbClr val="1F2A44"/>
+                </a:solidFill>
+                <a:latin typeface="Calibri" pitchFamily="34" charset="0"/>
+                <a:ea typeface="Calibri" pitchFamily="34" charset="-122"/>
+                <a:cs typeface="Calibri" pitchFamily="34" charset="-120"/>
+              </a:rPr>
+              <a:t>Felt</a:t>
+            </a:r>
+            <a:endParaRPr lang="en-US" sz="1400" dirty="0"/>
+          </a:p>
+        </p:txBody>
+      </p:sp>
+      <p:sp>
+        <p:nvSpPr>
+          <p:cNvPr id="36" name="Text 33"/>
+          <p:cNvSpPr txBox="1"/>
+          <p:nvPr/>
+        </p:nvSpPr>
+        <p:spPr>
+          <a:xfrm>
+            <a:off x="9646920" y="4242816"/>
+            <a:ext cx="640080" cy="310896"/>
+          </a:xfrm>
+          <a:prstGeom prst="rect">
+            <a:avLst/>
+          </a:prstGeom>
+          <a:noFill/>
+          <a:ln/>
+        </p:spPr>
+        <p:txBody>
+          <a:bodyPr wrap="square" lIns="0" tIns="0" rIns="0" bIns="0" rtlCol="0" anchor="ctr"/>
+          <a:lstStyle/>
+          <a:p>
+            <a:pPr indent="0" marL="0">
+              <a:buNone/>
+            </a:pPr>
+            <a:r>
+              <a:rPr lang="en-US" sz="1200" dirty="0">
+                <a:solidFill>
+                  <a:srgbClr val="5B6578"/>
+                </a:solidFill>
+                <a:latin typeface="Calibri" pitchFamily="34" charset="0"/>
+                <a:ea typeface="Calibri" pitchFamily="34" charset="-122"/>
+                <a:cs typeface="Calibri" pitchFamily="34" charset="-120"/>
+              </a:rPr>
+              <a:t>2 Oct</a:t>
+            </a:r>
+            <a:endParaRPr lang="en-US" sz="1200" dirty="0"/>
+          </a:p>
+        </p:txBody>
+      </p:sp>
+      <p:sp>
+        <p:nvSpPr>
+          <p:cNvPr id="37" name="Text 34"/>
+          <p:cNvSpPr txBox="1"/>
+          <p:nvPr/>
+        </p:nvSpPr>
+        <p:spPr>
+          <a:xfrm>
+            <a:off x="10241280" y="4242816"/>
+            <a:ext cx="1463040" cy="310896"/>
+          </a:xfrm>
+          <a:prstGeom prst="rect">
+            <a:avLst/>
+          </a:prstGeom>
+          <a:noFill/>
+          <a:ln/>
+        </p:spPr>
+        <p:txBody>
+          <a:bodyPr wrap="square" lIns="0" tIns="0" rIns="0" bIns="0" rtlCol="0" anchor="ctr"/>
+          <a:lstStyle/>
+          <a:p>
+            <a:pPr algn="r" indent="0" marL="0">
+              <a:buNone/>
+            </a:pPr>
+            <a:r>
+              <a:rPr lang="en-US" sz="1400" dirty="0">
+                <a:solidFill>
+                  <a:srgbClr val="1F2A44"/>
+                </a:solidFill>
+                <a:latin typeface="Calibri" pitchFamily="34" charset="0"/>
+                <a:ea typeface="Calibri" pitchFamily="34" charset="-122"/>
+                <a:cs typeface="Calibri" pitchFamily="34" charset="-120"/>
+              </a:rPr>
+              <a:t>79.3 dB</a:t>
+            </a:r>
+            <a:endParaRPr lang="en-US" sz="1400" dirty="0"/>
+          </a:p>
+        </p:txBody>
+      </p:sp>
+      <p:sp>
+        <p:nvSpPr>
+          <p:cNvPr id="38" name="Shape 35"/>
+          <p:cNvSpPr/>
+          <p:nvPr/>
+        </p:nvSpPr>
+        <p:spPr>
+          <a:xfrm>
+            <a:off x="6583680" y="4645152"/>
+            <a:ext cx="182880" cy="182880"/>
+          </a:xfrm>
+          <a:prstGeom prst="ellipse">
+            <a:avLst/>
+          </a:prstGeom>
+          <a:solidFill>
+            <a:srgbClr val="E03131"/>
+          </a:solidFill>
+          <a:ln w="12700">
+            <a:solidFill>
+              <a:srgbClr val="E03131"/>
+            </a:solidFill>
+            <a:prstDash val="solid"/>
+          </a:ln>
+        </p:spPr>
+      </p:sp>
+      <p:sp>
+        <p:nvSpPr>
+          <p:cNvPr id="39" name="Text 36"/>
+          <p:cNvSpPr txBox="1"/>
+          <p:nvPr/>
+        </p:nvSpPr>
+        <p:spPr>
+          <a:xfrm>
+            <a:off x="6858000" y="4581144"/>
+            <a:ext cx="2743200" cy="310896"/>
+          </a:xfrm>
+          <a:prstGeom prst="rect">
+            <a:avLst/>
+          </a:prstGeom>
+          <a:noFill/>
+          <a:ln/>
+        </p:spPr>
+        <p:txBody>
+          <a:bodyPr wrap="square" lIns="0" tIns="0" rIns="0" bIns="0" rtlCol="0" anchor="ctr"/>
+          <a:lstStyle/>
+          <a:p>
+            <a:pPr indent="0" marL="0">
+              <a:buNone/>
+            </a:pPr>
+            <a:r>
+              <a:rPr lang="en-US" sz="1400" b="1" dirty="0">
+                <a:solidFill>
+                  <a:srgbClr val="1F2A44"/>
+                </a:solidFill>
+                <a:latin typeface="Calibri" pitchFamily="34" charset="0"/>
+                <a:ea typeface="Calibri" pitchFamily="34" charset="-122"/>
+                <a:cs typeface="Calibri" pitchFamily="34" charset="-120"/>
+              </a:rPr>
+              <a:t>Thinsulate, 4 layers</a:t>
+            </a:r>
+            <a:endParaRPr lang="en-US" sz="1400" dirty="0"/>
+          </a:p>
+        </p:txBody>
+      </p:sp>
+      <p:sp>
+        <p:nvSpPr>
+          <p:cNvPr id="40" name="Text 37"/>
+          <p:cNvSpPr txBox="1"/>
+          <p:nvPr/>
+        </p:nvSpPr>
+        <p:spPr>
+          <a:xfrm>
+            <a:off x="9646920" y="4581144"/>
+            <a:ext cx="640080" cy="310896"/>
+          </a:xfrm>
+          <a:prstGeom prst="rect">
+            <a:avLst/>
+          </a:prstGeom>
+          <a:noFill/>
+          <a:ln/>
+        </p:spPr>
+        <p:txBody>
+          <a:bodyPr wrap="square" lIns="0" tIns="0" rIns="0" bIns="0" rtlCol="0" anchor="ctr"/>
+          <a:lstStyle/>
+          <a:p>
+            <a:pPr indent="0" marL="0">
+              <a:buNone/>
+            </a:pPr>
+            <a:r>
+              <a:rPr lang="en-US" sz="1200" dirty="0">
+                <a:solidFill>
+                  <a:srgbClr val="5B6578"/>
+                </a:solidFill>
+                <a:latin typeface="Calibri" pitchFamily="34" charset="0"/>
+                <a:ea typeface="Calibri" pitchFamily="34" charset="-122"/>
+                <a:cs typeface="Calibri" pitchFamily="34" charset="-120"/>
+              </a:rPr>
+              <a:t>7 Oct</a:t>
+            </a:r>
+            <a:endParaRPr lang="en-US" sz="1200" dirty="0"/>
+          </a:p>
+        </p:txBody>
+      </p:sp>
+      <p:sp>
+        <p:nvSpPr>
+          <p:cNvPr id="41" name="Text 38"/>
+          <p:cNvSpPr txBox="1"/>
+          <p:nvPr/>
+        </p:nvSpPr>
+        <p:spPr>
+          <a:xfrm>
+            <a:off x="10241280" y="4581144"/>
+            <a:ext cx="1463040" cy="310896"/>
+          </a:xfrm>
+          <a:prstGeom prst="rect">
+            <a:avLst/>
+          </a:prstGeom>
+          <a:noFill/>
+          <a:ln/>
+        </p:spPr>
+        <p:txBody>
+          <a:bodyPr wrap="square" lIns="0" tIns="0" rIns="0" bIns="0" rtlCol="0" anchor="ctr"/>
+          <a:lstStyle/>
+          <a:p>
+            <a:pPr algn="r" indent="0" marL="0">
+              <a:buNone/>
+            </a:pPr>
+            <a:r>
+              <a:rPr lang="en-US" sz="1400" dirty="0">
+                <a:solidFill>
+                  <a:srgbClr val="1F2A44"/>
+                </a:solidFill>
+                <a:latin typeface="Calibri" pitchFamily="34" charset="0"/>
+                <a:ea typeface="Calibri" pitchFamily="34" charset="-122"/>
+                <a:cs typeface="Calibri" pitchFamily="34" charset="-120"/>
+              </a:rPr>
+              <a:t>79.4 dB</a:t>
+            </a:r>
+            <a:endParaRPr lang="en-US" sz="1400" dirty="0"/>
+          </a:p>
+        </p:txBody>
+      </p:sp>
+      <p:sp>
+        <p:nvSpPr>
+          <p:cNvPr id="42" name="Shape 39"/>
+          <p:cNvSpPr/>
+          <p:nvPr/>
+        </p:nvSpPr>
+        <p:spPr>
+          <a:xfrm>
+            <a:off x="6583680" y="4983480"/>
+            <a:ext cx="182880" cy="182880"/>
+          </a:xfrm>
+          <a:prstGeom prst="ellipse">
+            <a:avLst/>
+          </a:prstGeom>
+          <a:solidFill>
+            <a:srgbClr val="F08C00"/>
+          </a:solidFill>
+          <a:ln w="12700">
+            <a:solidFill>
+              <a:srgbClr val="F08C00"/>
+            </a:solidFill>
+            <a:prstDash val="solid"/>
+          </a:ln>
+        </p:spPr>
+      </p:sp>
+      <p:sp>
+        <p:nvSpPr>
+          <p:cNvPr id="43" name="Text 40"/>
+          <p:cNvSpPr txBox="1"/>
+          <p:nvPr/>
+        </p:nvSpPr>
+        <p:spPr>
+          <a:xfrm>
+            <a:off x="6858000" y="4919472"/>
+            <a:ext cx="2743200" cy="310896"/>
+          </a:xfrm>
+          <a:prstGeom prst="rect">
+            <a:avLst/>
+          </a:prstGeom>
+          <a:noFill/>
+          <a:ln/>
+        </p:spPr>
+        <p:txBody>
+          <a:bodyPr wrap="square" lIns="0" tIns="0" rIns="0" bIns="0" rtlCol="0" anchor="ctr"/>
+          <a:lstStyle/>
+          <a:p>
+            <a:pPr indent="0" marL="0">
+              <a:buNone/>
+            </a:pPr>
+            <a:r>
+              <a:rPr lang="en-US" sz="1400" b="1" dirty="0">
+                <a:solidFill>
+                  <a:srgbClr val="1F2A44"/>
+                </a:solidFill>
+                <a:latin typeface="Calibri" pitchFamily="34" charset="0"/>
+                <a:ea typeface="Calibri" pitchFamily="34" charset="-122"/>
+                <a:cs typeface="Calibri" pitchFamily="34" charset="-120"/>
+              </a:rPr>
+              <a:t>Rubber</a:t>
+            </a:r>
+            <a:endParaRPr lang="en-US" sz="1400" dirty="0"/>
+          </a:p>
+        </p:txBody>
+      </p:sp>
+      <p:sp>
+        <p:nvSpPr>
+          <p:cNvPr id="44" name="Text 41"/>
+          <p:cNvSpPr txBox="1"/>
+          <p:nvPr/>
+        </p:nvSpPr>
+        <p:spPr>
+          <a:xfrm>
+            <a:off x="9646920" y="4919472"/>
+            <a:ext cx="640080" cy="310896"/>
+          </a:xfrm>
+          <a:prstGeom prst="rect">
+            <a:avLst/>
+          </a:prstGeom>
+          <a:noFill/>
+          <a:ln/>
+        </p:spPr>
+        <p:txBody>
+          <a:bodyPr wrap="square" lIns="0" tIns="0" rIns="0" bIns="0" rtlCol="0" anchor="ctr"/>
+          <a:lstStyle/>
+          <a:p>
+            <a:pPr indent="0" marL="0">
+              <a:buNone/>
+            </a:pPr>
+            <a:r>
+              <a:rPr lang="en-US" sz="1200" dirty="0">
+                <a:solidFill>
+                  <a:srgbClr val="5B6578"/>
+                </a:solidFill>
+                <a:latin typeface="Calibri" pitchFamily="34" charset="0"/>
+                <a:ea typeface="Calibri" pitchFamily="34" charset="-122"/>
+                <a:cs typeface="Calibri" pitchFamily="34" charset="-120"/>
+              </a:rPr>
+              <a:t>2 Oct</a:t>
+            </a:r>
+            <a:endParaRPr lang="en-US" sz="1200" dirty="0"/>
+          </a:p>
+        </p:txBody>
+      </p:sp>
+      <p:sp>
+        <p:nvSpPr>
+          <p:cNvPr id="45" name="Text 42"/>
+          <p:cNvSpPr txBox="1"/>
+          <p:nvPr/>
+        </p:nvSpPr>
+        <p:spPr>
+          <a:xfrm>
+            <a:off x="10241280" y="4919472"/>
+            <a:ext cx="1463040" cy="310896"/>
+          </a:xfrm>
+          <a:prstGeom prst="rect">
+            <a:avLst/>
+          </a:prstGeom>
+          <a:noFill/>
+          <a:ln/>
+        </p:spPr>
+        <p:txBody>
+          <a:bodyPr wrap="square" lIns="0" tIns="0" rIns="0" bIns="0" rtlCol="0" anchor="ctr"/>
+          <a:lstStyle/>
+          <a:p>
+            <a:pPr algn="r" indent="0" marL="0">
+              <a:buNone/>
+            </a:pPr>
+            <a:r>
+              <a:rPr lang="en-US" sz="1400" dirty="0">
+                <a:solidFill>
+                  <a:srgbClr val="1F2A44"/>
+                </a:solidFill>
+                <a:latin typeface="Calibri" pitchFamily="34" charset="0"/>
+                <a:ea typeface="Calibri" pitchFamily="34" charset="-122"/>
+                <a:cs typeface="Calibri" pitchFamily="34" charset="-120"/>
+              </a:rPr>
+              <a:t>80.3 dB</a:t>
+            </a:r>
+            <a:endParaRPr lang="en-US" sz="1400" dirty="0"/>
+          </a:p>
+        </p:txBody>
+      </p:sp>
+      <p:sp>
+        <p:nvSpPr>
+          <p:cNvPr id="46" name="Text 43"/>
+          <p:cNvSpPr txBox="1"/>
+          <p:nvPr/>
+        </p:nvSpPr>
+        <p:spPr>
+          <a:xfrm>
+            <a:off x="6583680" y="5349240"/>
+            <a:ext cx="5120640" cy="640080"/>
+          </a:xfrm>
+          <a:prstGeom prst="rect">
+            <a:avLst/>
+          </a:prstGeom>
+          <a:noFill/>
+          <a:ln/>
+        </p:spPr>
+        <p:txBody>
+          <a:bodyPr wrap="square" lIns="0" tIns="0" rIns="0" bIns="0" rtlCol="0" anchor="ctr"/>
+          <a:lstStyle/>
+          <a:p>
+            <a:pPr indent="0" marL="0">
+              <a:buNone/>
+            </a:pPr>
+            <a:r>
+              <a:rPr lang="en-US" sz="3600" b="1" dirty="0">
+                <a:solidFill>
+                  <a:srgbClr val="D6336C"/>
+                </a:solidFill>
+                <a:latin typeface="Cambria" pitchFamily="34" charset="0"/>
+                <a:ea typeface="Cambria" pitchFamily="34" charset="-122"/>
+                <a:cs typeface="Cambria" pitchFamily="34" charset="-120"/>
+              </a:rPr>
+              <a:t>+3.4 to +6.2 dB</a:t>
+            </a:r>
+            <a:endParaRPr lang="en-US" sz="3600" dirty="0"/>
+          </a:p>
+        </p:txBody>
+      </p:sp>
+      <p:sp>
+        <p:nvSpPr>
+          <p:cNvPr id="47" name="Text 44"/>
+          <p:cNvSpPr txBox="1"/>
+          <p:nvPr/>
+        </p:nvSpPr>
+        <p:spPr>
+          <a:xfrm>
+            <a:off x="6583680" y="5943600"/>
+            <a:ext cx="5120640" cy="274320"/>
+          </a:xfrm>
+          <a:prstGeom prst="rect">
+            <a:avLst/>
+          </a:prstGeom>
+          <a:noFill/>
+          <a:ln/>
+        </p:spPr>
+        <p:txBody>
+          <a:bodyPr wrap="square" lIns="0" tIns="0" rIns="0" bIns="0" rtlCol="0" anchor="ctr"/>
+          <a:lstStyle/>
+          <a:p>
+            <a:pPr indent="0" marL="0">
+              <a:buNone/>
+            </a:pPr>
+            <a:r>
+              <a:rPr lang="en-US" sz="1300" dirty="0">
+                <a:solidFill>
+                  <a:srgbClr val="1F2A44"/>
+                </a:solidFill>
+                <a:latin typeface="Calibri" pitchFamily="34" charset="0"/>
+                <a:ea typeface="Calibri" pitchFamily="34" charset="-122"/>
+                <a:cs typeface="Calibri" pitchFamily="34" charset="-120"/>
+              </a:rPr>
+              <a:t>louder than bare, on average (bare measured 2 Oct)</a:t>
+            </a:r>
+            <a:endParaRPr lang="en-US" sz="1300" dirty="0"/>
+          </a:p>
+        </p:txBody>
+      </p:sp>
+      <p:sp>
+        <p:nvSpPr>
+          <p:cNvPr id="48" name="Text 45"/>
           <p:cNvSpPr txBox="1"/>
           <p:nvPr/>
         </p:nvSpPr>
@@ -12574,7 +13440,7 @@
                 <a:ea typeface="Calibri" pitchFamily="34" charset="-122"/>
                 <a:cs typeface="Calibri" pitchFamily="34" charset="-120"/>
               </a:rPr>
-              <a:t>2 Oct 2026, 5-inch 3-blade propeller, total level 100 Hz–10 kHz, motor at 2000 µs, corrected microphone files. Radial axis 65–90 dB.</a:t>
+              <a:t>2 and 7 Oct 2026, 5-inch 3-blade propeller, total level 500 Hz–24 kHz, motor at 2000 µs, corrected microphone files. Radial axis 68–89 dB.</a:t>
             </a:r>
             <a:endParaRPr lang="en-US" sz="1100" dirty="0"/>
           </a:p>
@@ -12582,7 +13448,7 @@
       </p:sp>
       <p:sp>
         <p:nvSpPr>
-          <p:cNvPr id="25" name="Text 22"/>
+          <p:cNvPr id="49" name="Text 46"/>
           <p:cNvSpPr txBox="1"/>
           <p:nvPr/>
         </p:nvSpPr>

</xml_diff>

<commit_message>
Slides: slide 9, the ten membrane set-ups (8-9 Oct) overlaid at 2000 us, 500 Hz-24 kHz, mean of 3 repeats
Co-Authored-By: Claude Sonnet 5.5 <noreply@anthropic.com>
</commit_message>
<xml_diff>
--- a/docs/analysis/chamber-final-2026-10-01/slides/chamber-slides-final.pptx
+++ b/docs/analysis/chamber-final-2026-10-01/slides/chamber-slides-final.pptx
@@ -13,9 +13,10 @@
     <p:sldId id="261" r:id="rId7"/>
     <p:sldId id="262" r:id="rId8"/>
     <p:sldId id="263" r:id="rId9"/>
+    <p:sldId id="264" r:id="rId10"/>
   </p:sldIdLst>
   <p:notesMasterIdLst>
-    <p:notesMasterId r:id="rId10"/>
+    <p:notesMasterId r:id="rId11"/>
   </p:notesMasterIdLst>
   <p:sldSz cx="12192000" cy="6858000"/>
   <p:notesSz cx="6858000" cy="12192000"/>
@@ -1560,6 +1561,94 @@
             <a:fld id="{F7021451-1387-4CA6-816F-3879F97B5CBC}" type="slidenum">
               <a:rPr lang="en-US"/>
               <a:t>8</a:t>
+            </a:fld>
+            <a:endParaRPr lang="en-US"/>
+          </a:p>
+        </p:txBody>
+      </p:sp>
+    </p:spTree>
+    <p:extLst>
+      <p:ext uri="{BB962C8B-B14F-4D97-AF65-F5344CB8AC3E}">
+        <p14:creationId xmlns:p14="http://schemas.microsoft.com/office/powerpoint/2010/main" val="1024086991"/>
+      </p:ext>
+    </p:extLst>
+  </p:cSld>
+  <p:clrMapOvr>
+    <a:masterClrMapping/>
+  </p:clrMapOvr>
+</p:notes>
+</file>
+
+<file path=ppt/notesSlides/notesSlide9.xml><?xml version="1.0" encoding="utf-8"?>
+<p:notes xmlns:a="http://schemas.openxmlformats.org/drawingml/2006/main" xmlns:r="http://schemas.openxmlformats.org/officeDocument/2006/relationships" xmlns:p="http://schemas.openxmlformats.org/presentationml/2006/main">
+  <p:cSld>
+    <p:spTree>
+      <p:nvGrpSpPr>
+        <p:cNvPr id="1" name=""/>
+        <p:cNvGrpSpPr/>
+        <p:nvPr/>
+      </p:nvGrpSpPr>
+      <p:grpSpPr>
+        <a:xfrm>
+          <a:off x="0" y="0"/>
+          <a:ext cx="0" cy="0"/>
+          <a:chOff x="0" y="0"/>
+          <a:chExt cx="0" cy="0"/>
+        </a:xfrm>
+      </p:grpSpPr>
+      <p:sp>
+        <p:nvSpPr>
+          <p:cNvPr id="2" name="Slide Image Placeholder 1"/>
+          <p:cNvSpPr>
+            <a:spLocks noGrp="1" noRot="1" noChangeAspect="1"/>
+          </p:cNvSpPr>
+          <p:nvPr>
+            <p:ph type="sldImg"/>
+          </p:nvPr>
+        </p:nvSpPr>
+        <p:spPr/>
+      </p:sp>
+      <p:sp>
+        <p:nvSpPr>
+          <p:cNvPr id="3" name="Notes Placeholder 2"/>
+          <p:cNvSpPr>
+            <a:spLocks noGrp="1"/>
+          </p:cNvSpPr>
+          <p:nvPr>
+            <p:ph type="body" idx="1"/>
+          </p:nvPr>
+        </p:nvSpPr>
+        <p:spPr/>
+        <p:txBody>
+          <a:bodyPr/>
+          <a:lstStyle/>
+          <a:p>
+            <a:r>
+              <a:rPr lang="en-US" dirty="0"/>
+              <a:t>Bases in the data repo (f30__5in3b__membrane-...): 8 Oct 2026: membrane-duct-small, membrane-open-pore-pu-foam. 9 Oct 2026: membrane-duct-open-pore-pu-foam-double-layer, membrane-felt, membrane-felt-double-layer, membrane-cork, membrane-felt-rubber, membrane-thinsulate-8-layers, -4-layers, -2-layers. Each base was captured with 3 repeats of the ramp; the plot uses the PWM 2000 step and the mean over the 3 repeats of the total level 500 Hz to 24 kHz per microphone, in dB SPL, read with the corrected microphone files. The repeat-to-repeat scatter of the mean level is 0.02-0.11 dB. There is no bare reference measured with this set-up (the base names carry a different motor field, f30, from the 2 and 7 Oct materials), so levels here are not comparable with slide 8 and no louder-than-bare figure is given; the callout is the spread between the quietest (Thinsulate 4 layers) and loudest (small membrane duct) set-up. Two of the bases are ducts. The polar is mirrored to 360 degrees.</a:t>
+            </a:r>
+            <a:endParaRPr lang="en-US" dirty="0"/>
+          </a:p>
+        </p:txBody>
+      </p:sp>
+      <p:sp>
+        <p:nvSpPr>
+          <p:cNvPr id="4" name="Slide Number Placeholder 3"/>
+          <p:cNvSpPr>
+            <a:spLocks noGrp="1"/>
+          </p:cNvSpPr>
+          <p:nvPr>
+            <p:ph type="sldNum" sz="quarter" idx="10"/>
+          </p:nvPr>
+        </p:nvSpPr>
+        <p:spPr/>
+        <p:txBody>
+          <a:bodyPr/>
+          <a:lstStyle/>
+          <a:p>
+            <a:fld id="{F7021451-1387-4CA6-816F-3879F97B5CBC}" type="slidenum">
+              <a:rPr lang="en-US"/>
+              <a:t>9</a:t>
             </a:fld>
             <a:endParaRPr lang="en-US"/>
           </a:p>
@@ -13493,6 +13582,1755 @@
 </p:sld>
 </file>
 
+<file path=ppt/slides/slide9.xml><?xml version="1.0" encoding="utf-8"?>
+<p:sld xmlns:a="http://schemas.openxmlformats.org/drawingml/2006/main" xmlns:r="http://schemas.openxmlformats.org/officeDocument/2006/relationships" xmlns:p="http://schemas.openxmlformats.org/presentationml/2006/main">
+  <p:cSld name="Slide 9">
+    <p:bg>
+      <p:bgPr>
+        <a:solidFill>
+          <a:srgbClr val="FFFFFF"/>
+        </a:solidFill>
+      </p:bgPr>
+    </p:bg>
+    <p:spTree>
+      <p:nvGrpSpPr>
+        <p:cNvPr id="1" name=""/>
+        <p:cNvGrpSpPr/>
+        <p:nvPr/>
+      </p:nvGrpSpPr>
+      <p:grpSpPr>
+        <a:xfrm>
+          <a:off x="0" y="0"/>
+          <a:ext cx="0" cy="0"/>
+          <a:chOff x="0" y="0"/>
+          <a:chExt cx="0" cy="0"/>
+        </a:xfrm>
+      </p:grpSpPr>
+      <p:pic>
+        <p:nvPicPr>
+          <p:cNvPr id="2" name="Image 0" descr="Polar plot of ten membrane set-ups at 2000 microseconds, total level 500 Hz to 24 kHz">    </p:cNvPr>
+          <p:cNvPicPr>
+            <a:picLocks noChangeAspect="1"/>
+          </p:cNvPicPr>
+          <p:nvPr/>
+        </p:nvPicPr>
+        <p:blipFill>
+          <a:blip r:embed="rId1"/>
+          <a:stretch>
+            <a:fillRect/>
+          </a:stretch>
+        </p:blipFill>
+        <p:spPr>
+          <a:xfrm>
+            <a:off x="411480" y="411480"/>
+            <a:ext cx="5824728" cy="5806440"/>
+          </a:xfrm>
+          <a:prstGeom prst="rect">
+            <a:avLst/>
+          </a:prstGeom>
+        </p:spPr>
+      </p:pic>
+      <p:sp>
+        <p:nvSpPr>
+          <p:cNvPr id="3" name="Text 0"/>
+          <p:cNvSpPr txBox="1"/>
+          <p:nvPr/>
+        </p:nvSpPr>
+        <p:spPr>
+          <a:xfrm>
+            <a:off x="6583680" y="365760"/>
+            <a:ext cx="5120640" cy="320040"/>
+          </a:xfrm>
+          <a:prstGeom prst="rect">
+            <a:avLst/>
+          </a:prstGeom>
+          <a:noFill/>
+          <a:ln/>
+        </p:spPr>
+        <p:txBody>
+          <a:bodyPr wrap="square" lIns="0" tIns="0" rIns="0" bIns="0" rtlCol="0" anchor="ctr"/>
+          <a:lstStyle/>
+          <a:p>
+            <a:pPr indent="0" marL="0">
+              <a:buNone/>
+            </a:pPr>
+            <a:r>
+              <a:rPr lang="en-US" sz="1400" b="1" spc="300" kern="0" dirty="0">
+                <a:solidFill>
+                  <a:srgbClr val="2B6CB0"/>
+                </a:solidFill>
+                <a:latin typeface="Calibri" pitchFamily="34" charset="0"/>
+                <a:ea typeface="Calibri" pitchFamily="34" charset="-122"/>
+                <a:cs typeface="Calibri" pitchFamily="34" charset="-120"/>
+              </a:rPr>
+              <a:t>THE MEMBRANES</a:t>
+            </a:r>
+            <a:endParaRPr lang="en-US" sz="1400" dirty="0"/>
+          </a:p>
+        </p:txBody>
+      </p:sp>
+      <p:sp>
+        <p:nvSpPr>
+          <p:cNvPr id="4" name="Text 1"/>
+          <p:cNvSpPr txBox="1"/>
+          <p:nvPr/>
+        </p:nvSpPr>
+        <p:spPr>
+          <a:xfrm>
+            <a:off x="6583680" y="658368"/>
+            <a:ext cx="5120640" cy="822960"/>
+          </a:xfrm>
+          <a:prstGeom prst="rect">
+            <a:avLst/>
+          </a:prstGeom>
+          <a:noFill/>
+          <a:ln/>
+        </p:spPr>
+        <p:txBody>
+          <a:bodyPr wrap="square" lIns="0" tIns="0" rIns="0" bIns="0" rtlCol="0" anchor="t"/>
+          <a:lstStyle/>
+          <a:p>
+            <a:pPr indent="0" marL="0">
+              <a:buNone/>
+            </a:pPr>
+            <a:r>
+              <a:rPr lang="en-US" sz="3000" b="1" dirty="0">
+                <a:solidFill>
+                  <a:srgbClr val="1F2A44"/>
+                </a:solidFill>
+                <a:latin typeface="Cambria" pitchFamily="34" charset="0"/>
+                <a:ea typeface="Cambria" pitchFamily="34" charset="-122"/>
+                <a:cs typeface="Cambria" pitchFamily="34" charset="-120"/>
+              </a:rPr>
+              <a:t>Membranes at 2000 µs</a:t>
+            </a:r>
+            <a:endParaRPr lang="en-US" sz="3000" dirty="0"/>
+          </a:p>
+        </p:txBody>
+      </p:sp>
+      <p:sp>
+        <p:nvSpPr>
+          <p:cNvPr id="5" name="Text 2"/>
+          <p:cNvSpPr txBox="1"/>
+          <p:nvPr/>
+        </p:nvSpPr>
+        <p:spPr>
+          <a:xfrm>
+            <a:off x="6583680" y="1508760"/>
+            <a:ext cx="5120640" cy="274320"/>
+          </a:xfrm>
+          <a:prstGeom prst="rect">
+            <a:avLst/>
+          </a:prstGeom>
+          <a:noFill/>
+          <a:ln/>
+        </p:spPr>
+        <p:txBody>
+          <a:bodyPr wrap="square" lIns="0" tIns="0" rIns="0" bIns="0" rtlCol="0" anchor="ctr"/>
+          <a:lstStyle/>
+          <a:p>
+            <a:pPr indent="0" marL="0">
+              <a:buNone/>
+            </a:pPr>
+            <a:r>
+              <a:rPr lang="en-US" sz="1200" dirty="0">
+                <a:solidFill>
+                  <a:srgbClr val="5B6578"/>
+                </a:solidFill>
+                <a:latin typeface="Calibri" pitchFamily="34" charset="0"/>
+                <a:ea typeface="Calibri" pitchFamily="34" charset="-122"/>
+                <a:cs typeface="Calibri" pitchFamily="34" charset="-120"/>
+              </a:rPr>
+              <a:t>Mean level. Round markers: 8 Oct. Square: 9 Oct.</a:t>
+            </a:r>
+            <a:endParaRPr lang="en-US" sz="1200" dirty="0"/>
+          </a:p>
+        </p:txBody>
+      </p:sp>
+      <p:sp>
+        <p:nvSpPr>
+          <p:cNvPr id="6" name="Shape 3"/>
+          <p:cNvSpPr/>
+          <p:nvPr/>
+        </p:nvSpPr>
+        <p:spPr>
+          <a:xfrm>
+            <a:off x="6583680" y="1938528"/>
+            <a:ext cx="182880" cy="182880"/>
+          </a:xfrm>
+          <a:prstGeom prst="ellipse">
+            <a:avLst/>
+          </a:prstGeom>
+          <a:solidFill>
+            <a:srgbClr val="E03131"/>
+          </a:solidFill>
+          <a:ln w="12700">
+            <a:solidFill>
+              <a:srgbClr val="E03131"/>
+            </a:solidFill>
+            <a:prstDash val="solid"/>
+          </a:ln>
+        </p:spPr>
+      </p:sp>
+      <p:sp>
+        <p:nvSpPr>
+          <p:cNvPr id="7" name="Text 4"/>
+          <p:cNvSpPr txBox="1"/>
+          <p:nvPr/>
+        </p:nvSpPr>
+        <p:spPr>
+          <a:xfrm>
+            <a:off x="6858000" y="1874520"/>
+            <a:ext cx="2834640" cy="310896"/>
+          </a:xfrm>
+          <a:prstGeom prst="rect">
+            <a:avLst/>
+          </a:prstGeom>
+          <a:noFill/>
+          <a:ln/>
+        </p:spPr>
+        <p:txBody>
+          <a:bodyPr wrap="square" lIns="0" tIns="0" rIns="0" bIns="0" rtlCol="0" anchor="ctr"/>
+          <a:lstStyle/>
+          <a:p>
+            <a:pPr indent="0" marL="0">
+              <a:buNone/>
+            </a:pPr>
+            <a:r>
+              <a:rPr lang="en-US" sz="1400" b="1" dirty="0">
+                <a:solidFill>
+                  <a:srgbClr val="1F2A44"/>
+                </a:solidFill>
+                <a:latin typeface="Calibri" pitchFamily="34" charset="0"/>
+                <a:ea typeface="Calibri" pitchFamily="34" charset="-122"/>
+                <a:cs typeface="Calibri" pitchFamily="34" charset="-120"/>
+              </a:rPr>
+              <a:t>Thinsulate, 4 layers</a:t>
+            </a:r>
+            <a:endParaRPr lang="en-US" sz="1400" dirty="0"/>
+          </a:p>
+        </p:txBody>
+      </p:sp>
+      <p:sp>
+        <p:nvSpPr>
+          <p:cNvPr id="8" name="Text 5"/>
+          <p:cNvSpPr txBox="1"/>
+          <p:nvPr/>
+        </p:nvSpPr>
+        <p:spPr>
+          <a:xfrm>
+            <a:off x="9692640" y="1874520"/>
+            <a:ext cx="640080" cy="310896"/>
+          </a:xfrm>
+          <a:prstGeom prst="rect">
+            <a:avLst/>
+          </a:prstGeom>
+          <a:noFill/>
+          <a:ln/>
+        </p:spPr>
+        <p:txBody>
+          <a:bodyPr wrap="square" lIns="0" tIns="0" rIns="0" bIns="0" rtlCol="0" anchor="ctr"/>
+          <a:lstStyle/>
+          <a:p>
+            <a:pPr indent="0" marL="0">
+              <a:buNone/>
+            </a:pPr>
+            <a:r>
+              <a:rPr lang="en-US" sz="1200" dirty="0">
+                <a:solidFill>
+                  <a:srgbClr val="5B6578"/>
+                </a:solidFill>
+                <a:latin typeface="Calibri" pitchFamily="34" charset="0"/>
+                <a:ea typeface="Calibri" pitchFamily="34" charset="-122"/>
+                <a:cs typeface="Calibri" pitchFamily="34" charset="-120"/>
+              </a:rPr>
+              <a:t>9 Oct</a:t>
+            </a:r>
+            <a:endParaRPr lang="en-US" sz="1200" dirty="0"/>
+          </a:p>
+        </p:txBody>
+      </p:sp>
+      <p:sp>
+        <p:nvSpPr>
+          <p:cNvPr id="9" name="Text 6"/>
+          <p:cNvSpPr txBox="1"/>
+          <p:nvPr/>
+        </p:nvSpPr>
+        <p:spPr>
+          <a:xfrm>
+            <a:off x="10241280" y="1874520"/>
+            <a:ext cx="1463040" cy="310896"/>
+          </a:xfrm>
+          <a:prstGeom prst="rect">
+            <a:avLst/>
+          </a:prstGeom>
+          <a:noFill/>
+          <a:ln/>
+        </p:spPr>
+        <p:txBody>
+          <a:bodyPr wrap="square" lIns="0" tIns="0" rIns="0" bIns="0" rtlCol="0" anchor="ctr"/>
+          <a:lstStyle/>
+          <a:p>
+            <a:pPr algn="r" indent="0" marL="0">
+              <a:buNone/>
+            </a:pPr>
+            <a:r>
+              <a:rPr lang="en-US" sz="1400" dirty="0">
+                <a:solidFill>
+                  <a:srgbClr val="1F2A44"/>
+                </a:solidFill>
+                <a:latin typeface="Calibri" pitchFamily="34" charset="0"/>
+                <a:ea typeface="Calibri" pitchFamily="34" charset="-122"/>
+                <a:cs typeface="Calibri" pitchFamily="34" charset="-120"/>
+              </a:rPr>
+              <a:t>82.8 dB</a:t>
+            </a:r>
+            <a:endParaRPr lang="en-US" sz="1400" dirty="0"/>
+          </a:p>
+        </p:txBody>
+      </p:sp>
+      <p:sp>
+        <p:nvSpPr>
+          <p:cNvPr id="10" name="Shape 7"/>
+          <p:cNvSpPr/>
+          <p:nvPr/>
+        </p:nvSpPr>
+        <p:spPr>
+          <a:xfrm>
+            <a:off x="6583680" y="2276856"/>
+            <a:ext cx="182880" cy="182880"/>
+          </a:xfrm>
+          <a:prstGeom prst="ellipse">
+            <a:avLst/>
+          </a:prstGeom>
+          <a:solidFill>
+            <a:srgbClr val="F08C00"/>
+          </a:solidFill>
+          <a:ln w="12700">
+            <a:solidFill>
+              <a:srgbClr val="F08C00"/>
+            </a:solidFill>
+            <a:prstDash val="solid"/>
+          </a:ln>
+        </p:spPr>
+      </p:sp>
+      <p:sp>
+        <p:nvSpPr>
+          <p:cNvPr id="11" name="Text 8"/>
+          <p:cNvSpPr txBox="1"/>
+          <p:nvPr/>
+        </p:nvSpPr>
+        <p:spPr>
+          <a:xfrm>
+            <a:off x="6858000" y="2212848"/>
+            <a:ext cx="2834640" cy="310896"/>
+          </a:xfrm>
+          <a:prstGeom prst="rect">
+            <a:avLst/>
+          </a:prstGeom>
+          <a:noFill/>
+          <a:ln/>
+        </p:spPr>
+        <p:txBody>
+          <a:bodyPr wrap="square" lIns="0" tIns="0" rIns="0" bIns="0" rtlCol="0" anchor="ctr"/>
+          <a:lstStyle/>
+          <a:p>
+            <a:pPr indent="0" marL="0">
+              <a:buNone/>
+            </a:pPr>
+            <a:r>
+              <a:rPr lang="en-US" sz="1400" b="1" dirty="0">
+                <a:solidFill>
+                  <a:srgbClr val="1F2A44"/>
+                </a:solidFill>
+                <a:latin typeface="Calibri" pitchFamily="34" charset="0"/>
+                <a:ea typeface="Calibri" pitchFamily="34" charset="-122"/>
+                <a:cs typeface="Calibri" pitchFamily="34" charset="-120"/>
+              </a:rPr>
+              <a:t>Thinsulate, 2 layers</a:t>
+            </a:r>
+            <a:endParaRPr lang="en-US" sz="1400" dirty="0"/>
+          </a:p>
+        </p:txBody>
+      </p:sp>
+      <p:sp>
+        <p:nvSpPr>
+          <p:cNvPr id="12" name="Text 9"/>
+          <p:cNvSpPr txBox="1"/>
+          <p:nvPr/>
+        </p:nvSpPr>
+        <p:spPr>
+          <a:xfrm>
+            <a:off x="9692640" y="2212848"/>
+            <a:ext cx="640080" cy="310896"/>
+          </a:xfrm>
+          <a:prstGeom prst="rect">
+            <a:avLst/>
+          </a:prstGeom>
+          <a:noFill/>
+          <a:ln/>
+        </p:spPr>
+        <p:txBody>
+          <a:bodyPr wrap="square" lIns="0" tIns="0" rIns="0" bIns="0" rtlCol="0" anchor="ctr"/>
+          <a:lstStyle/>
+          <a:p>
+            <a:pPr indent="0" marL="0">
+              <a:buNone/>
+            </a:pPr>
+            <a:r>
+              <a:rPr lang="en-US" sz="1200" dirty="0">
+                <a:solidFill>
+                  <a:srgbClr val="5B6578"/>
+                </a:solidFill>
+                <a:latin typeface="Calibri" pitchFamily="34" charset="0"/>
+                <a:ea typeface="Calibri" pitchFamily="34" charset="-122"/>
+                <a:cs typeface="Calibri" pitchFamily="34" charset="-120"/>
+              </a:rPr>
+              <a:t>9 Oct</a:t>
+            </a:r>
+            <a:endParaRPr lang="en-US" sz="1200" dirty="0"/>
+          </a:p>
+        </p:txBody>
+      </p:sp>
+      <p:sp>
+        <p:nvSpPr>
+          <p:cNvPr id="13" name="Text 10"/>
+          <p:cNvSpPr txBox="1"/>
+          <p:nvPr/>
+        </p:nvSpPr>
+        <p:spPr>
+          <a:xfrm>
+            <a:off x="10241280" y="2212848"/>
+            <a:ext cx="1463040" cy="310896"/>
+          </a:xfrm>
+          <a:prstGeom prst="rect">
+            <a:avLst/>
+          </a:prstGeom>
+          <a:noFill/>
+          <a:ln/>
+        </p:spPr>
+        <p:txBody>
+          <a:bodyPr wrap="square" lIns="0" tIns="0" rIns="0" bIns="0" rtlCol="0" anchor="ctr"/>
+          <a:lstStyle/>
+          <a:p>
+            <a:pPr algn="r" indent="0" marL="0">
+              <a:buNone/>
+            </a:pPr>
+            <a:r>
+              <a:rPr lang="en-US" sz="1400" dirty="0">
+                <a:solidFill>
+                  <a:srgbClr val="1F2A44"/>
+                </a:solidFill>
+                <a:latin typeface="Calibri" pitchFamily="34" charset="0"/>
+                <a:ea typeface="Calibri" pitchFamily="34" charset="-122"/>
+                <a:cs typeface="Calibri" pitchFamily="34" charset="-120"/>
+              </a:rPr>
+              <a:t>84.0 dB</a:t>
+            </a:r>
+            <a:endParaRPr lang="en-US" sz="1400" dirty="0"/>
+          </a:p>
+        </p:txBody>
+      </p:sp>
+      <p:sp>
+        <p:nvSpPr>
+          <p:cNvPr id="14" name="Shape 11"/>
+          <p:cNvSpPr/>
+          <p:nvPr/>
+        </p:nvSpPr>
+        <p:spPr>
+          <a:xfrm>
+            <a:off x="6583680" y="2615184"/>
+            <a:ext cx="182880" cy="182880"/>
+          </a:xfrm>
+          <a:prstGeom prst="ellipse">
+            <a:avLst/>
+          </a:prstGeom>
+          <a:solidFill>
+            <a:srgbClr val="C2255C"/>
+          </a:solidFill>
+          <a:ln w="12700">
+            <a:solidFill>
+              <a:srgbClr val="C2255C"/>
+            </a:solidFill>
+            <a:prstDash val="solid"/>
+          </a:ln>
+        </p:spPr>
+      </p:sp>
+      <p:sp>
+        <p:nvSpPr>
+          <p:cNvPr id="15" name="Text 12"/>
+          <p:cNvSpPr txBox="1"/>
+          <p:nvPr/>
+        </p:nvSpPr>
+        <p:spPr>
+          <a:xfrm>
+            <a:off x="6858000" y="2551176"/>
+            <a:ext cx="2834640" cy="310896"/>
+          </a:xfrm>
+          <a:prstGeom prst="rect">
+            <a:avLst/>
+          </a:prstGeom>
+          <a:noFill/>
+          <a:ln/>
+        </p:spPr>
+        <p:txBody>
+          <a:bodyPr wrap="square" lIns="0" tIns="0" rIns="0" bIns="0" rtlCol="0" anchor="ctr"/>
+          <a:lstStyle/>
+          <a:p>
+            <a:pPr indent="0" marL="0">
+              <a:buNone/>
+            </a:pPr>
+            <a:r>
+              <a:rPr lang="en-US" sz="1400" b="1" dirty="0">
+                <a:solidFill>
+                  <a:srgbClr val="1F2A44"/>
+                </a:solidFill>
+                <a:latin typeface="Calibri" pitchFamily="34" charset="0"/>
+                <a:ea typeface="Calibri" pitchFamily="34" charset="-122"/>
+                <a:cs typeface="Calibri" pitchFamily="34" charset="-120"/>
+              </a:rPr>
+              <a:t>Thinsulate, 8 layers</a:t>
+            </a:r>
+            <a:endParaRPr lang="en-US" sz="1400" dirty="0"/>
+          </a:p>
+        </p:txBody>
+      </p:sp>
+      <p:sp>
+        <p:nvSpPr>
+          <p:cNvPr id="16" name="Text 13"/>
+          <p:cNvSpPr txBox="1"/>
+          <p:nvPr/>
+        </p:nvSpPr>
+        <p:spPr>
+          <a:xfrm>
+            <a:off x="9692640" y="2551176"/>
+            <a:ext cx="640080" cy="310896"/>
+          </a:xfrm>
+          <a:prstGeom prst="rect">
+            <a:avLst/>
+          </a:prstGeom>
+          <a:noFill/>
+          <a:ln/>
+        </p:spPr>
+        <p:txBody>
+          <a:bodyPr wrap="square" lIns="0" tIns="0" rIns="0" bIns="0" rtlCol="0" anchor="ctr"/>
+          <a:lstStyle/>
+          <a:p>
+            <a:pPr indent="0" marL="0">
+              <a:buNone/>
+            </a:pPr>
+            <a:r>
+              <a:rPr lang="en-US" sz="1200" dirty="0">
+                <a:solidFill>
+                  <a:srgbClr val="5B6578"/>
+                </a:solidFill>
+                <a:latin typeface="Calibri" pitchFamily="34" charset="0"/>
+                <a:ea typeface="Calibri" pitchFamily="34" charset="-122"/>
+                <a:cs typeface="Calibri" pitchFamily="34" charset="-120"/>
+              </a:rPr>
+              <a:t>9 Oct</a:t>
+            </a:r>
+            <a:endParaRPr lang="en-US" sz="1200" dirty="0"/>
+          </a:p>
+        </p:txBody>
+      </p:sp>
+      <p:sp>
+        <p:nvSpPr>
+          <p:cNvPr id="17" name="Text 14"/>
+          <p:cNvSpPr txBox="1"/>
+          <p:nvPr/>
+        </p:nvSpPr>
+        <p:spPr>
+          <a:xfrm>
+            <a:off x="10241280" y="2551176"/>
+            <a:ext cx="1463040" cy="310896"/>
+          </a:xfrm>
+          <a:prstGeom prst="rect">
+            <a:avLst/>
+          </a:prstGeom>
+          <a:noFill/>
+          <a:ln/>
+        </p:spPr>
+        <p:txBody>
+          <a:bodyPr wrap="square" lIns="0" tIns="0" rIns="0" bIns="0" rtlCol="0" anchor="ctr"/>
+          <a:lstStyle/>
+          <a:p>
+            <a:pPr algn="r" indent="0" marL="0">
+              <a:buNone/>
+            </a:pPr>
+            <a:r>
+              <a:rPr lang="en-US" sz="1400" dirty="0">
+                <a:solidFill>
+                  <a:srgbClr val="1F2A44"/>
+                </a:solidFill>
+                <a:latin typeface="Calibri" pitchFamily="34" charset="0"/>
+                <a:ea typeface="Calibri" pitchFamily="34" charset="-122"/>
+                <a:cs typeface="Calibri" pitchFamily="34" charset="-120"/>
+              </a:rPr>
+              <a:t>85.0 dB</a:t>
+            </a:r>
+            <a:endParaRPr lang="en-US" sz="1400" dirty="0"/>
+          </a:p>
+        </p:txBody>
+      </p:sp>
+      <p:sp>
+        <p:nvSpPr>
+          <p:cNvPr id="18" name="Shape 15"/>
+          <p:cNvSpPr/>
+          <p:nvPr/>
+        </p:nvSpPr>
+        <p:spPr>
+          <a:xfrm>
+            <a:off x="6583680" y="2953512"/>
+            <a:ext cx="182880" cy="182880"/>
+          </a:xfrm>
+          <a:prstGeom prst="ellipse">
+            <a:avLst/>
+          </a:prstGeom>
+          <a:solidFill>
+            <a:srgbClr val="7048E8"/>
+          </a:solidFill>
+          <a:ln w="12700">
+            <a:solidFill>
+              <a:srgbClr val="7048E8"/>
+            </a:solidFill>
+            <a:prstDash val="solid"/>
+          </a:ln>
+        </p:spPr>
+      </p:sp>
+      <p:sp>
+        <p:nvSpPr>
+          <p:cNvPr id="19" name="Text 16"/>
+          <p:cNvSpPr txBox="1"/>
+          <p:nvPr/>
+        </p:nvSpPr>
+        <p:spPr>
+          <a:xfrm>
+            <a:off x="6858000" y="2889504"/>
+            <a:ext cx="2834640" cy="310896"/>
+          </a:xfrm>
+          <a:prstGeom prst="rect">
+            <a:avLst/>
+          </a:prstGeom>
+          <a:noFill/>
+          <a:ln/>
+        </p:spPr>
+        <p:txBody>
+          <a:bodyPr wrap="square" lIns="0" tIns="0" rIns="0" bIns="0" rtlCol="0" anchor="ctr"/>
+          <a:lstStyle/>
+          <a:p>
+            <a:pPr indent="0" marL="0">
+              <a:buNone/>
+            </a:pPr>
+            <a:r>
+              <a:rPr lang="en-US" sz="1400" b="1" dirty="0">
+                <a:solidFill>
+                  <a:srgbClr val="1F2A44"/>
+                </a:solidFill>
+                <a:latin typeface="Calibri" pitchFamily="34" charset="0"/>
+                <a:ea typeface="Calibri" pitchFamily="34" charset="-122"/>
+                <a:cs typeface="Calibri" pitchFamily="34" charset="-120"/>
+              </a:rPr>
+              <a:t>Felt + rubber</a:t>
+            </a:r>
+            <a:endParaRPr lang="en-US" sz="1400" dirty="0"/>
+          </a:p>
+        </p:txBody>
+      </p:sp>
+      <p:sp>
+        <p:nvSpPr>
+          <p:cNvPr id="20" name="Text 17"/>
+          <p:cNvSpPr txBox="1"/>
+          <p:nvPr/>
+        </p:nvSpPr>
+        <p:spPr>
+          <a:xfrm>
+            <a:off x="9692640" y="2889504"/>
+            <a:ext cx="640080" cy="310896"/>
+          </a:xfrm>
+          <a:prstGeom prst="rect">
+            <a:avLst/>
+          </a:prstGeom>
+          <a:noFill/>
+          <a:ln/>
+        </p:spPr>
+        <p:txBody>
+          <a:bodyPr wrap="square" lIns="0" tIns="0" rIns="0" bIns="0" rtlCol="0" anchor="ctr"/>
+          <a:lstStyle/>
+          <a:p>
+            <a:pPr indent="0" marL="0">
+              <a:buNone/>
+            </a:pPr>
+            <a:r>
+              <a:rPr lang="en-US" sz="1200" dirty="0">
+                <a:solidFill>
+                  <a:srgbClr val="5B6578"/>
+                </a:solidFill>
+                <a:latin typeface="Calibri" pitchFamily="34" charset="0"/>
+                <a:ea typeface="Calibri" pitchFamily="34" charset="-122"/>
+                <a:cs typeface="Calibri" pitchFamily="34" charset="-120"/>
+              </a:rPr>
+              <a:t>9 Oct</a:t>
+            </a:r>
+            <a:endParaRPr lang="en-US" sz="1200" dirty="0"/>
+          </a:p>
+        </p:txBody>
+      </p:sp>
+      <p:sp>
+        <p:nvSpPr>
+          <p:cNvPr id="21" name="Text 18"/>
+          <p:cNvSpPr txBox="1"/>
+          <p:nvPr/>
+        </p:nvSpPr>
+        <p:spPr>
+          <a:xfrm>
+            <a:off x="10241280" y="2889504"/>
+            <a:ext cx="1463040" cy="310896"/>
+          </a:xfrm>
+          <a:prstGeom prst="rect">
+            <a:avLst/>
+          </a:prstGeom>
+          <a:noFill/>
+          <a:ln/>
+        </p:spPr>
+        <p:txBody>
+          <a:bodyPr wrap="square" lIns="0" tIns="0" rIns="0" bIns="0" rtlCol="0" anchor="ctr"/>
+          <a:lstStyle/>
+          <a:p>
+            <a:pPr algn="r" indent="0" marL="0">
+              <a:buNone/>
+            </a:pPr>
+            <a:r>
+              <a:rPr lang="en-US" sz="1400" dirty="0">
+                <a:solidFill>
+                  <a:srgbClr val="1F2A44"/>
+                </a:solidFill>
+                <a:latin typeface="Calibri" pitchFamily="34" charset="0"/>
+                <a:ea typeface="Calibri" pitchFamily="34" charset="-122"/>
+                <a:cs typeface="Calibri" pitchFamily="34" charset="-120"/>
+              </a:rPr>
+              <a:t>86.0 dB</a:t>
+            </a:r>
+            <a:endParaRPr lang="en-US" sz="1400" dirty="0"/>
+          </a:p>
+        </p:txBody>
+      </p:sp>
+      <p:sp>
+        <p:nvSpPr>
+          <p:cNvPr id="22" name="Shape 19"/>
+          <p:cNvSpPr/>
+          <p:nvPr/>
+        </p:nvSpPr>
+        <p:spPr>
+          <a:xfrm>
+            <a:off x="6583680" y="3291840"/>
+            <a:ext cx="182880" cy="182880"/>
+          </a:xfrm>
+          <a:prstGeom prst="ellipse">
+            <a:avLst/>
+          </a:prstGeom>
+          <a:solidFill>
+            <a:srgbClr val="1098AD"/>
+          </a:solidFill>
+          <a:ln w="12700">
+            <a:solidFill>
+              <a:srgbClr val="1098AD"/>
+            </a:solidFill>
+            <a:prstDash val="solid"/>
+          </a:ln>
+        </p:spPr>
+      </p:sp>
+      <p:sp>
+        <p:nvSpPr>
+          <p:cNvPr id="23" name="Text 20"/>
+          <p:cNvSpPr txBox="1"/>
+          <p:nvPr/>
+        </p:nvSpPr>
+        <p:spPr>
+          <a:xfrm>
+            <a:off x="6858000" y="3227832"/>
+            <a:ext cx="2834640" cy="310896"/>
+          </a:xfrm>
+          <a:prstGeom prst="rect">
+            <a:avLst/>
+          </a:prstGeom>
+          <a:noFill/>
+          <a:ln/>
+        </p:spPr>
+        <p:txBody>
+          <a:bodyPr wrap="square" lIns="0" tIns="0" rIns="0" bIns="0" rtlCol="0" anchor="ctr"/>
+          <a:lstStyle/>
+          <a:p>
+            <a:pPr indent="0" marL="0">
+              <a:buNone/>
+            </a:pPr>
+            <a:r>
+              <a:rPr lang="en-US" sz="1400" b="1" dirty="0">
+                <a:solidFill>
+                  <a:srgbClr val="1F2A44"/>
+                </a:solidFill>
+                <a:latin typeface="Calibri" pitchFamily="34" charset="0"/>
+                <a:ea typeface="Calibri" pitchFamily="34" charset="-122"/>
+                <a:cs typeface="Calibri" pitchFamily="34" charset="-120"/>
+              </a:rPr>
+              <a:t>Felt</a:t>
+            </a:r>
+            <a:endParaRPr lang="en-US" sz="1400" dirty="0"/>
+          </a:p>
+        </p:txBody>
+      </p:sp>
+      <p:sp>
+        <p:nvSpPr>
+          <p:cNvPr id="24" name="Text 21"/>
+          <p:cNvSpPr txBox="1"/>
+          <p:nvPr/>
+        </p:nvSpPr>
+        <p:spPr>
+          <a:xfrm>
+            <a:off x="9692640" y="3227832"/>
+            <a:ext cx="640080" cy="310896"/>
+          </a:xfrm>
+          <a:prstGeom prst="rect">
+            <a:avLst/>
+          </a:prstGeom>
+          <a:noFill/>
+          <a:ln/>
+        </p:spPr>
+        <p:txBody>
+          <a:bodyPr wrap="square" lIns="0" tIns="0" rIns="0" bIns="0" rtlCol="0" anchor="ctr"/>
+          <a:lstStyle/>
+          <a:p>
+            <a:pPr indent="0" marL="0">
+              <a:buNone/>
+            </a:pPr>
+            <a:r>
+              <a:rPr lang="en-US" sz="1200" dirty="0">
+                <a:solidFill>
+                  <a:srgbClr val="5B6578"/>
+                </a:solidFill>
+                <a:latin typeface="Calibri" pitchFamily="34" charset="0"/>
+                <a:ea typeface="Calibri" pitchFamily="34" charset="-122"/>
+                <a:cs typeface="Calibri" pitchFamily="34" charset="-120"/>
+              </a:rPr>
+              <a:t>9 Oct</a:t>
+            </a:r>
+            <a:endParaRPr lang="en-US" sz="1200" dirty="0"/>
+          </a:p>
+        </p:txBody>
+      </p:sp>
+      <p:sp>
+        <p:nvSpPr>
+          <p:cNvPr id="25" name="Text 22"/>
+          <p:cNvSpPr txBox="1"/>
+          <p:nvPr/>
+        </p:nvSpPr>
+        <p:spPr>
+          <a:xfrm>
+            <a:off x="10241280" y="3227832"/>
+            <a:ext cx="1463040" cy="310896"/>
+          </a:xfrm>
+          <a:prstGeom prst="rect">
+            <a:avLst/>
+          </a:prstGeom>
+          <a:noFill/>
+          <a:ln/>
+        </p:spPr>
+        <p:txBody>
+          <a:bodyPr wrap="square" lIns="0" tIns="0" rIns="0" bIns="0" rtlCol="0" anchor="ctr"/>
+          <a:lstStyle/>
+          <a:p>
+            <a:pPr algn="r" indent="0" marL="0">
+              <a:buNone/>
+            </a:pPr>
+            <a:r>
+              <a:rPr lang="en-US" sz="1400" dirty="0">
+                <a:solidFill>
+                  <a:srgbClr val="1F2A44"/>
+                </a:solidFill>
+                <a:latin typeface="Calibri" pitchFamily="34" charset="0"/>
+                <a:ea typeface="Calibri" pitchFamily="34" charset="-122"/>
+                <a:cs typeface="Calibri" pitchFamily="34" charset="-120"/>
+              </a:rPr>
+              <a:t>86.3 dB</a:t>
+            </a:r>
+            <a:endParaRPr lang="en-US" sz="1400" dirty="0"/>
+          </a:p>
+        </p:txBody>
+      </p:sp>
+      <p:sp>
+        <p:nvSpPr>
+          <p:cNvPr id="26" name="Shape 23"/>
+          <p:cNvSpPr/>
+          <p:nvPr/>
+        </p:nvSpPr>
+        <p:spPr>
+          <a:xfrm>
+            <a:off x="6583680" y="3630168"/>
+            <a:ext cx="182880" cy="182880"/>
+          </a:xfrm>
+          <a:prstGeom prst="ellipse">
+            <a:avLst/>
+          </a:prstGeom>
+          <a:solidFill>
+            <a:srgbClr val="1864AB"/>
+          </a:solidFill>
+          <a:ln w="12700">
+            <a:solidFill>
+              <a:srgbClr val="1864AB"/>
+            </a:solidFill>
+            <a:prstDash val="solid"/>
+          </a:ln>
+        </p:spPr>
+      </p:sp>
+      <p:sp>
+        <p:nvSpPr>
+          <p:cNvPr id="27" name="Text 24"/>
+          <p:cNvSpPr txBox="1"/>
+          <p:nvPr/>
+        </p:nvSpPr>
+        <p:spPr>
+          <a:xfrm>
+            <a:off x="6858000" y="3566160"/>
+            <a:ext cx="2834640" cy="310896"/>
+          </a:xfrm>
+          <a:prstGeom prst="rect">
+            <a:avLst/>
+          </a:prstGeom>
+          <a:noFill/>
+          <a:ln/>
+        </p:spPr>
+        <p:txBody>
+          <a:bodyPr wrap="square" lIns="0" tIns="0" rIns="0" bIns="0" rtlCol="0" anchor="ctr"/>
+          <a:lstStyle/>
+          <a:p>
+            <a:pPr indent="0" marL="0">
+              <a:buNone/>
+            </a:pPr>
+            <a:r>
+              <a:rPr lang="en-US" sz="1400" b="1" dirty="0">
+                <a:solidFill>
+                  <a:srgbClr val="1F2A44"/>
+                </a:solidFill>
+                <a:latin typeface="Calibri" pitchFamily="34" charset="0"/>
+                <a:ea typeface="Calibri" pitchFamily="34" charset="-122"/>
+                <a:cs typeface="Calibri" pitchFamily="34" charset="-120"/>
+              </a:rPr>
+              <a:t>Felt, double layer</a:t>
+            </a:r>
+            <a:endParaRPr lang="en-US" sz="1400" dirty="0"/>
+          </a:p>
+        </p:txBody>
+      </p:sp>
+      <p:sp>
+        <p:nvSpPr>
+          <p:cNvPr id="28" name="Text 25"/>
+          <p:cNvSpPr txBox="1"/>
+          <p:nvPr/>
+        </p:nvSpPr>
+        <p:spPr>
+          <a:xfrm>
+            <a:off x="9692640" y="3566160"/>
+            <a:ext cx="640080" cy="310896"/>
+          </a:xfrm>
+          <a:prstGeom prst="rect">
+            <a:avLst/>
+          </a:prstGeom>
+          <a:noFill/>
+          <a:ln/>
+        </p:spPr>
+        <p:txBody>
+          <a:bodyPr wrap="square" lIns="0" tIns="0" rIns="0" bIns="0" rtlCol="0" anchor="ctr"/>
+          <a:lstStyle/>
+          <a:p>
+            <a:pPr indent="0" marL="0">
+              <a:buNone/>
+            </a:pPr>
+            <a:r>
+              <a:rPr lang="en-US" sz="1200" dirty="0">
+                <a:solidFill>
+                  <a:srgbClr val="5B6578"/>
+                </a:solidFill>
+                <a:latin typeface="Calibri" pitchFamily="34" charset="0"/>
+                <a:ea typeface="Calibri" pitchFamily="34" charset="-122"/>
+                <a:cs typeface="Calibri" pitchFamily="34" charset="-120"/>
+              </a:rPr>
+              <a:t>9 Oct</a:t>
+            </a:r>
+            <a:endParaRPr lang="en-US" sz="1200" dirty="0"/>
+          </a:p>
+        </p:txBody>
+      </p:sp>
+      <p:sp>
+        <p:nvSpPr>
+          <p:cNvPr id="29" name="Text 26"/>
+          <p:cNvSpPr txBox="1"/>
+          <p:nvPr/>
+        </p:nvSpPr>
+        <p:spPr>
+          <a:xfrm>
+            <a:off x="10241280" y="3566160"/>
+            <a:ext cx="1463040" cy="310896"/>
+          </a:xfrm>
+          <a:prstGeom prst="rect">
+            <a:avLst/>
+          </a:prstGeom>
+          <a:noFill/>
+          <a:ln/>
+        </p:spPr>
+        <p:txBody>
+          <a:bodyPr wrap="square" lIns="0" tIns="0" rIns="0" bIns="0" rtlCol="0" anchor="ctr"/>
+          <a:lstStyle/>
+          <a:p>
+            <a:pPr algn="r" indent="0" marL="0">
+              <a:buNone/>
+            </a:pPr>
+            <a:r>
+              <a:rPr lang="en-US" sz="1400" dirty="0">
+                <a:solidFill>
+                  <a:srgbClr val="1F2A44"/>
+                </a:solidFill>
+                <a:latin typeface="Calibri" pitchFamily="34" charset="0"/>
+                <a:ea typeface="Calibri" pitchFamily="34" charset="-122"/>
+                <a:cs typeface="Calibri" pitchFamily="34" charset="-120"/>
+              </a:rPr>
+              <a:t>86.4 dB</a:t>
+            </a:r>
+            <a:endParaRPr lang="en-US" sz="1400" dirty="0"/>
+          </a:p>
+        </p:txBody>
+      </p:sp>
+      <p:sp>
+        <p:nvSpPr>
+          <p:cNvPr id="30" name="Shape 27"/>
+          <p:cNvSpPr/>
+          <p:nvPr/>
+        </p:nvSpPr>
+        <p:spPr>
+          <a:xfrm>
+            <a:off x="6583680" y="3968496"/>
+            <a:ext cx="182880" cy="182880"/>
+          </a:xfrm>
+          <a:prstGeom prst="ellipse">
+            <a:avLst/>
+          </a:prstGeom>
+          <a:solidFill>
+            <a:srgbClr val="5C940D"/>
+          </a:solidFill>
+          <a:ln w="12700">
+            <a:solidFill>
+              <a:srgbClr val="5C940D"/>
+            </a:solidFill>
+            <a:prstDash val="solid"/>
+          </a:ln>
+        </p:spPr>
+      </p:sp>
+      <p:sp>
+        <p:nvSpPr>
+          <p:cNvPr id="31" name="Text 28"/>
+          <p:cNvSpPr txBox="1"/>
+          <p:nvPr/>
+        </p:nvSpPr>
+        <p:spPr>
+          <a:xfrm>
+            <a:off x="6858000" y="3904488"/>
+            <a:ext cx="2834640" cy="310896"/>
+          </a:xfrm>
+          <a:prstGeom prst="rect">
+            <a:avLst/>
+          </a:prstGeom>
+          <a:noFill/>
+          <a:ln/>
+        </p:spPr>
+        <p:txBody>
+          <a:bodyPr wrap="square" lIns="0" tIns="0" rIns="0" bIns="0" rtlCol="0" anchor="ctr"/>
+          <a:lstStyle/>
+          <a:p>
+            <a:pPr indent="0" marL="0">
+              <a:buNone/>
+            </a:pPr>
+            <a:r>
+              <a:rPr lang="en-US" sz="1400" b="1" dirty="0">
+                <a:solidFill>
+                  <a:srgbClr val="1F2A44"/>
+                </a:solidFill>
+                <a:latin typeface="Calibri" pitchFamily="34" charset="0"/>
+                <a:ea typeface="Calibri" pitchFamily="34" charset="-122"/>
+                <a:cs typeface="Calibri" pitchFamily="34" charset="-120"/>
+              </a:rPr>
+              <a:t>Duct + PU foam, double</a:t>
+            </a:r>
+            <a:endParaRPr lang="en-US" sz="1400" dirty="0"/>
+          </a:p>
+        </p:txBody>
+      </p:sp>
+      <p:sp>
+        <p:nvSpPr>
+          <p:cNvPr id="32" name="Text 29"/>
+          <p:cNvSpPr txBox="1"/>
+          <p:nvPr/>
+        </p:nvSpPr>
+        <p:spPr>
+          <a:xfrm>
+            <a:off x="9692640" y="3904488"/>
+            <a:ext cx="640080" cy="310896"/>
+          </a:xfrm>
+          <a:prstGeom prst="rect">
+            <a:avLst/>
+          </a:prstGeom>
+          <a:noFill/>
+          <a:ln/>
+        </p:spPr>
+        <p:txBody>
+          <a:bodyPr wrap="square" lIns="0" tIns="0" rIns="0" bIns="0" rtlCol="0" anchor="ctr"/>
+          <a:lstStyle/>
+          <a:p>
+            <a:pPr indent="0" marL="0">
+              <a:buNone/>
+            </a:pPr>
+            <a:r>
+              <a:rPr lang="en-US" sz="1200" dirty="0">
+                <a:solidFill>
+                  <a:srgbClr val="5B6578"/>
+                </a:solidFill>
+                <a:latin typeface="Calibri" pitchFamily="34" charset="0"/>
+                <a:ea typeface="Calibri" pitchFamily="34" charset="-122"/>
+                <a:cs typeface="Calibri" pitchFamily="34" charset="-120"/>
+              </a:rPr>
+              <a:t>9 Oct</a:t>
+            </a:r>
+            <a:endParaRPr lang="en-US" sz="1200" dirty="0"/>
+          </a:p>
+        </p:txBody>
+      </p:sp>
+      <p:sp>
+        <p:nvSpPr>
+          <p:cNvPr id="33" name="Text 30"/>
+          <p:cNvSpPr txBox="1"/>
+          <p:nvPr/>
+        </p:nvSpPr>
+        <p:spPr>
+          <a:xfrm>
+            <a:off x="10241280" y="3904488"/>
+            <a:ext cx="1463040" cy="310896"/>
+          </a:xfrm>
+          <a:prstGeom prst="rect">
+            <a:avLst/>
+          </a:prstGeom>
+          <a:noFill/>
+          <a:ln/>
+        </p:spPr>
+        <p:txBody>
+          <a:bodyPr wrap="square" lIns="0" tIns="0" rIns="0" bIns="0" rtlCol="0" anchor="ctr"/>
+          <a:lstStyle/>
+          <a:p>
+            <a:pPr algn="r" indent="0" marL="0">
+              <a:buNone/>
+            </a:pPr>
+            <a:r>
+              <a:rPr lang="en-US" sz="1400" dirty="0">
+                <a:solidFill>
+                  <a:srgbClr val="1F2A44"/>
+                </a:solidFill>
+                <a:latin typeface="Calibri" pitchFamily="34" charset="0"/>
+                <a:ea typeface="Calibri" pitchFamily="34" charset="-122"/>
+                <a:cs typeface="Calibri" pitchFamily="34" charset="-120"/>
+              </a:rPr>
+              <a:t>87.5 dB</a:t>
+            </a:r>
+            <a:endParaRPr lang="en-US" sz="1400" dirty="0"/>
+          </a:p>
+        </p:txBody>
+      </p:sp>
+      <p:sp>
+        <p:nvSpPr>
+          <p:cNvPr id="34" name="Shape 31"/>
+          <p:cNvSpPr/>
+          <p:nvPr/>
+        </p:nvSpPr>
+        <p:spPr>
+          <a:xfrm>
+            <a:off x="6583680" y="4306824"/>
+            <a:ext cx="182880" cy="182880"/>
+          </a:xfrm>
+          <a:prstGeom prst="ellipse">
+            <a:avLst/>
+          </a:prstGeom>
+          <a:solidFill>
+            <a:srgbClr val="862E9C"/>
+          </a:solidFill>
+          <a:ln w="12700">
+            <a:solidFill>
+              <a:srgbClr val="862E9C"/>
+            </a:solidFill>
+            <a:prstDash val="solid"/>
+          </a:ln>
+        </p:spPr>
+      </p:sp>
+      <p:sp>
+        <p:nvSpPr>
+          <p:cNvPr id="35" name="Text 32"/>
+          <p:cNvSpPr txBox="1"/>
+          <p:nvPr/>
+        </p:nvSpPr>
+        <p:spPr>
+          <a:xfrm>
+            <a:off x="6858000" y="4242816"/>
+            <a:ext cx="2834640" cy="310896"/>
+          </a:xfrm>
+          <a:prstGeom prst="rect">
+            <a:avLst/>
+          </a:prstGeom>
+          <a:noFill/>
+          <a:ln/>
+        </p:spPr>
+        <p:txBody>
+          <a:bodyPr wrap="square" lIns="0" tIns="0" rIns="0" bIns="0" rtlCol="0" anchor="ctr"/>
+          <a:lstStyle/>
+          <a:p>
+            <a:pPr indent="0" marL="0">
+              <a:buNone/>
+            </a:pPr>
+            <a:r>
+              <a:rPr lang="en-US" sz="1400" b="1" dirty="0">
+                <a:solidFill>
+                  <a:srgbClr val="1F2A44"/>
+                </a:solidFill>
+                <a:latin typeface="Calibri" pitchFamily="34" charset="0"/>
+                <a:ea typeface="Calibri" pitchFamily="34" charset="-122"/>
+                <a:cs typeface="Calibri" pitchFamily="34" charset="-120"/>
+              </a:rPr>
+              <a:t>PU foam</a:t>
+            </a:r>
+            <a:endParaRPr lang="en-US" sz="1400" dirty="0"/>
+          </a:p>
+        </p:txBody>
+      </p:sp>
+      <p:sp>
+        <p:nvSpPr>
+          <p:cNvPr id="36" name="Text 33"/>
+          <p:cNvSpPr txBox="1"/>
+          <p:nvPr/>
+        </p:nvSpPr>
+        <p:spPr>
+          <a:xfrm>
+            <a:off x="9692640" y="4242816"/>
+            <a:ext cx="640080" cy="310896"/>
+          </a:xfrm>
+          <a:prstGeom prst="rect">
+            <a:avLst/>
+          </a:prstGeom>
+          <a:noFill/>
+          <a:ln/>
+        </p:spPr>
+        <p:txBody>
+          <a:bodyPr wrap="square" lIns="0" tIns="0" rIns="0" bIns="0" rtlCol="0" anchor="ctr"/>
+          <a:lstStyle/>
+          <a:p>
+            <a:pPr indent="0" marL="0">
+              <a:buNone/>
+            </a:pPr>
+            <a:r>
+              <a:rPr lang="en-US" sz="1200" dirty="0">
+                <a:solidFill>
+                  <a:srgbClr val="5B6578"/>
+                </a:solidFill>
+                <a:latin typeface="Calibri" pitchFamily="34" charset="0"/>
+                <a:ea typeface="Calibri" pitchFamily="34" charset="-122"/>
+                <a:cs typeface="Calibri" pitchFamily="34" charset="-120"/>
+              </a:rPr>
+              <a:t>8 Oct</a:t>
+            </a:r>
+            <a:endParaRPr lang="en-US" sz="1200" dirty="0"/>
+          </a:p>
+        </p:txBody>
+      </p:sp>
+      <p:sp>
+        <p:nvSpPr>
+          <p:cNvPr id="37" name="Text 34"/>
+          <p:cNvSpPr txBox="1"/>
+          <p:nvPr/>
+        </p:nvSpPr>
+        <p:spPr>
+          <a:xfrm>
+            <a:off x="10241280" y="4242816"/>
+            <a:ext cx="1463040" cy="310896"/>
+          </a:xfrm>
+          <a:prstGeom prst="rect">
+            <a:avLst/>
+          </a:prstGeom>
+          <a:noFill/>
+          <a:ln/>
+        </p:spPr>
+        <p:txBody>
+          <a:bodyPr wrap="square" lIns="0" tIns="0" rIns="0" bIns="0" rtlCol="0" anchor="ctr"/>
+          <a:lstStyle/>
+          <a:p>
+            <a:pPr algn="r" indent="0" marL="0">
+              <a:buNone/>
+            </a:pPr>
+            <a:r>
+              <a:rPr lang="en-US" sz="1400" dirty="0">
+                <a:solidFill>
+                  <a:srgbClr val="1F2A44"/>
+                </a:solidFill>
+                <a:latin typeface="Calibri" pitchFamily="34" charset="0"/>
+                <a:ea typeface="Calibri" pitchFamily="34" charset="-122"/>
+                <a:cs typeface="Calibri" pitchFamily="34" charset="-120"/>
+              </a:rPr>
+              <a:t>87.9 dB</a:t>
+            </a:r>
+            <a:endParaRPr lang="en-US" sz="1400" dirty="0"/>
+          </a:p>
+        </p:txBody>
+      </p:sp>
+      <p:sp>
+        <p:nvSpPr>
+          <p:cNvPr id="38" name="Shape 35"/>
+          <p:cNvSpPr/>
+          <p:nvPr/>
+        </p:nvSpPr>
+        <p:spPr>
+          <a:xfrm>
+            <a:off x="6583680" y="4645152"/>
+            <a:ext cx="182880" cy="182880"/>
+          </a:xfrm>
+          <a:prstGeom prst="ellipse">
+            <a:avLst/>
+          </a:prstGeom>
+          <a:solidFill>
+            <a:srgbClr val="2F9E44"/>
+          </a:solidFill>
+          <a:ln w="12700">
+            <a:solidFill>
+              <a:srgbClr val="2F9E44"/>
+            </a:solidFill>
+            <a:prstDash val="solid"/>
+          </a:ln>
+        </p:spPr>
+      </p:sp>
+      <p:sp>
+        <p:nvSpPr>
+          <p:cNvPr id="39" name="Text 36"/>
+          <p:cNvSpPr txBox="1"/>
+          <p:nvPr/>
+        </p:nvSpPr>
+        <p:spPr>
+          <a:xfrm>
+            <a:off x="6858000" y="4581144"/>
+            <a:ext cx="2834640" cy="310896"/>
+          </a:xfrm>
+          <a:prstGeom prst="rect">
+            <a:avLst/>
+          </a:prstGeom>
+          <a:noFill/>
+          <a:ln/>
+        </p:spPr>
+        <p:txBody>
+          <a:bodyPr wrap="square" lIns="0" tIns="0" rIns="0" bIns="0" rtlCol="0" anchor="ctr"/>
+          <a:lstStyle/>
+          <a:p>
+            <a:pPr indent="0" marL="0">
+              <a:buNone/>
+            </a:pPr>
+            <a:r>
+              <a:rPr lang="en-US" sz="1400" b="1" dirty="0">
+                <a:solidFill>
+                  <a:srgbClr val="1F2A44"/>
+                </a:solidFill>
+                <a:latin typeface="Calibri" pitchFamily="34" charset="0"/>
+                <a:ea typeface="Calibri" pitchFamily="34" charset="-122"/>
+                <a:cs typeface="Calibri" pitchFamily="34" charset="-120"/>
+              </a:rPr>
+              <a:t>Cork</a:t>
+            </a:r>
+            <a:endParaRPr lang="en-US" sz="1400" dirty="0"/>
+          </a:p>
+        </p:txBody>
+      </p:sp>
+      <p:sp>
+        <p:nvSpPr>
+          <p:cNvPr id="40" name="Text 37"/>
+          <p:cNvSpPr txBox="1"/>
+          <p:nvPr/>
+        </p:nvSpPr>
+        <p:spPr>
+          <a:xfrm>
+            <a:off x="9692640" y="4581144"/>
+            <a:ext cx="640080" cy="310896"/>
+          </a:xfrm>
+          <a:prstGeom prst="rect">
+            <a:avLst/>
+          </a:prstGeom>
+          <a:noFill/>
+          <a:ln/>
+        </p:spPr>
+        <p:txBody>
+          <a:bodyPr wrap="square" lIns="0" tIns="0" rIns="0" bIns="0" rtlCol="0" anchor="ctr"/>
+          <a:lstStyle/>
+          <a:p>
+            <a:pPr indent="0" marL="0">
+              <a:buNone/>
+            </a:pPr>
+            <a:r>
+              <a:rPr lang="en-US" sz="1200" dirty="0">
+                <a:solidFill>
+                  <a:srgbClr val="5B6578"/>
+                </a:solidFill>
+                <a:latin typeface="Calibri" pitchFamily="34" charset="0"/>
+                <a:ea typeface="Calibri" pitchFamily="34" charset="-122"/>
+                <a:cs typeface="Calibri" pitchFamily="34" charset="-120"/>
+              </a:rPr>
+              <a:t>9 Oct</a:t>
+            </a:r>
+            <a:endParaRPr lang="en-US" sz="1200" dirty="0"/>
+          </a:p>
+        </p:txBody>
+      </p:sp>
+      <p:sp>
+        <p:nvSpPr>
+          <p:cNvPr id="41" name="Text 38"/>
+          <p:cNvSpPr txBox="1"/>
+          <p:nvPr/>
+        </p:nvSpPr>
+        <p:spPr>
+          <a:xfrm>
+            <a:off x="10241280" y="4581144"/>
+            <a:ext cx="1463040" cy="310896"/>
+          </a:xfrm>
+          <a:prstGeom prst="rect">
+            <a:avLst/>
+          </a:prstGeom>
+          <a:noFill/>
+          <a:ln/>
+        </p:spPr>
+        <p:txBody>
+          <a:bodyPr wrap="square" lIns="0" tIns="0" rIns="0" bIns="0" rtlCol="0" anchor="ctr"/>
+          <a:lstStyle/>
+          <a:p>
+            <a:pPr algn="r" indent="0" marL="0">
+              <a:buNone/>
+            </a:pPr>
+            <a:r>
+              <a:rPr lang="en-US" sz="1400" dirty="0">
+                <a:solidFill>
+                  <a:srgbClr val="1F2A44"/>
+                </a:solidFill>
+                <a:latin typeface="Calibri" pitchFamily="34" charset="0"/>
+                <a:ea typeface="Calibri" pitchFamily="34" charset="-122"/>
+                <a:cs typeface="Calibri" pitchFamily="34" charset="-120"/>
+              </a:rPr>
+              <a:t>88.5 dB</a:t>
+            </a:r>
+            <a:endParaRPr lang="en-US" sz="1400" dirty="0"/>
+          </a:p>
+        </p:txBody>
+      </p:sp>
+      <p:sp>
+        <p:nvSpPr>
+          <p:cNvPr id="42" name="Shape 39"/>
+          <p:cNvSpPr/>
+          <p:nvPr/>
+        </p:nvSpPr>
+        <p:spPr>
+          <a:xfrm>
+            <a:off x="6583680" y="4983480"/>
+            <a:ext cx="182880" cy="182880"/>
+          </a:xfrm>
+          <a:prstGeom prst="ellipse">
+            <a:avLst/>
+          </a:prstGeom>
+          <a:solidFill>
+            <a:srgbClr val="1F2A44"/>
+          </a:solidFill>
+          <a:ln w="12700">
+            <a:solidFill>
+              <a:srgbClr val="1F2A44"/>
+            </a:solidFill>
+            <a:prstDash val="solid"/>
+          </a:ln>
+        </p:spPr>
+      </p:sp>
+      <p:sp>
+        <p:nvSpPr>
+          <p:cNvPr id="43" name="Text 40"/>
+          <p:cNvSpPr txBox="1"/>
+          <p:nvPr/>
+        </p:nvSpPr>
+        <p:spPr>
+          <a:xfrm>
+            <a:off x="6858000" y="4919472"/>
+            <a:ext cx="2834640" cy="310896"/>
+          </a:xfrm>
+          <a:prstGeom prst="rect">
+            <a:avLst/>
+          </a:prstGeom>
+          <a:noFill/>
+          <a:ln/>
+        </p:spPr>
+        <p:txBody>
+          <a:bodyPr wrap="square" lIns="0" tIns="0" rIns="0" bIns="0" rtlCol="0" anchor="ctr"/>
+          <a:lstStyle/>
+          <a:p>
+            <a:pPr indent="0" marL="0">
+              <a:buNone/>
+            </a:pPr>
+            <a:r>
+              <a:rPr lang="en-US" sz="1400" b="1" dirty="0">
+                <a:solidFill>
+                  <a:srgbClr val="1F2A44"/>
+                </a:solidFill>
+                <a:latin typeface="Calibri" pitchFamily="34" charset="0"/>
+                <a:ea typeface="Calibri" pitchFamily="34" charset="-122"/>
+                <a:cs typeface="Calibri" pitchFamily="34" charset="-120"/>
+              </a:rPr>
+              <a:t>Duct, small</a:t>
+            </a:r>
+            <a:endParaRPr lang="en-US" sz="1400" dirty="0"/>
+          </a:p>
+        </p:txBody>
+      </p:sp>
+      <p:sp>
+        <p:nvSpPr>
+          <p:cNvPr id="44" name="Text 41"/>
+          <p:cNvSpPr txBox="1"/>
+          <p:nvPr/>
+        </p:nvSpPr>
+        <p:spPr>
+          <a:xfrm>
+            <a:off x="9692640" y="4919472"/>
+            <a:ext cx="640080" cy="310896"/>
+          </a:xfrm>
+          <a:prstGeom prst="rect">
+            <a:avLst/>
+          </a:prstGeom>
+          <a:noFill/>
+          <a:ln/>
+        </p:spPr>
+        <p:txBody>
+          <a:bodyPr wrap="square" lIns="0" tIns="0" rIns="0" bIns="0" rtlCol="0" anchor="ctr"/>
+          <a:lstStyle/>
+          <a:p>
+            <a:pPr indent="0" marL="0">
+              <a:buNone/>
+            </a:pPr>
+            <a:r>
+              <a:rPr lang="en-US" sz="1200" dirty="0">
+                <a:solidFill>
+                  <a:srgbClr val="5B6578"/>
+                </a:solidFill>
+                <a:latin typeface="Calibri" pitchFamily="34" charset="0"/>
+                <a:ea typeface="Calibri" pitchFamily="34" charset="-122"/>
+                <a:cs typeface="Calibri" pitchFamily="34" charset="-120"/>
+              </a:rPr>
+              <a:t>8 Oct</a:t>
+            </a:r>
+            <a:endParaRPr lang="en-US" sz="1200" dirty="0"/>
+          </a:p>
+        </p:txBody>
+      </p:sp>
+      <p:sp>
+        <p:nvSpPr>
+          <p:cNvPr id="45" name="Text 42"/>
+          <p:cNvSpPr txBox="1"/>
+          <p:nvPr/>
+        </p:nvSpPr>
+        <p:spPr>
+          <a:xfrm>
+            <a:off x="10241280" y="4919472"/>
+            <a:ext cx="1463040" cy="310896"/>
+          </a:xfrm>
+          <a:prstGeom prst="rect">
+            <a:avLst/>
+          </a:prstGeom>
+          <a:noFill/>
+          <a:ln/>
+        </p:spPr>
+        <p:txBody>
+          <a:bodyPr wrap="square" lIns="0" tIns="0" rIns="0" bIns="0" rtlCol="0" anchor="ctr"/>
+          <a:lstStyle/>
+          <a:p>
+            <a:pPr algn="r" indent="0" marL="0">
+              <a:buNone/>
+            </a:pPr>
+            <a:r>
+              <a:rPr lang="en-US" sz="1400" dirty="0">
+                <a:solidFill>
+                  <a:srgbClr val="1F2A44"/>
+                </a:solidFill>
+                <a:latin typeface="Calibri" pitchFamily="34" charset="0"/>
+                <a:ea typeface="Calibri" pitchFamily="34" charset="-122"/>
+                <a:cs typeface="Calibri" pitchFamily="34" charset="-120"/>
+              </a:rPr>
+              <a:t>89.5 dB</a:t>
+            </a:r>
+            <a:endParaRPr lang="en-US" sz="1400" dirty="0"/>
+          </a:p>
+        </p:txBody>
+      </p:sp>
+      <p:sp>
+        <p:nvSpPr>
+          <p:cNvPr id="46" name="Text 43"/>
+          <p:cNvSpPr txBox="1"/>
+          <p:nvPr/>
+        </p:nvSpPr>
+        <p:spPr>
+          <a:xfrm>
+            <a:off x="6583680" y="5349240"/>
+            <a:ext cx="5120640" cy="640080"/>
+          </a:xfrm>
+          <a:prstGeom prst="rect">
+            <a:avLst/>
+          </a:prstGeom>
+          <a:noFill/>
+          <a:ln/>
+        </p:spPr>
+        <p:txBody>
+          <a:bodyPr wrap="square" lIns="0" tIns="0" rIns="0" bIns="0" rtlCol="0" anchor="ctr"/>
+          <a:lstStyle/>
+          <a:p>
+            <a:pPr indent="0" marL="0">
+              <a:buNone/>
+            </a:pPr>
+            <a:r>
+              <a:rPr lang="en-US" sz="3600" b="1" dirty="0">
+                <a:solidFill>
+                  <a:srgbClr val="D6336C"/>
+                </a:solidFill>
+                <a:latin typeface="Cambria" pitchFamily="34" charset="0"/>
+                <a:ea typeface="Cambria" pitchFamily="34" charset="-122"/>
+                <a:cs typeface="Cambria" pitchFamily="34" charset="-120"/>
+              </a:rPr>
+              <a:t>6.7 dB</a:t>
+            </a:r>
+            <a:endParaRPr lang="en-US" sz="3600" dirty="0"/>
+          </a:p>
+        </p:txBody>
+      </p:sp>
+      <p:sp>
+        <p:nvSpPr>
+          <p:cNvPr id="47" name="Text 44"/>
+          <p:cNvSpPr txBox="1"/>
+          <p:nvPr/>
+        </p:nvSpPr>
+        <p:spPr>
+          <a:xfrm>
+            <a:off x="6583680" y="5943600"/>
+            <a:ext cx="5120640" cy="274320"/>
+          </a:xfrm>
+          <a:prstGeom prst="rect">
+            <a:avLst/>
+          </a:prstGeom>
+          <a:noFill/>
+          <a:ln/>
+        </p:spPr>
+        <p:txBody>
+          <a:bodyPr wrap="square" lIns="0" tIns="0" rIns="0" bIns="0" rtlCol="0" anchor="ctr"/>
+          <a:lstStyle/>
+          <a:p>
+            <a:pPr indent="0" marL="0">
+              <a:buNone/>
+            </a:pPr>
+            <a:r>
+              <a:rPr lang="en-US" sz="1300" dirty="0">
+                <a:solidFill>
+                  <a:srgbClr val="1F2A44"/>
+                </a:solidFill>
+                <a:latin typeface="Calibri" pitchFamily="34" charset="0"/>
+                <a:ea typeface="Calibri" pitchFamily="34" charset="-122"/>
+                <a:cs typeface="Calibri" pitchFamily="34" charset="-120"/>
+              </a:rPr>
+              <a:t>between the quietest and loudest set-up, on average</a:t>
+            </a:r>
+            <a:endParaRPr lang="en-US" sz="1300" dirty="0"/>
+          </a:p>
+        </p:txBody>
+      </p:sp>
+      <p:sp>
+        <p:nvSpPr>
+          <p:cNvPr id="48" name="Text 45"/>
+          <p:cNvSpPr txBox="1"/>
+          <p:nvPr/>
+        </p:nvSpPr>
+        <p:spPr>
+          <a:xfrm>
+            <a:off x="548640" y="6355080"/>
+            <a:ext cx="10332720" cy="274320"/>
+          </a:xfrm>
+          <a:prstGeom prst="rect">
+            <a:avLst/>
+          </a:prstGeom>
+          <a:noFill/>
+          <a:ln/>
+        </p:spPr>
+        <p:txBody>
+          <a:bodyPr wrap="square" lIns="0" tIns="0" rIns="0" bIns="0" rtlCol="0" anchor="ctr"/>
+          <a:lstStyle/>
+          <a:p>
+            <a:pPr indent="0" marL="0">
+              <a:buNone/>
+            </a:pPr>
+            <a:r>
+              <a:rPr lang="en-US" sz="1100" dirty="0">
+                <a:solidFill>
+                  <a:srgbClr val="5B6578"/>
+                </a:solidFill>
+                <a:latin typeface="Calibri" pitchFamily="34" charset="0"/>
+                <a:ea typeface="Calibri" pitchFamily="34" charset="-122"/>
+                <a:cs typeface="Calibri" pitchFamily="34" charset="-120"/>
+              </a:rPr>
+              <a:t>8 and 9 Oct 2026, 5-inch 3-blade propeller, 500 Hz–24 kHz, 2000 µs, mean of 3 repeats, corrected files. Axis 76–94 dB. Not comparable with slide 8.</a:t>
+            </a:r>
+            <a:endParaRPr lang="en-US" sz="1100" dirty="0"/>
+          </a:p>
+        </p:txBody>
+      </p:sp>
+      <p:sp>
+        <p:nvSpPr>
+          <p:cNvPr id="49" name="Text 46"/>
+          <p:cNvSpPr txBox="1"/>
+          <p:nvPr/>
+        </p:nvSpPr>
+        <p:spPr>
+          <a:xfrm>
+            <a:off x="11155680" y="6355080"/>
+            <a:ext cx="457200" cy="274320"/>
+          </a:xfrm>
+          <a:prstGeom prst="rect">
+            <a:avLst/>
+          </a:prstGeom>
+          <a:noFill/>
+          <a:ln/>
+        </p:spPr>
+        <p:txBody>
+          <a:bodyPr wrap="square" lIns="0" tIns="0" rIns="0" bIns="0" rtlCol="0" anchor="ctr"/>
+          <a:lstStyle/>
+          <a:p>
+            <a:pPr algn="r" indent="0" marL="0">
+              <a:buNone/>
+            </a:pPr>
+            <a:r>
+              <a:rPr lang="en-US" sz="1200" dirty="0">
+                <a:solidFill>
+                  <a:srgbClr val="5B6578"/>
+                </a:solidFill>
+                <a:latin typeface="Calibri" pitchFamily="34" charset="0"/>
+                <a:ea typeface="Calibri" pitchFamily="34" charset="-122"/>
+                <a:cs typeface="Calibri" pitchFamily="34" charset="-120"/>
+              </a:rPr>
+              <a:t>9</a:t>
+            </a:r>
+            <a:endParaRPr lang="en-US" sz="1200" dirty="0"/>
+          </a:p>
+        </p:txBody>
+      </p:sp>
+    </p:spTree>
+  </p:cSld>
+  <p:clrMapOvr>
+    <a:masterClrMapping/>
+  </p:clrMapOvr>
+</p:sld>
+</file>
+
 <file path=ppt/theme/theme1.xml><?xml version="1.0" encoding="utf-8"?>
 <a:theme xmlns:a="http://schemas.openxmlformats.org/drawingml/2006/main" name="Office Theme">
   <a:themeElements>

</xml_diff>

<commit_message>
Slides: slide 9 callout shows the maximal best-vs-worst difference (up to 10.2 dB at +18 deg, 6.7 dB average)
Co-Authored-By: Claude Sonnet 5.5 <noreply@anthropic.com>
</commit_message>
<xml_diff>
--- a/docs/analysis/chamber-final-2026-10-01/slides/chamber-slides-final.pptx
+++ b/docs/analysis/chamber-final-2026-10-01/slides/chamber-slides-final.pptx
@@ -1625,7 +1625,7 @@
           <a:p>
             <a:r>
               <a:rPr lang="en-US" dirty="0"/>
-              <a:t>Bases in the data repo (f30__5in3b__membrane-...): 8 Oct 2026: membrane-duct-small, membrane-open-pore-pu-foam. 9 Oct 2026: membrane-duct-open-pore-pu-foam-double-layer, membrane-felt, membrane-felt-double-layer, membrane-cork, membrane-felt-rubber, membrane-thinsulate-8-layers, -4-layers, -2-layers. Each base was captured with 3 repeats of the ramp; the plot uses the PWM 2000 step and the mean over the 3 repeats of the total level 500 Hz to 24 kHz per microphone, in dB SPL, read with the corrected microphone files. The repeat-to-repeat scatter of the mean level is 0.02-0.11 dB. There is no bare reference measured with this set-up (the base names carry a different motor field, f30, from the 2 and 7 Oct materials), so levels here are not comparable with slide 8 and no louder-than-bare figure is given; the callout is the spread between the quietest (Thinsulate 4 layers) and loudest (small membrane duct) set-up. Two of the bases are ducts. The polar is mirrored to 360 degrees.</a:t>
+              <a:t>Bases in the data repo (f30__5in3b__membrane-...): 8 Oct 2026: membrane-duct-small, membrane-open-pore-pu-foam. 9 Oct 2026: membrane-duct-open-pore-pu-foam-double-layer, membrane-felt, membrane-felt-double-layer, membrane-cork, membrane-felt-rubber, membrane-thinsulate-8-layers, -4-layers, -2-layers. Each base was captured with 3 repeats of the ramp; the plot uses the PWM 2000 step and the mean over the 3 repeats of the total level 500 Hz to 24 kHz per microphone, in dB SPL, read with the corrected microphone files. The repeat-to-repeat scatter of the mean level is 0.02-0.11 dB. There is no bare reference measured with this set-up (the base names carry a different motor field, f30, from the 2 and 7 Oct materials), so levels here are not comparable with slide 8 and no louder-than-bare figure is given; the callout is the difference between the quietest (best: Thinsulate, 4 layers) and the loudest (worst: duct, membrane only) set-up: 10.2 dB at its largest, at +18°, and 6.7 dB on average over the eleven microphones. Per angle the difference runs from 4.1 dB at -90 degrees to 10.2 dB at +18 degrees; the largest spread across all ten set-ups at a single angle is the same 10.2 dB. Two of the bases are ducts. The polar is mirrored to 360 degrees.</a:t>
             </a:r>
             <a:endParaRPr lang="en-US" dirty="0"/>
           </a:p>
@@ -15175,8 +15175,8 @@
         </p:nvSpPr>
         <p:spPr>
           <a:xfrm>
-            <a:off x="6583680" y="5349240"/>
-            <a:ext cx="5120640" cy="640080"/>
+            <a:off x="6583680" y="5193792"/>
+            <a:ext cx="5120640" cy="548640"/>
           </a:xfrm>
           <a:prstGeom prst="rect">
             <a:avLst/>
@@ -15192,7 +15192,7 @@
               <a:buNone/>
             </a:pPr>
             <a:r>
-              <a:rPr lang="en-US" sz="3600" b="1" dirty="0">
+              <a:rPr lang="en-US" sz="3400" b="1" dirty="0">
                 <a:solidFill>
                   <a:srgbClr val="D6336C"/>
                 </a:solidFill>
@@ -15200,9 +15200,9 @@
                 <a:ea typeface="Cambria" pitchFamily="34" charset="-122"/>
                 <a:cs typeface="Cambria" pitchFamily="34" charset="-120"/>
               </a:rPr>
-              <a:t>6.7 dB</a:t>
-            </a:r>
-            <a:endParaRPr lang="en-US" sz="3600" dirty="0"/>
+              <a:t>up to 10.2 dB</a:t>
+            </a:r>
+            <a:endParaRPr lang="en-US" sz="3400" dirty="0"/>
           </a:p>
         </p:txBody>
       </p:sp>
@@ -15214,8 +15214,8 @@
         </p:nvSpPr>
         <p:spPr>
           <a:xfrm>
-            <a:off x="6583680" y="5943600"/>
-            <a:ext cx="5120640" cy="274320"/>
+            <a:off x="6583680" y="5760720"/>
+            <a:ext cx="5120640" cy="457200"/>
           </a:xfrm>
           <a:prstGeom prst="rect">
             <a:avLst/>
@@ -15224,7 +15224,7 @@
           <a:ln/>
         </p:spPr>
         <p:txBody>
-          <a:bodyPr wrap="square" lIns="0" tIns="0" rIns="0" bIns="0" rtlCol="0" anchor="ctr"/>
+          <a:bodyPr wrap="square" lIns="0" tIns="0" rIns="0" bIns="0" rtlCol="0" anchor="t"/>
           <a:lstStyle/>
           <a:p>
             <a:pPr indent="0" marL="0">
@@ -15239,7 +15239,7 @@
                 <a:ea typeface="Calibri" pitchFamily="34" charset="-122"/>
                 <a:cs typeface="Calibri" pitchFamily="34" charset="-120"/>
               </a:rPr>
-              <a:t>between the quietest and loudest set-up, on average</a:t>
+              <a:t>best (Thinsulate, 4 layers) against worst (Duct, membrane only), at +18°; 6.7 dB on average</a:t>
             </a:r>
             <a:endParaRPr lang="en-US" sz="1300" dirty="0"/>
           </a:p>

</xml_diff>